<commit_message>
M05: fix missing Project Knowledge upload instructions for cm-template-wa.txt / cm-template-email.txt
Both prompts referenced these files by name ("Skenario 1 dari cm-template-wa.txt", "cm-template-email.txt Email 2 sudah saya lengkapi") as if Claude could already read them, but the module never instructed students to actually upload either file to Project Knowledge -- the same continuity gap M02 had before it was fixed earlier this session, never carried over to M05.

Added the upload instruction in 4 places (HTML + PPTX, matching M02's pattern):
- module-desc-box intro
- Integrasi tip-box (deeper explanation)
- Cara Kerja step for each channel (WA step 1, Email step 2)
- Latihan case-box reminder before the exercise
</commit_message>
<xml_diff>
--- a/Content-Marketing/M05-Komunikasi-Pelanggan/K3-M05-Komunikasi-Pelanggan.pptx
+++ b/Content-Marketing/M05-Komunikasi-Pelanggan/K3-M05-Komunikasi-Pelanggan.pptx
@@ -2483,7 +2483,7 @@
                 <a:ea typeface="Helvetica" pitchFamily="34" charset="-122"/>
                 <a:cs typeface="Helvetica" pitchFamily="34" charset="-120"/>
               </a:rPr>
-              <a:t>Level: Claude Projects (semua plan termasuk Free) · Setup: 5 menit sekali. Tambahkan brand voice CS ke Claude Project dari Modul 1 (sudah punya positioning &amp; identitas visual). WhatsApp: generate lalu copy-paste manual. Email: aktifkan juga Gmail Connector (gratis, 60 detik) — Claude langsung membuat draft di inbox-mu, kamu tinggal review dan klik Send.</a:t>
+              <a:t>Level: Claude Projects (semua plan termasuk Free) · Setup: 5 menit sekali. Tambahkan brand voice CS ke Claude Project dari Modul 1 (sudah punya positioning &amp; identitas visual). Upload juga cm-template-wa.txt dan cm-template-email.txt ke Project Knowledge — supaya prompt yang menyebut "Skenario 1" atau "Email 2" langsung terbaca Claude. WhatsApp: generate lalu copy-paste manual. Email: aktifkan juga Gmail Connector (gratis, 60 detik) — Claude langsung membuat draft di inbox-mu, kamu tinggal review dan klik Send.</a:t>
             </a:r>
             <a:endParaRPr lang="en-US" sz="1200" dirty="0"/>
           </a:p>
@@ -4099,7 +4099,7 @@
                 <a:ea typeface="Helvetica" pitchFamily="34" charset="-122"/>
                 <a:cs typeface="Helvetica" pitchFamily="34" charset="-120"/>
               </a:rPr>
-              <a:t>Tambahkan brand voice CS ke Project Modul 1, pilih skenario dari cm-template-wa.txt</a:t>
+              <a:t>Tambahkan brand voice CS ke Project Modul 1, upload cm-template-wa.txt ke Project Knowledge, pilih skenario</a:t>
             </a:r>
             <a:endParaRPr lang="en-US" sz="1100" dirty="0"/>
           </a:p>
@@ -4542,7 +4542,7 @@
                 <a:ea typeface="Helvetica" pitchFamily="34" charset="-122"/>
                 <a:cs typeface="Helvetica" pitchFamily="34" charset="-120"/>
               </a:rPr>
-              <a:t>Isi cm-template-email.txt bagian relevan: nama produk, harga promo, tanggal, CTA</a:t>
+              <a:t>Isi cm-template-email.txt bagian relevan (nama produk, harga promo, tanggal, CTA), lalu upload ke Project Knowledge</a:t>
             </a:r>
             <a:endParaRPr lang="en-US" sz="1100" dirty="0"/>
           </a:p>
@@ -6056,7 +6056,7 @@
                 <a:ea typeface="Helvetica" pitchFamily="34" charset="-122"/>
                 <a:cs typeface="Helvetica" pitchFamily="34" charset="-120"/>
               </a:rPr>
-              <a:t>Jalankan prompt ini untuk generate template WA (pakai skenario di cm-template-wa.txt, gunakan minimal 5 kali dalam 1 minggu) dan 2 draft email (dari cm-template-email.txt). Kirim ke minimal 10 kontak, catat open rate dan respons.</a:t>
+              <a:t>Pastikan cm-template-wa.txt dan cm-template-email.txt sudah diupload ke Project Knowledge dari Project Modul 1. Jalankan prompt ini untuk generate template WA (gunakan minimal 5 kali dalam 1 minggu) dan 2 draft email. Kirim ke minimal 10 kontak, catat open rate dan respons.</a:t>
             </a:r>
             <a:endParaRPr lang="en-US" sz="1200" dirty="0"/>
           </a:p>

</xml_diff>

<commit_message>
M05: remove redundant brand-info fields from txt files, add Project context-note to Email prompt, fix Modul 6 typo
</commit_message>
<xml_diff>
--- a/Content-Marketing/M05-Komunikasi-Pelanggan/K3-M05-Komunikasi-Pelanggan.pptx
+++ b/Content-Marketing/M05-Komunikasi-Pelanggan/K3-M05-Komunikasi-Pelanggan.pptx
@@ -4,6 +4,9 @@
   <p:sldMasterIdLst>
     <p:sldMasterId id="2147483648" r:id="rId1"/>
   </p:sldMasterIdLst>
+  <p:notesMasterIdLst>
+    <p:notesMasterId r:id="rId9"/>
+  </p:notesMasterIdLst>
   <p:sldIdLst>
     <p:sldId id="256" r:id="rId2"/>
     <p:sldId id="257" r:id="rId3"/>
@@ -13,11 +16,8 @@
     <p:sldId id="261" r:id="rId7"/>
     <p:sldId id="262" r:id="rId8"/>
   </p:sldIdLst>
-  <p:notesMasterIdLst>
-    <p:notesMasterId r:id="rId9"/>
-  </p:notesMasterIdLst>
-  <p:sldSz cx="12191695" cy="6858000"/>
-  <p:notesSz cx="6858000" cy="12191695"/>
+  <p:sldSz cx="12192000" cy="6858000"/>
+  <p:notesSz cx="6858000" cy="12192000"/>
   <p:defaultTextStyle>
     <a:lvl1pPr marL="0" algn="l" defTabSz="914400" rtl="0" eaLnBrk="1" latinLnBrk="0" hangingPunct="1">
       <a:defRPr sz="1800" kern="1200">
@@ -110,6 +110,11 @@
       </a:defRPr>
     </a:lvl9pPr>
   </p:defaultTextStyle>
+  <p:extLst>
+    <p:ext uri="{EFAFB233-063F-42B5-8137-9DF3F51BA10A}">
+      <p15:sldGuideLst xmlns:p15="http://schemas.microsoft.com/office/powerpoint/2012/main"/>
+    </p:ext>
+  </p:extLst>
 </p:presentation>
 </file>
 
@@ -135,234 +140,10 @@
           <a:chExt cx="0" cy="0"/>
         </a:xfrm>
       </p:grpSpPr>
-      <p:sp>
-        <p:nvSpPr>
-          <p:cNvPr id="2" name="Header Placeholder 1"/>
-          <p:cNvSpPr>
-            <a:spLocks noGrp="1"/>
-          </p:cNvSpPr>
-          <p:nvPr>
-            <p:ph type="hdr" sz="quarter"/>
-          </p:nvPr>
-        </p:nvSpPr>
-        <p:spPr>
-          <a:xfrm>
-            <a:off x="0" y="0"/>
-            <a:ext cx="2971800" cy="458788"/>
-          </a:xfrm>
-          <a:prstGeom prst="rect">
-            <a:avLst/>
-          </a:prstGeom>
-        </p:spPr>
-        <p:txBody>
-          <a:bodyPr vert="horz" lIns="91440" tIns="45720" rIns="91440" bIns="45720" rtlCol="0"/>
-          <a:lstStyle>
-            <a:lvl1pPr algn="l">
-              <a:defRPr sz="1200"/>
-            </a:lvl1pPr>
-          </a:lstStyle>
-          <a:p>
-            <a:endParaRPr lang="en-US"/>
-          </a:p>
-        </p:txBody>
-      </p:sp>
-      <p:sp>
-        <p:nvSpPr>
-          <p:cNvPr id="3" name="Date Placeholder 2"/>
-          <p:cNvSpPr>
-            <a:spLocks noGrp="1"/>
-          </p:cNvSpPr>
-          <p:nvPr>
-            <p:ph type="dt" idx="1"/>
-          </p:nvPr>
-        </p:nvSpPr>
-        <p:spPr>
-          <a:xfrm>
-            <a:off x="3884613" y="0"/>
-            <a:ext cx="2971800" cy="458788"/>
-          </a:xfrm>
-          <a:prstGeom prst="rect">
-            <a:avLst/>
-          </a:prstGeom>
-        </p:spPr>
-        <p:txBody>
-          <a:bodyPr vert="horz" lIns="91440" tIns="45720" rIns="91440" bIns="45720" rtlCol="0"/>
-          <a:lstStyle>
-            <a:lvl1pPr algn="r">
-              <a:defRPr sz="1200"/>
-            </a:lvl1pPr>
-          </a:lstStyle>
-          <a:p>
-            <a:fld id="{5282F153-3F37-0F45-9E97-73ACFA13230C}" type="datetimeFigureOut">
-              <a:rPr lang="en-US"/>
-              <a:t>7/23/19</a:t>
-            </a:fld>
-            <a:endParaRPr lang="en-US"/>
-          </a:p>
-        </p:txBody>
-      </p:sp>
-      <p:sp>
-        <p:nvSpPr>
-          <p:cNvPr id="4" name="Slide Image Placeholder 3"/>
-          <p:cNvSpPr>
-            <a:spLocks noGrp="1" noRot="1" noChangeAspect="1"/>
-          </p:cNvSpPr>
-          <p:nvPr>
-            <p:ph type="sldImg" idx="2"/>
-          </p:nvPr>
-        </p:nvSpPr>
-        <p:spPr>
-          <a:xfrm>
-            <a:off x="685800" y="1143000"/>
-            <a:ext cx="5486400" cy="3086100"/>
-          </a:xfrm>
-          <a:prstGeom prst="rect">
-            <a:avLst/>
-          </a:prstGeom>
-          <a:noFill/>
-          <a:ln w="12700">
-            <a:solidFill>
-              <a:prstClr val="black"/>
-            </a:solidFill>
-          </a:ln>
-        </p:spPr>
-        <p:txBody>
-          <a:bodyPr vert="horz" lIns="91440" tIns="45720" rIns="91440" bIns="45720" rtlCol="0" anchor="ctr"/>
-          <a:lstStyle/>
-          <a:p>
-            <a:endParaRPr lang="en-US"/>
-          </a:p>
-        </p:txBody>
-      </p:sp>
-      <p:sp>
-        <p:nvSpPr>
-          <p:cNvPr id="5" name="Notes Placeholder 4"/>
-          <p:cNvSpPr>
-            <a:spLocks noGrp="1"/>
-          </p:cNvSpPr>
-          <p:nvPr>
-            <p:ph type="body" sz="quarter" idx="3"/>
-          </p:nvPr>
-        </p:nvSpPr>
-        <p:spPr>
-          <a:xfrm>
-            <a:off x="685800" y="4400550"/>
-            <a:ext cx="5486400" cy="3600450"/>
-          </a:xfrm>
-          <a:prstGeom prst="rect">
-            <a:avLst/>
-          </a:prstGeom>
-        </p:spPr>
-        <p:txBody>
-          <a:bodyPr vert="horz" lIns="91440" tIns="45720" rIns="91440" bIns="45720" rtlCol="0"/>
-          <a:lstStyle/>
-          <a:p>
-            <a:pPr lvl="0"/>
-            <a:r>
-              <a:rPr lang="en-US"/>
-              <a:t>Click to edit Master text styles</a:t>
-            </a:r>
-          </a:p>
-          <a:p>
-            <a:pPr lvl="1"/>
-            <a:r>
-              <a:rPr lang="en-US"/>
-              <a:t>Second level</a:t>
-            </a:r>
-          </a:p>
-          <a:p>
-            <a:pPr lvl="2"/>
-            <a:r>
-              <a:rPr lang="en-US"/>
-              <a:t>Third level</a:t>
-            </a:r>
-          </a:p>
-          <a:p>
-            <a:pPr lvl="3"/>
-            <a:r>
-              <a:rPr lang="en-US"/>
-              <a:t>Fourth level</a:t>
-            </a:r>
-          </a:p>
-          <a:p>
-            <a:pPr lvl="4"/>
-            <a:r>
-              <a:rPr lang="en-US"/>
-              <a:t>Fifth level</a:t>
-            </a:r>
-          </a:p>
-        </p:txBody>
-      </p:sp>
-      <p:sp>
-        <p:nvSpPr>
-          <p:cNvPr id="6" name="Footer Placeholder 5"/>
-          <p:cNvSpPr>
-            <a:spLocks noGrp="1"/>
-          </p:cNvSpPr>
-          <p:nvPr>
-            <p:ph type="ftr" sz="quarter" idx="4"/>
-          </p:nvPr>
-        </p:nvSpPr>
-        <p:spPr>
-          <a:xfrm>
-            <a:off x="0" y="8685213"/>
-            <a:ext cx="2971800" cy="458787"/>
-          </a:xfrm>
-          <a:prstGeom prst="rect">
-            <a:avLst/>
-          </a:prstGeom>
-        </p:spPr>
-        <p:txBody>
-          <a:bodyPr vert="horz" lIns="91440" tIns="45720" rIns="91440" bIns="45720" rtlCol="0" anchor="b"/>
-          <a:lstStyle>
-            <a:lvl1pPr algn="l">
-              <a:defRPr sz="1200"/>
-            </a:lvl1pPr>
-          </a:lstStyle>
-          <a:p>
-            <a:endParaRPr lang="en-US"/>
-          </a:p>
-        </p:txBody>
-      </p:sp>
-      <p:sp>
-        <p:nvSpPr>
-          <p:cNvPr id="7" name="Slide Number Placeholder 6"/>
-          <p:cNvSpPr>
-            <a:spLocks noGrp="1"/>
-          </p:cNvSpPr>
-          <p:nvPr>
-            <p:ph type="sldNum" sz="quarter" idx="5"/>
-          </p:nvPr>
-        </p:nvSpPr>
-        <p:spPr>
-          <a:xfrm>
-            <a:off x="3884613" y="8685213"/>
-            <a:ext cx="2971800" cy="458787"/>
-          </a:xfrm>
-          <a:prstGeom prst="rect">
-            <a:avLst/>
-          </a:prstGeom>
-        </p:spPr>
-        <p:txBody>
-          <a:bodyPr vert="horz" lIns="91440" tIns="45720" rIns="91440" bIns="45720" rtlCol="0" anchor="b"/>
-          <a:lstStyle>
-            <a:lvl1pPr algn="r">
-              <a:defRPr sz="1200"/>
-            </a:lvl1pPr>
-          </a:lstStyle>
-          <a:p>
-            <a:fld id="{CE5E9CC1-C706-0F49-92D6-E571CC5EEA8F}" type="slidenum">
-              <a:rPr lang="en-US"/>
-              <a:t>‹#›</a:t>
-            </a:fld>
-            <a:endParaRPr lang="en-US"/>
-          </a:p>
-        </p:txBody>
-      </p:sp>
     </p:spTree>
     <p:extLst>
       <p:ext uri="{BB962C8B-B14F-4D97-AF65-F5344CB8AC3E}">
-        <p14:creationId xmlns:p14="http://schemas.microsoft.com/office/powerpoint/2010/main" val="1024086991"/>
+        <p14:creationId xmlns:p14="http://schemas.microsoft.com/office/powerpoint/2010/main" val="4267468471"/>
       </p:ext>
     </p:extLst>
   </p:cSld>
@@ -506,10 +287,6 @@
           <a:bodyPr/>
           <a:lstStyle/>
           <a:p>
-            <a:r>
-              <a:rPr lang="en-US" dirty="0"/>
-              <a:t/>
-            </a:r>
             <a:endParaRPr lang="en-US" dirty="0"/>
           </a:p>
         </p:txBody>
@@ -594,10 +371,6 @@
           <a:bodyPr/>
           <a:lstStyle/>
           <a:p>
-            <a:r>
-              <a:rPr lang="en-US" dirty="0"/>
-              <a:t/>
-            </a:r>
             <a:endParaRPr lang="en-US" dirty="0"/>
           </a:p>
         </p:txBody>
@@ -682,10 +455,6 @@
           <a:bodyPr/>
           <a:lstStyle/>
           <a:p>
-            <a:r>
-              <a:rPr lang="en-US" dirty="0"/>
-              <a:t/>
-            </a:r>
             <a:endParaRPr lang="en-US" dirty="0"/>
           </a:p>
         </p:txBody>
@@ -770,10 +539,6 @@
           <a:bodyPr/>
           <a:lstStyle/>
           <a:p>
-            <a:r>
-              <a:rPr lang="en-US" dirty="0"/>
-              <a:t/>
-            </a:r>
             <a:endParaRPr lang="en-US" dirty="0"/>
           </a:p>
         </p:txBody>
@@ -858,10 +623,6 @@
           <a:bodyPr/>
           <a:lstStyle/>
           <a:p>
-            <a:r>
-              <a:rPr lang="en-US" dirty="0"/>
-              <a:t/>
-            </a:r>
             <a:endParaRPr lang="en-US" dirty="0"/>
           </a:p>
         </p:txBody>
@@ -946,10 +707,6 @@
           <a:bodyPr/>
           <a:lstStyle/>
           <a:p>
-            <a:r>
-              <a:rPr lang="en-US" dirty="0"/>
-              <a:t/>
-            </a:r>
             <a:endParaRPr lang="en-US" dirty="0"/>
           </a:p>
         </p:txBody>
@@ -1034,10 +791,6 @@
           <a:bodyPr/>
           <a:lstStyle/>
           <a:p>
-            <a:r>
-              <a:rPr lang="en-US" dirty="0"/>
-              <a:t/>
-            </a:r>
             <a:endParaRPr lang="en-US" dirty="0"/>
           </a:p>
         </p:txBody>
@@ -1111,6 +864,11 @@
 <file path=ppt/slideMasters/slideMaster1.xml><?xml version="1.0" encoding="utf-8"?>
 <p:sldMaster xmlns:a="http://schemas.openxmlformats.org/drawingml/2006/main" xmlns:r="http://schemas.openxmlformats.org/officeDocument/2006/relationships" xmlns:p="http://schemas.openxmlformats.org/presentationml/2006/main">
   <p:cSld>
+    <p:bg>
+      <p:bgRef idx="1001">
+        <a:schemeClr val="bg1"/>
+      </p:bgRef>
+    </p:bg>
     <p:spTree>
       <p:nvGrpSpPr>
         <p:cNvPr id="1" name=""/>
@@ -1393,6 +1151,7 @@
         <a:solidFill>
           <a:srgbClr val="0D1321"/>
         </a:solidFill>
+        <a:effectLst/>
       </p:bgPr>
     </p:bg>
     <p:spTree>
@@ -1428,6 +1187,13 @@
           </a:solidFill>
           <a:ln/>
         </p:spPr>
+        <p:txBody>
+          <a:bodyPr/>
+          <a:lstStyle/>
+          <a:p>
+            <a:endParaRPr lang="en-ID"/>
+          </a:p>
+        </p:txBody>
       </p:sp>
       <p:sp>
         <p:nvSpPr>
@@ -1450,7 +1216,7 @@
           <a:bodyPr wrap="square" lIns="0" tIns="0" rIns="0" bIns="0" rtlCol="0" anchor="ctr"/>
           <a:lstStyle/>
           <a:p>
-            <a:pPr indent="0" marL="0">
+            <a:pPr marL="0" indent="0">
               <a:buNone/>
             </a:pPr>
             <a:r>
@@ -1464,9 +1230,6 @@
               </a:rPr>
               <a:t>belajar</a:t>
             </a:r>
-            <a:pPr indent="0" marL="0">
-              <a:buNone/>
-            </a:pPr>
             <a:r>
               <a:rPr lang="en-US" sz="2000" b="1" dirty="0">
                 <a:solidFill>
@@ -1503,6 +1266,13 @@
           </a:solidFill>
           <a:ln/>
         </p:spPr>
+        <p:txBody>
+          <a:bodyPr/>
+          <a:lstStyle/>
+          <a:p>
+            <a:endParaRPr lang="en-ID"/>
+          </a:p>
+        </p:txBody>
       </p:sp>
       <p:sp>
         <p:nvSpPr>
@@ -1525,7 +1295,7 @@
           <a:bodyPr wrap="square" lIns="0" tIns="0" rIns="0" bIns="0" rtlCol="0" anchor="ctr"/>
           <a:lstStyle/>
           <a:p>
-            <a:pPr algn="ctr" indent="0" marL="0">
+            <a:pPr marL="0" indent="0" algn="ctr">
               <a:buNone/>
             </a:pPr>
             <a:r>
@@ -1564,11 +1334,11 @@
           <a:bodyPr wrap="square" lIns="0" tIns="0" rIns="0" bIns="0" rtlCol="0" anchor="ctr"/>
           <a:lstStyle/>
           <a:p>
-            <a:pPr indent="0" marL="0">
-              <a:buNone/>
-            </a:pPr>
-            <a:r>
-              <a:rPr lang="en-US" sz="1300" b="1" spc="40" kern="0" dirty="0">
+            <a:pPr marL="0" indent="0">
+              <a:buNone/>
+            </a:pPr>
+            <a:r>
+              <a:rPr lang="en-US" sz="1300" b="1" kern="0" spc="40" dirty="0">
                 <a:solidFill>
                   <a:srgbClr val="8B7CF6"/>
                 </a:solidFill>
@@ -1603,7 +1373,7 @@
           <a:bodyPr wrap="square" lIns="0" tIns="0" rIns="0" bIns="0" rtlCol="0" anchor="ctr"/>
           <a:lstStyle/>
           <a:p>
-            <a:pPr indent="0" marL="0">
+            <a:pPr marL="0" indent="0">
               <a:lnSpc>
                 <a:spcPts val="4800"/>
               </a:lnSpc>
@@ -1645,7 +1415,7 @@
           <a:bodyPr wrap="square" lIns="0" tIns="0" rIns="0" bIns="0" rtlCol="0" anchor="ctr"/>
           <a:lstStyle/>
           <a:p>
-            <a:pPr indent="0" marL="0">
+            <a:pPr marL="0" indent="0">
               <a:buNone/>
             </a:pPr>
             <a:r>
@@ -1684,7 +1454,7 @@
           <a:bodyPr wrap="square" lIns="0" tIns="0" rIns="0" bIns="0" rtlCol="0" anchor="ctr"/>
           <a:lstStyle/>
           <a:p>
-            <a:pPr indent="0" marL="0">
+            <a:pPr marL="0" indent="0">
               <a:buNone/>
             </a:pPr>
             <a:r>
@@ -1746,6 +1516,13 @@
           </a:solidFill>
           <a:ln/>
         </p:spPr>
+        <p:txBody>
+          <a:bodyPr/>
+          <a:lstStyle/>
+          <a:p>
+            <a:endParaRPr lang="en-ID"/>
+          </a:p>
+        </p:txBody>
       </p:sp>
       <p:sp>
         <p:nvSpPr>
@@ -1766,6 +1543,13 @@
           </a:solidFill>
           <a:ln/>
         </p:spPr>
+        <p:txBody>
+          <a:bodyPr/>
+          <a:lstStyle/>
+          <a:p>
+            <a:endParaRPr lang="en-ID"/>
+          </a:p>
+        </p:txBody>
       </p:sp>
       <p:sp>
         <p:nvSpPr>
@@ -1788,7 +1572,7 @@
           <a:bodyPr wrap="square" lIns="0" tIns="0" rIns="0" bIns="0" rtlCol="0" anchor="ctr"/>
           <a:lstStyle/>
           <a:p>
-            <a:pPr indent="0" marL="0">
+            <a:pPr marL="0" indent="0">
               <a:buNone/>
             </a:pPr>
             <a:r>
@@ -1802,9 +1586,6 @@
               </a:rPr>
               <a:t>belajar</a:t>
             </a:r>
-            <a:pPr indent="0" marL="0">
-              <a:buNone/>
-            </a:pPr>
             <a:r>
               <a:rPr lang="en-US" sz="2000" b="1" dirty="0">
                 <a:solidFill>
@@ -1841,7 +1622,7 @@
           <a:bodyPr wrap="square" lIns="0" tIns="0" rIns="0" bIns="0" rtlCol="0" anchor="ctr"/>
           <a:lstStyle/>
           <a:p>
-            <a:pPr algn="r" indent="0" marL="0">
+            <a:pPr marL="0" indent="0" algn="r">
               <a:buNone/>
             </a:pPr>
             <a:r>
@@ -1880,11 +1661,11 @@
           <a:bodyPr wrap="square" lIns="0" tIns="0" rIns="0" bIns="0" rtlCol="0" anchor="ctr"/>
           <a:lstStyle/>
           <a:p>
-            <a:pPr indent="0" marL="0">
-              <a:buNone/>
-            </a:pPr>
-            <a:r>
-              <a:rPr lang="en-US" sz="1250" b="1" spc="40" kern="0" dirty="0">
+            <a:pPr marL="0" indent="0">
+              <a:buNone/>
+            </a:pPr>
+            <a:r>
+              <a:rPr lang="en-US" sz="1250" b="1" kern="0" spc="40" dirty="0">
                 <a:solidFill>
                   <a:srgbClr val="4B36C7"/>
                 </a:solidFill>
@@ -1919,7 +1700,7 @@
           <a:bodyPr wrap="square" lIns="0" tIns="0" rIns="0" bIns="0" rtlCol="0" anchor="ctr"/>
           <a:lstStyle/>
           <a:p>
-            <a:pPr indent="0" marL="0">
+            <a:pPr marL="0" indent="0">
               <a:buNone/>
             </a:pPr>
             <a:r>
@@ -1963,6 +1744,13 @@
             <a:prstDash val="solid"/>
           </a:ln>
         </p:spPr>
+        <p:txBody>
+          <a:bodyPr/>
+          <a:lstStyle/>
+          <a:p>
+            <a:endParaRPr lang="en-ID"/>
+          </a:p>
+        </p:txBody>
       </p:sp>
       <p:sp>
         <p:nvSpPr>
@@ -1985,7 +1773,7 @@
           <a:bodyPr wrap="square" lIns="0" tIns="0" rIns="0" bIns="0" rtlCol="0" anchor="ctr"/>
           <a:lstStyle/>
           <a:p>
-            <a:pPr indent="0" marL="0">
+            <a:pPr marL="0" indent="0">
               <a:lnSpc>
                 <a:spcPct val="115000"/>
               </a:lnSpc>
@@ -2027,7 +1815,7 @@
           <a:bodyPr wrap="square" lIns="0" tIns="0" rIns="0" bIns="0" rtlCol="0" anchor="ctr"/>
           <a:lstStyle/>
           <a:p>
-            <a:pPr indent="0" marL="0">
+            <a:pPr marL="0" indent="0">
               <a:lnSpc>
                 <a:spcPct val="120000"/>
               </a:lnSpc>
@@ -2074,6 +1862,13 @@
             <a:prstDash val="solid"/>
           </a:ln>
         </p:spPr>
+        <p:txBody>
+          <a:bodyPr/>
+          <a:lstStyle/>
+          <a:p>
+            <a:endParaRPr lang="en-ID"/>
+          </a:p>
+        </p:txBody>
       </p:sp>
       <p:sp>
         <p:nvSpPr>
@@ -2096,7 +1891,7 @@
           <a:bodyPr wrap="square" lIns="0" tIns="0" rIns="0" bIns="0" rtlCol="0" anchor="ctr"/>
           <a:lstStyle/>
           <a:p>
-            <a:pPr indent="0" marL="0">
+            <a:pPr marL="0" indent="0">
               <a:lnSpc>
                 <a:spcPct val="115000"/>
               </a:lnSpc>
@@ -2138,7 +1933,7 @@
           <a:bodyPr wrap="square" lIns="0" tIns="0" rIns="0" bIns="0" rtlCol="0" anchor="ctr"/>
           <a:lstStyle/>
           <a:p>
-            <a:pPr indent="0" marL="0">
+            <a:pPr marL="0" indent="0">
               <a:lnSpc>
                 <a:spcPct val="120000"/>
               </a:lnSpc>
@@ -2185,6 +1980,13 @@
             <a:prstDash val="solid"/>
           </a:ln>
         </p:spPr>
+        <p:txBody>
+          <a:bodyPr/>
+          <a:lstStyle/>
+          <a:p>
+            <a:endParaRPr lang="en-ID"/>
+          </a:p>
+        </p:txBody>
       </p:sp>
       <p:sp>
         <p:nvSpPr>
@@ -2207,7 +2009,7 @@
           <a:bodyPr wrap="square" lIns="0" tIns="0" rIns="0" bIns="0" rtlCol="0" anchor="ctr"/>
           <a:lstStyle/>
           <a:p>
-            <a:pPr indent="0" marL="0">
+            <a:pPr marL="0" indent="0">
               <a:lnSpc>
                 <a:spcPct val="115000"/>
               </a:lnSpc>
@@ -2249,7 +2051,7 @@
           <a:bodyPr wrap="square" lIns="0" tIns="0" rIns="0" bIns="0" rtlCol="0" anchor="ctr"/>
           <a:lstStyle/>
           <a:p>
-            <a:pPr indent="0" marL="0">
+            <a:pPr marL="0" indent="0">
               <a:lnSpc>
                 <a:spcPct val="120000"/>
               </a:lnSpc>
@@ -2296,6 +2098,13 @@
             <a:prstDash val="solid"/>
           </a:ln>
         </p:spPr>
+        <p:txBody>
+          <a:bodyPr/>
+          <a:lstStyle/>
+          <a:p>
+            <a:endParaRPr lang="en-ID"/>
+          </a:p>
+        </p:txBody>
       </p:sp>
       <p:sp>
         <p:nvSpPr>
@@ -2318,7 +2127,7 @@
           <a:bodyPr wrap="square" lIns="0" tIns="0" rIns="0" bIns="0" rtlCol="0" anchor="ctr"/>
           <a:lstStyle/>
           <a:p>
-            <a:pPr indent="0" marL="0">
+            <a:pPr marL="0" indent="0">
               <a:lnSpc>
                 <a:spcPct val="115000"/>
               </a:lnSpc>
@@ -2360,7 +2169,7 @@
           <a:bodyPr wrap="square" lIns="0" tIns="0" rIns="0" bIns="0" rtlCol="0" anchor="ctr"/>
           <a:lstStyle/>
           <a:p>
-            <a:pPr indent="0" marL="0">
+            <a:pPr marL="0" indent="0">
               <a:lnSpc>
                 <a:spcPct val="120000"/>
               </a:lnSpc>
@@ -2407,6 +2216,13 @@
             <a:prstDash val="solid"/>
           </a:ln>
         </p:spPr>
+        <p:txBody>
+          <a:bodyPr/>
+          <a:lstStyle/>
+          <a:p>
+            <a:endParaRPr lang="en-ID"/>
+          </a:p>
+        </p:txBody>
       </p:sp>
       <p:sp>
         <p:nvSpPr>
@@ -2429,7 +2245,7 @@
           <a:bodyPr wrap="square" lIns="0" tIns="0" rIns="0" bIns="0" rtlCol="0" anchor="ctr"/>
           <a:lstStyle/>
           <a:p>
-            <a:pPr indent="0" marL="0">
+            <a:pPr marL="0" indent="0">
               <a:buNone/>
             </a:pPr>
             <a:r>
@@ -2468,7 +2284,7 @@
           <a:bodyPr wrap="square" lIns="0" tIns="0" rIns="0" bIns="0" rtlCol="0" anchor="ctr"/>
           <a:lstStyle/>
           <a:p>
-            <a:pPr indent="0" marL="0">
+            <a:pPr marL="0" indent="0">
               <a:lnSpc>
                 <a:spcPct val="125000"/>
               </a:lnSpc>
@@ -2533,6 +2349,13 @@
           </a:solidFill>
           <a:ln/>
         </p:spPr>
+        <p:txBody>
+          <a:bodyPr/>
+          <a:lstStyle/>
+          <a:p>
+            <a:endParaRPr lang="en-ID"/>
+          </a:p>
+        </p:txBody>
       </p:sp>
       <p:sp>
         <p:nvSpPr>
@@ -2553,6 +2376,13 @@
           </a:solidFill>
           <a:ln/>
         </p:spPr>
+        <p:txBody>
+          <a:bodyPr/>
+          <a:lstStyle/>
+          <a:p>
+            <a:endParaRPr lang="en-ID"/>
+          </a:p>
+        </p:txBody>
       </p:sp>
       <p:sp>
         <p:nvSpPr>
@@ -2575,7 +2405,7 @@
           <a:bodyPr wrap="square" lIns="0" tIns="0" rIns="0" bIns="0" rtlCol="0" anchor="ctr"/>
           <a:lstStyle/>
           <a:p>
-            <a:pPr indent="0" marL="0">
+            <a:pPr marL="0" indent="0">
               <a:buNone/>
             </a:pPr>
             <a:r>
@@ -2589,9 +2419,6 @@
               </a:rPr>
               <a:t>belajar</a:t>
             </a:r>
-            <a:pPr indent="0" marL="0">
-              <a:buNone/>
-            </a:pPr>
             <a:r>
               <a:rPr lang="en-US" sz="2000" b="1" dirty="0">
                 <a:solidFill>
@@ -2628,7 +2455,7 @@
           <a:bodyPr wrap="square" lIns="0" tIns="0" rIns="0" bIns="0" rtlCol="0" anchor="ctr"/>
           <a:lstStyle/>
           <a:p>
-            <a:pPr algn="r" indent="0" marL="0">
+            <a:pPr marL="0" indent="0" algn="r">
               <a:buNone/>
             </a:pPr>
             <a:r>
@@ -2667,11 +2494,11 @@
           <a:bodyPr wrap="square" lIns="0" tIns="0" rIns="0" bIns="0" rtlCol="0" anchor="ctr"/>
           <a:lstStyle/>
           <a:p>
-            <a:pPr indent="0" marL="0">
-              <a:buNone/>
-            </a:pPr>
-            <a:r>
-              <a:rPr lang="en-US" sz="1250" b="1" spc="40" kern="0" dirty="0">
+            <a:pPr marL="0" indent="0">
+              <a:buNone/>
+            </a:pPr>
+            <a:r>
+              <a:rPr lang="en-US" sz="1250" b="1" kern="0" spc="40" dirty="0">
                 <a:solidFill>
                   <a:srgbClr val="4B36C7"/>
                 </a:solidFill>
@@ -2706,7 +2533,7 @@
           <a:bodyPr wrap="square" lIns="0" tIns="0" rIns="0" bIns="0" rtlCol="0" anchor="ctr"/>
           <a:lstStyle/>
           <a:p>
-            <a:pPr indent="0" marL="0">
+            <a:pPr marL="0" indent="0">
               <a:buNone/>
             </a:pPr>
             <a:r>
@@ -2750,6 +2577,13 @@
             <a:prstDash val="solid"/>
           </a:ln>
         </p:spPr>
+        <p:txBody>
+          <a:bodyPr/>
+          <a:lstStyle/>
+          <a:p>
+            <a:endParaRPr lang="en-ID"/>
+          </a:p>
+        </p:txBody>
       </p:sp>
       <p:sp>
         <p:nvSpPr>
@@ -2772,11 +2606,11 @@
           <a:bodyPr wrap="square" lIns="0" tIns="0" rIns="0" bIns="0" rtlCol="0" anchor="ctr"/>
           <a:lstStyle/>
           <a:p>
-            <a:pPr indent="0" marL="0">
-              <a:buNone/>
-            </a:pPr>
-            <a:r>
-              <a:rPr lang="en-US" sz="1250" b="1" spc="40" kern="0" dirty="0">
+            <a:pPr marL="0" indent="0">
+              <a:buNone/>
+            </a:pPr>
+            <a:r>
+              <a:rPr lang="en-US" sz="1250" b="1" kern="0" spc="40" dirty="0">
                 <a:solidFill>
                   <a:srgbClr val="DC2626"/>
                 </a:solidFill>
@@ -2811,7 +2645,7 @@
           <a:bodyPr wrap="square" lIns="0" tIns="0" rIns="0" bIns="0" rtlCol="0" anchor="ctr"/>
           <a:lstStyle/>
           <a:p>
-            <a:pPr indent="0" marL="0">
+            <a:pPr marL="0" indent="0">
               <a:buNone/>
             </a:pPr>
             <a:r>
@@ -2850,7 +2684,7 @@
           <a:bodyPr wrap="square" lIns="0" tIns="0" rIns="0" bIns="0" rtlCol="0" anchor="ctr"/>
           <a:lstStyle/>
           <a:p>
-            <a:pPr indent="0" marL="0">
+            <a:pPr marL="0" indent="0">
               <a:lnSpc>
                 <a:spcPct val="115000"/>
               </a:lnSpc>
@@ -2892,7 +2726,7 @@
           <a:bodyPr wrap="square" lIns="0" tIns="0" rIns="0" bIns="0" rtlCol="0" anchor="ctr"/>
           <a:lstStyle/>
           <a:p>
-            <a:pPr indent="0" marL="0">
+            <a:pPr marL="0" indent="0">
               <a:buNone/>
             </a:pPr>
             <a:r>
@@ -2931,7 +2765,7 @@
           <a:bodyPr wrap="square" lIns="0" tIns="0" rIns="0" bIns="0" rtlCol="0" anchor="ctr"/>
           <a:lstStyle/>
           <a:p>
-            <a:pPr indent="0" marL="0">
+            <a:pPr marL="0" indent="0">
               <a:lnSpc>
                 <a:spcPct val="115000"/>
               </a:lnSpc>
@@ -2973,7 +2807,7 @@
           <a:bodyPr wrap="square" lIns="0" tIns="0" rIns="0" bIns="0" rtlCol="0" anchor="ctr"/>
           <a:lstStyle/>
           <a:p>
-            <a:pPr indent="0" marL="0">
+            <a:pPr marL="0" indent="0">
               <a:buNone/>
             </a:pPr>
             <a:r>
@@ -3012,7 +2846,7 @@
           <a:bodyPr wrap="square" lIns="0" tIns="0" rIns="0" bIns="0" rtlCol="0" anchor="ctr"/>
           <a:lstStyle/>
           <a:p>
-            <a:pPr indent="0" marL="0">
+            <a:pPr marL="0" indent="0">
               <a:lnSpc>
                 <a:spcPct val="115000"/>
               </a:lnSpc>
@@ -3054,7 +2888,7 @@
           <a:bodyPr wrap="square" lIns="0" tIns="0" rIns="0" bIns="0" rtlCol="0" anchor="ctr"/>
           <a:lstStyle/>
           <a:p>
-            <a:pPr indent="0" marL="0">
+            <a:pPr marL="0" indent="0">
               <a:buNone/>
             </a:pPr>
             <a:r>
@@ -3093,7 +2927,7 @@
           <a:bodyPr wrap="square" lIns="0" tIns="0" rIns="0" bIns="0" rtlCol="0" anchor="ctr"/>
           <a:lstStyle/>
           <a:p>
-            <a:pPr indent="0" marL="0">
+            <a:pPr marL="0" indent="0">
               <a:lnSpc>
                 <a:spcPct val="115000"/>
               </a:lnSpc>
@@ -3135,7 +2969,7 @@
           <a:bodyPr wrap="square" lIns="0" tIns="0" rIns="0" bIns="0" rtlCol="0" anchor="ctr"/>
           <a:lstStyle/>
           <a:p>
-            <a:pPr indent="0" marL="0">
+            <a:pPr marL="0" indent="0">
               <a:buNone/>
             </a:pPr>
             <a:r>
@@ -3174,7 +3008,7 @@
           <a:bodyPr wrap="square" lIns="0" tIns="0" rIns="0" bIns="0" rtlCol="0" anchor="ctr"/>
           <a:lstStyle/>
           <a:p>
-            <a:pPr indent="0" marL="0">
+            <a:pPr marL="0" indent="0">
               <a:lnSpc>
                 <a:spcPct val="115000"/>
               </a:lnSpc>
@@ -3239,6 +3073,13 @@
           </a:solidFill>
           <a:ln/>
         </p:spPr>
+        <p:txBody>
+          <a:bodyPr/>
+          <a:lstStyle/>
+          <a:p>
+            <a:endParaRPr lang="en-ID"/>
+          </a:p>
+        </p:txBody>
       </p:sp>
       <p:sp>
         <p:nvSpPr>
@@ -3259,6 +3100,13 @@
           </a:solidFill>
           <a:ln/>
         </p:spPr>
+        <p:txBody>
+          <a:bodyPr/>
+          <a:lstStyle/>
+          <a:p>
+            <a:endParaRPr lang="en-ID"/>
+          </a:p>
+        </p:txBody>
       </p:sp>
       <p:sp>
         <p:nvSpPr>
@@ -3281,7 +3129,7 @@
           <a:bodyPr wrap="square" lIns="0" tIns="0" rIns="0" bIns="0" rtlCol="0" anchor="ctr"/>
           <a:lstStyle/>
           <a:p>
-            <a:pPr indent="0" marL="0">
+            <a:pPr marL="0" indent="0">
               <a:buNone/>
             </a:pPr>
             <a:r>
@@ -3295,9 +3143,6 @@
               </a:rPr>
               <a:t>belajar</a:t>
             </a:r>
-            <a:pPr indent="0" marL="0">
-              <a:buNone/>
-            </a:pPr>
             <a:r>
               <a:rPr lang="en-US" sz="2000" b="1" dirty="0">
                 <a:solidFill>
@@ -3334,7 +3179,7 @@
           <a:bodyPr wrap="square" lIns="0" tIns="0" rIns="0" bIns="0" rtlCol="0" anchor="ctr"/>
           <a:lstStyle/>
           <a:p>
-            <a:pPr algn="r" indent="0" marL="0">
+            <a:pPr marL="0" indent="0" algn="r">
               <a:buNone/>
             </a:pPr>
             <a:r>
@@ -3373,11 +3218,11 @@
           <a:bodyPr wrap="square" lIns="0" tIns="0" rIns="0" bIns="0" rtlCol="0" anchor="ctr"/>
           <a:lstStyle/>
           <a:p>
-            <a:pPr indent="0" marL="0">
-              <a:buNone/>
-            </a:pPr>
-            <a:r>
-              <a:rPr lang="en-US" sz="1250" b="1" spc="40" kern="0" dirty="0">
+            <a:pPr marL="0" indent="0">
+              <a:buNone/>
+            </a:pPr>
+            <a:r>
+              <a:rPr lang="en-US" sz="1250" b="1" kern="0" spc="40" dirty="0">
                 <a:solidFill>
                   <a:srgbClr val="4B36C7"/>
                 </a:solidFill>
@@ -3412,7 +3257,7 @@
           <a:bodyPr wrap="square" lIns="0" tIns="0" rIns="0" bIns="0" rtlCol="0" anchor="ctr"/>
           <a:lstStyle/>
           <a:p>
-            <a:pPr indent="0" marL="0">
+            <a:pPr marL="0" indent="0">
               <a:buNone/>
             </a:pPr>
             <a:r>
@@ -3456,6 +3301,13 @@
             <a:prstDash val="solid"/>
           </a:ln>
         </p:spPr>
+        <p:txBody>
+          <a:bodyPr/>
+          <a:lstStyle/>
+          <a:p>
+            <a:endParaRPr lang="en-ID"/>
+          </a:p>
+        </p:txBody>
       </p:sp>
       <p:sp>
         <p:nvSpPr>
@@ -3478,11 +3330,11 @@
           <a:bodyPr wrap="square" lIns="0" tIns="0" rIns="0" bIns="0" rtlCol="0" anchor="ctr"/>
           <a:lstStyle/>
           <a:p>
-            <a:pPr indent="0" marL="0">
-              <a:buNone/>
-            </a:pPr>
-            <a:r>
-              <a:rPr lang="en-US" sz="1150" b="1" spc="30" kern="0" dirty="0">
+            <a:pPr marL="0" indent="0">
+              <a:buNone/>
+            </a:pPr>
+            <a:r>
+              <a:rPr lang="en-US" sz="1150" b="1" kern="0" spc="30" dirty="0">
                 <a:solidFill>
                   <a:srgbClr val="1A7A44"/>
                 </a:solidFill>
@@ -3517,7 +3369,7 @@
           <a:bodyPr wrap="square" lIns="0" tIns="0" rIns="0" bIns="0" rtlCol="0" anchor="ctr"/>
           <a:lstStyle/>
           <a:p>
-            <a:pPr indent="0" marL="0">
+            <a:pPr marL="0" indent="0">
               <a:lnSpc>
                 <a:spcPct val="125000"/>
               </a:lnSpc>
@@ -3559,7 +3411,7 @@
           <a:bodyPr wrap="square" lIns="0" tIns="0" rIns="0" bIns="0" rtlCol="0" anchor="ctr"/>
           <a:lstStyle/>
           <a:p>
-            <a:pPr indent="0" marL="0">
+            <a:pPr marL="0" indent="0">
               <a:lnSpc>
                 <a:spcPct val="125000"/>
               </a:lnSpc>
@@ -3606,6 +3458,13 @@
             <a:prstDash val="solid"/>
           </a:ln>
         </p:spPr>
+        <p:txBody>
+          <a:bodyPr/>
+          <a:lstStyle/>
+          <a:p>
+            <a:endParaRPr lang="en-ID"/>
+          </a:p>
+        </p:txBody>
       </p:sp>
       <p:sp>
         <p:nvSpPr>
@@ -3628,11 +3487,11 @@
           <a:bodyPr wrap="square" lIns="0" tIns="0" rIns="0" bIns="0" rtlCol="0" anchor="ctr"/>
           <a:lstStyle/>
           <a:p>
-            <a:pPr indent="0" marL="0">
-              <a:buNone/>
-            </a:pPr>
-            <a:r>
-              <a:rPr lang="en-US" sz="1150" b="1" spc="30" kern="0" dirty="0">
+            <a:pPr marL="0" indent="0">
+              <a:buNone/>
+            </a:pPr>
+            <a:r>
+              <a:rPr lang="en-US" sz="1150" b="1" kern="0" spc="30" dirty="0">
                 <a:solidFill>
                   <a:srgbClr val="1D4ED8"/>
                 </a:solidFill>
@@ -3667,7 +3526,7 @@
           <a:bodyPr wrap="square" lIns="0" tIns="0" rIns="0" bIns="0" rtlCol="0" anchor="ctr"/>
           <a:lstStyle/>
           <a:p>
-            <a:pPr indent="0" marL="0">
+            <a:pPr marL="0" indent="0">
               <a:lnSpc>
                 <a:spcPct val="125000"/>
               </a:lnSpc>
@@ -3682,7 +3541,7 @@
                 <a:ea typeface="Helvetica" pitchFamily="34" charset="-122"/>
                 <a:cs typeface="Helvetica" pitchFamily="34" charset="-120"/>
               </a:rPr>
-              <a:t>"cm-template-email.txt Email 2 sudah saya lengkapi: Flash Sale Frozen Soto, diskon 25%, kode SOTO25, berlaku 3 hari. Tulis email promosi, subjek maks 9 kata, isi maks 150 kata, tone hangat, CTA ke bit.ly/dapurrara. Simpan sebagai draft di Gmail saya."</a:t>
+              <a:t>"[Project sudah punya profil bisnis, tone, nama pengirim, jabatan] cm-template-email.txt Email 2 sudah saya lengkapi: Flash Sale Frozen Soto, diskon 25%, kode SOTO25, berlaku 3 hari. Tulis email promosi, subjek maks 9 kata, isi maks 150 kata, CTA ke bit.ly/dapurrara. Simpan sebagai draft di Gmail saya."</a:t>
             </a:r>
             <a:endParaRPr lang="en-US" sz="1150" dirty="0"/>
           </a:p>
@@ -3709,7 +3568,7 @@
           <a:bodyPr wrap="square" lIns="0" tIns="0" rIns="0" bIns="0" rtlCol="0" anchor="ctr"/>
           <a:lstStyle/>
           <a:p>
-            <a:pPr indent="0" marL="0">
+            <a:pPr marL="0" indent="0">
               <a:lnSpc>
                 <a:spcPct val="125000"/>
               </a:lnSpc>
@@ -3724,7 +3583,7 @@
                 <a:ea typeface="Helvetica" pitchFamily="34" charset="-122"/>
                 <a:cs typeface="Helvetica" pitchFamily="34" charset="-120"/>
               </a:rPr>
-              <a:t>Kenapa berhasil: template + Gmail Connector = email draft langsung di inbox, siap send.</a:t>
+              <a:t>Kenapa berhasil: Project sudah tahu tone &amp; pengirim, tinggal ganti detail promo — plus Gmail Connector = draft langsung di inbox.</a:t>
             </a:r>
             <a:endParaRPr lang="en-US" sz="1050" dirty="0"/>
           </a:p>
@@ -3774,6 +3633,13 @@
           </a:solidFill>
           <a:ln/>
         </p:spPr>
+        <p:txBody>
+          <a:bodyPr/>
+          <a:lstStyle/>
+          <a:p>
+            <a:endParaRPr lang="en-ID"/>
+          </a:p>
+        </p:txBody>
       </p:sp>
       <p:sp>
         <p:nvSpPr>
@@ -3794,6 +3660,13 @@
           </a:solidFill>
           <a:ln/>
         </p:spPr>
+        <p:txBody>
+          <a:bodyPr/>
+          <a:lstStyle/>
+          <a:p>
+            <a:endParaRPr lang="en-ID"/>
+          </a:p>
+        </p:txBody>
       </p:sp>
       <p:sp>
         <p:nvSpPr>
@@ -3816,7 +3689,7 @@
           <a:bodyPr wrap="square" lIns="0" tIns="0" rIns="0" bIns="0" rtlCol="0" anchor="ctr"/>
           <a:lstStyle/>
           <a:p>
-            <a:pPr indent="0" marL="0">
+            <a:pPr marL="0" indent="0">
               <a:buNone/>
             </a:pPr>
             <a:r>
@@ -3830,9 +3703,6 @@
               </a:rPr>
               <a:t>belajar</a:t>
             </a:r>
-            <a:pPr indent="0" marL="0">
-              <a:buNone/>
-            </a:pPr>
             <a:r>
               <a:rPr lang="en-US" sz="2000" b="1" dirty="0">
                 <a:solidFill>
@@ -3869,7 +3739,7 @@
           <a:bodyPr wrap="square" lIns="0" tIns="0" rIns="0" bIns="0" rtlCol="0" anchor="ctr"/>
           <a:lstStyle/>
           <a:p>
-            <a:pPr algn="r" indent="0" marL="0">
+            <a:pPr marL="0" indent="0" algn="r">
               <a:buNone/>
             </a:pPr>
             <a:r>
@@ -3908,11 +3778,11 @@
           <a:bodyPr wrap="square" lIns="0" tIns="0" rIns="0" bIns="0" rtlCol="0" anchor="ctr"/>
           <a:lstStyle/>
           <a:p>
-            <a:pPr indent="0" marL="0">
-              <a:buNone/>
-            </a:pPr>
-            <a:r>
-              <a:rPr lang="en-US" sz="1250" b="1" spc="40" kern="0" dirty="0">
+            <a:pPr marL="0" indent="0">
+              <a:buNone/>
+            </a:pPr>
+            <a:r>
+              <a:rPr lang="en-US" sz="1250" b="1" kern="0" spc="40" dirty="0">
                 <a:solidFill>
                   <a:srgbClr val="4B36C7"/>
                 </a:solidFill>
@@ -3947,7 +3817,7 @@
           <a:bodyPr wrap="square" lIns="0" tIns="0" rIns="0" bIns="0" rtlCol="0" anchor="ctr"/>
           <a:lstStyle/>
           <a:p>
-            <a:pPr indent="0" marL="0">
+            <a:pPr marL="0" indent="0">
               <a:buNone/>
             </a:pPr>
             <a:r>
@@ -3986,11 +3856,11 @@
           <a:bodyPr wrap="square" lIns="0" tIns="0" rIns="0" bIns="0" rtlCol="0" anchor="ctr"/>
           <a:lstStyle/>
           <a:p>
-            <a:pPr indent="0" marL="0">
-              <a:buNone/>
-            </a:pPr>
-            <a:r>
-              <a:rPr lang="en-US" sz="1250" b="1" spc="30" kern="0" dirty="0">
+            <a:pPr marL="0" indent="0">
+              <a:buNone/>
+            </a:pPr>
+            <a:r>
+              <a:rPr lang="en-US" sz="1250" b="1" kern="0" spc="30" dirty="0">
                 <a:solidFill>
                   <a:srgbClr val="1A7A44"/>
                 </a:solidFill>
@@ -4023,6 +3893,13 @@
           </a:solidFill>
           <a:ln/>
         </p:spPr>
+        <p:txBody>
+          <a:bodyPr/>
+          <a:lstStyle/>
+          <a:p>
+            <a:endParaRPr lang="en-ID"/>
+          </a:p>
+        </p:txBody>
       </p:sp>
       <p:sp>
         <p:nvSpPr>
@@ -4045,7 +3922,7 @@
           <a:bodyPr wrap="square" lIns="0" tIns="0" rIns="0" bIns="0" rtlCol="0" anchor="ctr"/>
           <a:lstStyle/>
           <a:p>
-            <a:pPr algn="ctr" indent="0" marL="0">
+            <a:pPr marL="0" indent="0" algn="ctr">
               <a:buNone/>
             </a:pPr>
             <a:r>
@@ -4071,7 +3948,7 @@
         </p:nvSpPr>
         <p:spPr>
           <a:xfrm>
-            <a:off x="905256" y="2459736"/>
+            <a:off x="905256" y="2389848"/>
             <a:ext cx="4764024" cy="594360"/>
           </a:xfrm>
           <a:prstGeom prst="rect">
@@ -4084,7 +3961,7 @@
           <a:bodyPr wrap="square" lIns="0" tIns="0" rIns="0" bIns="0" rtlCol="0" anchor="ctr"/>
           <a:lstStyle/>
           <a:p>
-            <a:pPr indent="0" marL="0">
+            <a:pPr marL="0" indent="0">
               <a:lnSpc>
                 <a:spcPct val="120000"/>
               </a:lnSpc>
@@ -4124,6 +4001,13 @@
           </a:solidFill>
           <a:ln/>
         </p:spPr>
+        <p:txBody>
+          <a:bodyPr/>
+          <a:lstStyle/>
+          <a:p>
+            <a:endParaRPr lang="en-ID"/>
+          </a:p>
+        </p:txBody>
       </p:sp>
       <p:sp>
         <p:nvSpPr>
@@ -4146,7 +4030,7 @@
           <a:bodyPr wrap="square" lIns="0" tIns="0" rIns="0" bIns="0" rtlCol="0" anchor="ctr"/>
           <a:lstStyle/>
           <a:p>
-            <a:pPr algn="ctr" indent="0" marL="0">
+            <a:pPr marL="0" indent="0" algn="ctr">
               <a:buNone/>
             </a:pPr>
             <a:r>
@@ -4172,7 +4056,7 @@
         </p:nvSpPr>
         <p:spPr>
           <a:xfrm>
-            <a:off x="905256" y="3172968"/>
+            <a:off x="905256" y="3103080"/>
             <a:ext cx="4764024" cy="594360"/>
           </a:xfrm>
           <a:prstGeom prst="rect">
@@ -4185,7 +4069,7 @@
           <a:bodyPr wrap="square" lIns="0" tIns="0" rIns="0" bIns="0" rtlCol="0" anchor="ctr"/>
           <a:lstStyle/>
           <a:p>
-            <a:pPr indent="0" marL="0">
+            <a:pPr marL="0" indent="0">
               <a:lnSpc>
                 <a:spcPct val="120000"/>
               </a:lnSpc>
@@ -4225,6 +4109,13 @@
           </a:solidFill>
           <a:ln/>
         </p:spPr>
+        <p:txBody>
+          <a:bodyPr/>
+          <a:lstStyle/>
+          <a:p>
+            <a:endParaRPr lang="en-ID"/>
+          </a:p>
+        </p:txBody>
       </p:sp>
       <p:sp>
         <p:nvSpPr>
@@ -4247,7 +4138,7 @@
           <a:bodyPr wrap="square" lIns="0" tIns="0" rIns="0" bIns="0" rtlCol="0" anchor="ctr"/>
           <a:lstStyle/>
           <a:p>
-            <a:pPr algn="ctr" indent="0" marL="0">
+            <a:pPr marL="0" indent="0" algn="ctr">
               <a:buNone/>
             </a:pPr>
             <a:r>
@@ -4273,7 +4164,7 @@
         </p:nvSpPr>
         <p:spPr>
           <a:xfrm>
-            <a:off x="905256" y="3886200"/>
+            <a:off x="905256" y="3816312"/>
             <a:ext cx="4764024" cy="594360"/>
           </a:xfrm>
           <a:prstGeom prst="rect">
@@ -4286,7 +4177,7 @@
           <a:bodyPr wrap="square" lIns="0" tIns="0" rIns="0" bIns="0" rtlCol="0" anchor="ctr"/>
           <a:lstStyle/>
           <a:p>
-            <a:pPr indent="0" marL="0">
+            <a:pPr marL="0" indent="0">
               <a:lnSpc>
                 <a:spcPct val="120000"/>
               </a:lnSpc>
@@ -4328,11 +4219,11 @@
           <a:bodyPr wrap="square" lIns="0" tIns="0" rIns="0" bIns="0" rtlCol="0" anchor="ctr"/>
           <a:lstStyle/>
           <a:p>
-            <a:pPr indent="0" marL="0">
-              <a:buNone/>
-            </a:pPr>
-            <a:r>
-              <a:rPr lang="en-US" sz="1250" b="1" spc="30" kern="0" dirty="0">
+            <a:pPr marL="0" indent="0">
+              <a:buNone/>
+            </a:pPr>
+            <a:r>
+              <a:rPr lang="en-US" sz="1250" b="1" kern="0" spc="30" dirty="0">
                 <a:solidFill>
                   <a:srgbClr val="1D4ED8"/>
                 </a:solidFill>
@@ -4365,6 +4256,13 @@
           </a:solidFill>
           <a:ln/>
         </p:spPr>
+        <p:txBody>
+          <a:bodyPr/>
+          <a:lstStyle/>
+          <a:p>
+            <a:endParaRPr lang="en-ID"/>
+          </a:p>
+        </p:txBody>
       </p:sp>
       <p:sp>
         <p:nvSpPr>
@@ -4387,7 +4285,7 @@
           <a:bodyPr wrap="square" lIns="0" tIns="0" rIns="0" bIns="0" rtlCol="0" anchor="ctr"/>
           <a:lstStyle/>
           <a:p>
-            <a:pPr algn="ctr" indent="0" marL="0">
+            <a:pPr marL="0" indent="0" algn="ctr">
               <a:buNone/>
             </a:pPr>
             <a:r>
@@ -4413,7 +4311,7 @@
         </p:nvSpPr>
         <p:spPr>
           <a:xfrm>
-            <a:off x="6574536" y="2459736"/>
+            <a:off x="6574536" y="2407320"/>
             <a:ext cx="4764024" cy="594360"/>
           </a:xfrm>
           <a:prstGeom prst="rect">
@@ -4426,7 +4324,7 @@
           <a:bodyPr wrap="square" lIns="0" tIns="0" rIns="0" bIns="0" rtlCol="0" anchor="ctr"/>
           <a:lstStyle/>
           <a:p>
-            <a:pPr indent="0" marL="0">
+            <a:pPr marL="0" indent="0">
               <a:lnSpc>
                 <a:spcPct val="120000"/>
               </a:lnSpc>
@@ -4466,6 +4364,13 @@
           </a:solidFill>
           <a:ln/>
         </p:spPr>
+        <p:txBody>
+          <a:bodyPr/>
+          <a:lstStyle/>
+          <a:p>
+            <a:endParaRPr lang="en-ID"/>
+          </a:p>
+        </p:txBody>
       </p:sp>
       <p:sp>
         <p:nvSpPr>
@@ -4488,7 +4393,7 @@
           <a:bodyPr wrap="square" lIns="0" tIns="0" rIns="0" bIns="0" rtlCol="0" anchor="ctr"/>
           <a:lstStyle/>
           <a:p>
-            <a:pPr algn="ctr" indent="0" marL="0">
+            <a:pPr marL="0" indent="0" algn="ctr">
               <a:buNone/>
             </a:pPr>
             <a:r>
@@ -4514,7 +4419,7 @@
         </p:nvSpPr>
         <p:spPr>
           <a:xfrm>
-            <a:off x="6574536" y="3172968"/>
+            <a:off x="6574536" y="3120552"/>
             <a:ext cx="4764024" cy="594360"/>
           </a:xfrm>
           <a:prstGeom prst="rect">
@@ -4527,7 +4432,7 @@
           <a:bodyPr wrap="square" lIns="0" tIns="0" rIns="0" bIns="0" rtlCol="0" anchor="ctr"/>
           <a:lstStyle/>
           <a:p>
-            <a:pPr indent="0" marL="0">
+            <a:pPr marL="0" indent="0">
               <a:lnSpc>
                 <a:spcPct val="120000"/>
               </a:lnSpc>
@@ -4542,7 +4447,7 @@
                 <a:ea typeface="Helvetica" pitchFamily="34" charset="-122"/>
                 <a:cs typeface="Helvetica" pitchFamily="34" charset="-120"/>
               </a:rPr>
-              <a:t>Isi cm-template-email.txt bagian relevan (nama produk, harga promo, tanggal, CTA), lalu upload ke Project Knowledge</a:t>
+              <a:t>Isi cm-template-email.txt bagian relevan (nama produk, harga promo, tanggal, CTA — info bisnis sudah di Project), lalu upload ke Project Knowledge</a:t>
             </a:r>
             <a:endParaRPr lang="en-US" sz="1100" dirty="0"/>
           </a:p>
@@ -4567,6 +4472,13 @@
           </a:solidFill>
           <a:ln/>
         </p:spPr>
+        <p:txBody>
+          <a:bodyPr/>
+          <a:lstStyle/>
+          <a:p>
+            <a:endParaRPr lang="en-ID"/>
+          </a:p>
+        </p:txBody>
       </p:sp>
       <p:sp>
         <p:nvSpPr>
@@ -4589,7 +4501,7 @@
           <a:bodyPr wrap="square" lIns="0" tIns="0" rIns="0" bIns="0" rtlCol="0" anchor="ctr"/>
           <a:lstStyle/>
           <a:p>
-            <a:pPr algn="ctr" indent="0" marL="0">
+            <a:pPr marL="0" indent="0" algn="ctr">
               <a:buNone/>
             </a:pPr>
             <a:r>
@@ -4615,7 +4527,7 @@
         </p:nvSpPr>
         <p:spPr>
           <a:xfrm>
-            <a:off x="6574536" y="3886200"/>
+            <a:off x="6574536" y="3833784"/>
             <a:ext cx="4764024" cy="594360"/>
           </a:xfrm>
           <a:prstGeom prst="rect">
@@ -4628,7 +4540,7 @@
           <a:bodyPr wrap="square" lIns="0" tIns="0" rIns="0" bIns="0" rtlCol="0" anchor="ctr"/>
           <a:lstStyle/>
           <a:p>
-            <a:pPr indent="0" marL="0">
+            <a:pPr marL="0" indent="0">
               <a:lnSpc>
                 <a:spcPct val="120000"/>
               </a:lnSpc>
@@ -4668,6 +4580,13 @@
           </a:solidFill>
           <a:ln/>
         </p:spPr>
+        <p:txBody>
+          <a:bodyPr/>
+          <a:lstStyle/>
+          <a:p>
+            <a:endParaRPr lang="en-ID"/>
+          </a:p>
+        </p:txBody>
       </p:sp>
       <p:sp>
         <p:nvSpPr>
@@ -4690,7 +4609,7 @@
           <a:bodyPr wrap="square" lIns="0" tIns="0" rIns="0" bIns="0" rtlCol="0" anchor="ctr"/>
           <a:lstStyle/>
           <a:p>
-            <a:pPr algn="ctr" indent="0" marL="0">
+            <a:pPr marL="0" indent="0" algn="ctr">
               <a:buNone/>
             </a:pPr>
             <a:r>
@@ -4716,7 +4635,7 @@
         </p:nvSpPr>
         <p:spPr>
           <a:xfrm>
-            <a:off x="6574536" y="4599432"/>
+            <a:off x="6574536" y="4547016"/>
             <a:ext cx="4764024" cy="594360"/>
           </a:xfrm>
           <a:prstGeom prst="rect">
@@ -4729,7 +4648,7 @@
           <a:bodyPr wrap="square" lIns="0" tIns="0" rIns="0" bIns="0" rtlCol="0" anchor="ctr"/>
           <a:lstStyle/>
           <a:p>
-            <a:pPr indent="0" marL="0">
+            <a:pPr marL="0" indent="0">
               <a:lnSpc>
                 <a:spcPct val="120000"/>
               </a:lnSpc>
@@ -4776,6 +4695,13 @@
             <a:prstDash val="solid"/>
           </a:ln>
         </p:spPr>
+        <p:txBody>
+          <a:bodyPr/>
+          <a:lstStyle/>
+          <a:p>
+            <a:endParaRPr lang="en-ID"/>
+          </a:p>
+        </p:txBody>
       </p:sp>
       <p:sp>
         <p:nvSpPr>
@@ -4798,7 +4724,7 @@
           <a:bodyPr wrap="square" lIns="0" tIns="0" rIns="0" bIns="0" rtlCol="0" anchor="ctr"/>
           <a:lstStyle/>
           <a:p>
-            <a:pPr indent="0" marL="0">
+            <a:pPr marL="0" indent="0">
               <a:lnSpc>
                 <a:spcPct val="120000"/>
               </a:lnSpc>
@@ -4815,12 +4741,6 @@
               </a:rPr>
               <a:t>◆  KENAPA EMAIL 1 LANGKAH LEBIH PANJANG?  </a:t>
             </a:r>
-            <a:pPr indent="0" marL="0">
-              <a:lnSpc>
-                <a:spcPct val="120000"/>
-              </a:lnSpc>
-              <a:buNone/>
-            </a:pPr>
             <a:r>
               <a:rPr lang="en-US" sz="1200" dirty="0">
                 <a:solidFill>
@@ -4880,6 +4800,13 @@
           </a:solidFill>
           <a:ln/>
         </p:spPr>
+        <p:txBody>
+          <a:bodyPr/>
+          <a:lstStyle/>
+          <a:p>
+            <a:endParaRPr lang="en-ID"/>
+          </a:p>
+        </p:txBody>
       </p:sp>
       <p:sp>
         <p:nvSpPr>
@@ -4900,6 +4827,13 @@
           </a:solidFill>
           <a:ln/>
         </p:spPr>
+        <p:txBody>
+          <a:bodyPr/>
+          <a:lstStyle/>
+          <a:p>
+            <a:endParaRPr lang="en-ID"/>
+          </a:p>
+        </p:txBody>
       </p:sp>
       <p:sp>
         <p:nvSpPr>
@@ -4922,7 +4856,7 @@
           <a:bodyPr wrap="square" lIns="0" tIns="0" rIns="0" bIns="0" rtlCol="0" anchor="ctr"/>
           <a:lstStyle/>
           <a:p>
-            <a:pPr indent="0" marL="0">
+            <a:pPr marL="0" indent="0">
               <a:buNone/>
             </a:pPr>
             <a:r>
@@ -4936,9 +4870,6 @@
               </a:rPr>
               <a:t>belajar</a:t>
             </a:r>
-            <a:pPr indent="0" marL="0">
-              <a:buNone/>
-            </a:pPr>
             <a:r>
               <a:rPr lang="en-US" sz="2000" b="1" dirty="0">
                 <a:solidFill>
@@ -4975,7 +4906,7 @@
           <a:bodyPr wrap="square" lIns="0" tIns="0" rIns="0" bIns="0" rtlCol="0" anchor="ctr"/>
           <a:lstStyle/>
           <a:p>
-            <a:pPr algn="r" indent="0" marL="0">
+            <a:pPr marL="0" indent="0" algn="r">
               <a:buNone/>
             </a:pPr>
             <a:r>
@@ -5014,11 +4945,11 @@
           <a:bodyPr wrap="square" lIns="0" tIns="0" rIns="0" bIns="0" rtlCol="0" anchor="ctr"/>
           <a:lstStyle/>
           <a:p>
-            <a:pPr indent="0" marL="0">
-              <a:buNone/>
-            </a:pPr>
-            <a:r>
-              <a:rPr lang="en-US" sz="1250" b="1" spc="40" kern="0" dirty="0">
+            <a:pPr marL="0" indent="0">
+              <a:buNone/>
+            </a:pPr>
+            <a:r>
+              <a:rPr lang="en-US" sz="1250" b="1" kern="0" spc="40" dirty="0">
                 <a:solidFill>
                   <a:srgbClr val="4B36C7"/>
                 </a:solidFill>
@@ -5053,7 +4984,7 @@
           <a:bodyPr wrap="square" lIns="0" tIns="0" rIns="0" bIns="0" rtlCol="0" anchor="ctr"/>
           <a:lstStyle/>
           <a:p>
-            <a:pPr indent="0" marL="0">
+            <a:pPr marL="0" indent="0">
               <a:buNone/>
             </a:pPr>
             <a:r>
@@ -5097,6 +5028,13 @@
             <a:prstDash val="solid"/>
           </a:ln>
         </p:spPr>
+        <p:txBody>
+          <a:bodyPr/>
+          <a:lstStyle/>
+          <a:p>
+            <a:endParaRPr lang="en-ID"/>
+          </a:p>
+        </p:txBody>
       </p:sp>
       <p:sp>
         <p:nvSpPr>
@@ -5119,7 +5057,7 @@
           <a:bodyPr wrap="square" lIns="0" tIns="0" rIns="0" bIns="0" rtlCol="0" anchor="ctr"/>
           <a:lstStyle/>
           <a:p>
-            <a:pPr indent="0" marL="0">
+            <a:pPr marL="0" indent="0">
               <a:buNone/>
             </a:pPr>
             <a:r>
@@ -5158,7 +5096,7 @@
           <a:bodyPr wrap="square" lIns="0" tIns="0" rIns="0" bIns="0" rtlCol="0" anchor="ctr"/>
           <a:lstStyle/>
           <a:p>
-            <a:pPr indent="0" marL="0">
+            <a:pPr marL="0" indent="0">
               <a:lnSpc>
                 <a:spcPct val="120000"/>
               </a:lnSpc>
@@ -5205,6 +5143,13 @@
             <a:prstDash val="solid"/>
           </a:ln>
         </p:spPr>
+        <p:txBody>
+          <a:bodyPr/>
+          <a:lstStyle/>
+          <a:p>
+            <a:endParaRPr lang="en-ID"/>
+          </a:p>
+        </p:txBody>
       </p:sp>
       <p:sp>
         <p:nvSpPr>
@@ -5227,7 +5172,7 @@
           <a:bodyPr wrap="square" lIns="0" tIns="0" rIns="0" bIns="0" rtlCol="0" anchor="ctr"/>
           <a:lstStyle/>
           <a:p>
-            <a:pPr indent="0" marL="0">
+            <a:pPr marL="0" indent="0">
               <a:buNone/>
             </a:pPr>
             <a:r>
@@ -5266,7 +5211,7 @@
           <a:bodyPr wrap="square" lIns="0" tIns="0" rIns="0" bIns="0" rtlCol="0" anchor="ctr"/>
           <a:lstStyle/>
           <a:p>
-            <a:pPr indent="0" marL="0">
+            <a:pPr marL="0" indent="0">
               <a:lnSpc>
                 <a:spcPct val="120000"/>
               </a:lnSpc>
@@ -5313,6 +5258,13 @@
             <a:prstDash val="solid"/>
           </a:ln>
         </p:spPr>
+        <p:txBody>
+          <a:bodyPr/>
+          <a:lstStyle/>
+          <a:p>
+            <a:endParaRPr lang="en-ID"/>
+          </a:p>
+        </p:txBody>
       </p:sp>
       <p:sp>
         <p:nvSpPr>
@@ -5335,7 +5287,7 @@
           <a:bodyPr wrap="square" lIns="0" tIns="0" rIns="0" bIns="0" rtlCol="0" anchor="ctr"/>
           <a:lstStyle/>
           <a:p>
-            <a:pPr indent="0" marL="0">
+            <a:pPr marL="0" indent="0">
               <a:buNone/>
             </a:pPr>
             <a:r>
@@ -5374,7 +5326,7 @@
           <a:bodyPr wrap="square" lIns="0" tIns="0" rIns="0" bIns="0" rtlCol="0" anchor="ctr"/>
           <a:lstStyle/>
           <a:p>
-            <a:pPr indent="0" marL="0">
+            <a:pPr marL="0" indent="0">
               <a:lnSpc>
                 <a:spcPct val="120000"/>
               </a:lnSpc>
@@ -5421,6 +5373,13 @@
             <a:prstDash val="solid"/>
           </a:ln>
         </p:spPr>
+        <p:txBody>
+          <a:bodyPr/>
+          <a:lstStyle/>
+          <a:p>
+            <a:endParaRPr lang="en-ID"/>
+          </a:p>
+        </p:txBody>
       </p:sp>
       <p:sp>
         <p:nvSpPr>
@@ -5443,7 +5402,7 @@
           <a:bodyPr wrap="square" lIns="0" tIns="0" rIns="0" bIns="0" rtlCol="0" anchor="ctr"/>
           <a:lstStyle/>
           <a:p>
-            <a:pPr indent="0" marL="0">
+            <a:pPr marL="0" indent="0">
               <a:buNone/>
             </a:pPr>
             <a:r>
@@ -5482,7 +5441,7 @@
           <a:bodyPr wrap="square" lIns="0" tIns="0" rIns="0" bIns="0" rtlCol="0" anchor="ctr"/>
           <a:lstStyle/>
           <a:p>
-            <a:pPr indent="0" marL="0">
+            <a:pPr marL="0" indent="0">
               <a:lnSpc>
                 <a:spcPct val="120000"/>
               </a:lnSpc>
@@ -5529,6 +5488,13 @@
             <a:prstDash val="solid"/>
           </a:ln>
         </p:spPr>
+        <p:txBody>
+          <a:bodyPr/>
+          <a:lstStyle/>
+          <a:p>
+            <a:endParaRPr lang="en-ID"/>
+          </a:p>
+        </p:txBody>
       </p:sp>
       <p:sp>
         <p:nvSpPr>
@@ -5551,7 +5517,7 @@
           <a:bodyPr wrap="square" lIns="0" tIns="0" rIns="0" bIns="0" rtlCol="0" anchor="ctr"/>
           <a:lstStyle/>
           <a:p>
-            <a:pPr indent="0" marL="0">
+            <a:pPr marL="0" indent="0">
               <a:buNone/>
             </a:pPr>
             <a:r>
@@ -5590,7 +5556,7 @@
           <a:bodyPr wrap="square" lIns="0" tIns="0" rIns="0" bIns="0" rtlCol="0" anchor="ctr"/>
           <a:lstStyle/>
           <a:p>
-            <a:pPr indent="0" marL="0">
+            <a:pPr marL="0" indent="0">
               <a:lnSpc>
                 <a:spcPct val="120000"/>
               </a:lnSpc>
@@ -5637,6 +5603,13 @@
             <a:prstDash val="solid"/>
           </a:ln>
         </p:spPr>
+        <p:txBody>
+          <a:bodyPr/>
+          <a:lstStyle/>
+          <a:p>
+            <a:endParaRPr lang="en-ID"/>
+          </a:p>
+        </p:txBody>
       </p:sp>
       <p:sp>
         <p:nvSpPr>
@@ -5659,7 +5632,7 @@
           <a:bodyPr wrap="square" lIns="0" tIns="0" rIns="0" bIns="0" rtlCol="0" anchor="ctr"/>
           <a:lstStyle/>
           <a:p>
-            <a:pPr indent="0" marL="0">
+            <a:pPr marL="0" indent="0">
               <a:buNone/>
             </a:pPr>
             <a:r>
@@ -5698,7 +5671,7 @@
           <a:bodyPr wrap="square" lIns="0" tIns="0" rIns="0" bIns="0" rtlCol="0" anchor="ctr"/>
           <a:lstStyle/>
           <a:p>
-            <a:pPr indent="0" marL="0">
+            <a:pPr marL="0" indent="0">
               <a:lnSpc>
                 <a:spcPct val="120000"/>
               </a:lnSpc>
@@ -5763,6 +5736,13 @@
           </a:solidFill>
           <a:ln/>
         </p:spPr>
+        <p:txBody>
+          <a:bodyPr/>
+          <a:lstStyle/>
+          <a:p>
+            <a:endParaRPr lang="en-ID"/>
+          </a:p>
+        </p:txBody>
       </p:sp>
       <p:sp>
         <p:nvSpPr>
@@ -5783,6 +5763,13 @@
           </a:solidFill>
           <a:ln/>
         </p:spPr>
+        <p:txBody>
+          <a:bodyPr/>
+          <a:lstStyle/>
+          <a:p>
+            <a:endParaRPr lang="en-ID"/>
+          </a:p>
+        </p:txBody>
       </p:sp>
       <p:sp>
         <p:nvSpPr>
@@ -5805,7 +5792,7 @@
           <a:bodyPr wrap="square" lIns="0" tIns="0" rIns="0" bIns="0" rtlCol="0" anchor="ctr"/>
           <a:lstStyle/>
           <a:p>
-            <a:pPr indent="0" marL="0">
+            <a:pPr marL="0" indent="0">
               <a:buNone/>
             </a:pPr>
             <a:r>
@@ -5819,9 +5806,6 @@
               </a:rPr>
               <a:t>belajar</a:t>
             </a:r>
-            <a:pPr indent="0" marL="0">
-              <a:buNone/>
-            </a:pPr>
             <a:r>
               <a:rPr lang="en-US" sz="2000" b="1" dirty="0">
                 <a:solidFill>
@@ -5858,7 +5842,7 @@
           <a:bodyPr wrap="square" lIns="0" tIns="0" rIns="0" bIns="0" rtlCol="0" anchor="ctr"/>
           <a:lstStyle/>
           <a:p>
-            <a:pPr algn="r" indent="0" marL="0">
+            <a:pPr marL="0" indent="0" algn="r">
               <a:buNone/>
             </a:pPr>
             <a:r>
@@ -5897,11 +5881,11 @@
           <a:bodyPr wrap="square" lIns="0" tIns="0" rIns="0" bIns="0" rtlCol="0" anchor="ctr"/>
           <a:lstStyle/>
           <a:p>
-            <a:pPr indent="0" marL="0">
-              <a:buNone/>
-            </a:pPr>
-            <a:r>
-              <a:rPr lang="en-US" sz="1250" b="1" spc="40" kern="0" dirty="0">
+            <a:pPr marL="0" indent="0">
+              <a:buNone/>
+            </a:pPr>
+            <a:r>
+              <a:rPr lang="en-US" sz="1250" b="1" kern="0" spc="40" dirty="0">
                 <a:solidFill>
                   <a:srgbClr val="4B36C7"/>
                 </a:solidFill>
@@ -5936,7 +5920,7 @@
           <a:bodyPr wrap="square" lIns="0" tIns="0" rIns="0" bIns="0" rtlCol="0" anchor="ctr"/>
           <a:lstStyle/>
           <a:p>
-            <a:pPr indent="0" marL="0">
+            <a:pPr marL="0" indent="0">
               <a:buNone/>
             </a:pPr>
             <a:r>
@@ -5980,6 +5964,13 @@
             <a:prstDash val="solid"/>
           </a:ln>
         </p:spPr>
+        <p:txBody>
+          <a:bodyPr/>
+          <a:lstStyle/>
+          <a:p>
+            <a:endParaRPr lang="en-ID"/>
+          </a:p>
+        </p:txBody>
       </p:sp>
       <p:sp>
         <p:nvSpPr>
@@ -6002,7 +5993,7 @@
           <a:bodyPr wrap="square" lIns="0" tIns="0" rIns="0" bIns="0" rtlCol="0" anchor="ctr"/>
           <a:lstStyle/>
           <a:p>
-            <a:pPr indent="0" marL="0">
+            <a:pPr marL="0" indent="0">
               <a:buNone/>
             </a:pPr>
             <a:r>
@@ -6041,7 +6032,7 @@
           <a:bodyPr wrap="square" lIns="0" tIns="0" rIns="0" bIns="0" rtlCol="0" anchor="ctr"/>
           <a:lstStyle/>
           <a:p>
-            <a:pPr indent="0" marL="0">
+            <a:pPr marL="0" indent="0">
               <a:lnSpc>
                 <a:spcPct val="125000"/>
               </a:lnSpc>
@@ -6088,6 +6079,13 @@
             <a:prstDash val="solid"/>
           </a:ln>
         </p:spPr>
+        <p:txBody>
+          <a:bodyPr/>
+          <a:lstStyle/>
+          <a:p>
+            <a:endParaRPr lang="en-ID"/>
+          </a:p>
+        </p:txBody>
       </p:sp>
       <p:sp>
         <p:nvSpPr>
@@ -6110,7 +6108,7 @@
           <a:bodyPr wrap="square" lIns="0" tIns="0" rIns="0" bIns="0" rtlCol="0" anchor="ctr"/>
           <a:lstStyle/>
           <a:p>
-            <a:pPr indent="0" marL="0">
+            <a:pPr marL="0" indent="0">
               <a:lnSpc>
                 <a:spcPct val="120000"/>
               </a:lnSpc>
@@ -6125,7 +6123,7 @@
                 <a:ea typeface="Helvetica" pitchFamily="34" charset="-122"/>
                 <a:cs typeface="Helvetica" pitchFamily="34" charset="-120"/>
               </a:rPr>
-              <a:t>Tambahkan brand voice untuk komunikasi pelanggan: tone santai-hangat, sapaan "Kak", batasan emoji 1-2 per pesan. Lalu buatkan 10 template WhatsApp untuk skenario di cm-template-wa.txt, dan 2 draft email (launch produk baru + flash sale) dari cm-template-email.txt — simpan sebagai draft di Gmail saya.</a:t>
+              <a:t>Tambahkan brand voice: tone santai-hangat, sapaan "Kak", batasan emoji 1-2 per pesan, nama pengirim &amp; jabatan untuk email. Lalu buatkan 10 template WhatsApp untuk skenario di cm-template-wa.txt, dan 2 draft email (launch produk baru + flash sale) dari cm-template-email.txt — simpan sebagai draft di Gmail saya.</a:t>
             </a:r>
             <a:endParaRPr lang="en-US" sz="950" dirty="0"/>
           </a:p>
@@ -6152,6 +6150,13 @@
           </a:solidFill>
           <a:ln/>
         </p:spPr>
+        <p:txBody>
+          <a:bodyPr/>
+          <a:lstStyle/>
+          <a:p>
+            <a:endParaRPr lang="en-ID"/>
+          </a:p>
+        </p:txBody>
       </p:sp>
       <p:sp>
         <p:nvSpPr>
@@ -6174,7 +6179,7 @@
           <a:bodyPr wrap="square" lIns="0" tIns="0" rIns="0" bIns="0" rtlCol="0" anchor="ctr"/>
           <a:lstStyle/>
           <a:p>
-            <a:pPr indent="0" marL="0">
+            <a:pPr marL="0" indent="0">
               <a:buNone/>
             </a:pPr>
             <a:r>
@@ -6213,7 +6218,7 @@
           <a:bodyPr wrap="square" lIns="0" tIns="0" rIns="0" bIns="0" rtlCol="0" anchor="ctr"/>
           <a:lstStyle/>
           <a:p>
-            <a:pPr indent="0" marL="0">
+            <a:pPr marL="0" indent="0">
               <a:lnSpc>
                 <a:spcPct val="130000"/>
               </a:lnSpc>
@@ -6233,7 +6238,7 @@
             <a:endParaRPr lang="en-US" sz="1200" dirty="0"/>
           </a:p>
           <a:p>
-            <a:pPr indent="0" marL="0">
+            <a:pPr marL="0" indent="0">
               <a:lnSpc>
                 <a:spcPct val="130000"/>
               </a:lnSpc>
@@ -6555,4 +6560,319 @@
     </a:ext>
   </a:extLst>
 </a:theme>
+</file>
+
+<file path=ppt/theme/theme2.xml><?xml version="1.0" encoding="utf-8"?>
+<a:theme xmlns:a="http://schemas.openxmlformats.org/drawingml/2006/main" name="Office Theme">
+  <a:themeElements>
+    <a:clrScheme name="Office">
+      <a:dk1>
+        <a:sysClr val="windowText" lastClr="000000"/>
+      </a:dk1>
+      <a:lt1>
+        <a:sysClr val="window" lastClr="FFFFFF"/>
+      </a:lt1>
+      <a:dk2>
+        <a:srgbClr val="0E2841"/>
+      </a:dk2>
+      <a:lt2>
+        <a:srgbClr val="E8E8E8"/>
+      </a:lt2>
+      <a:accent1>
+        <a:srgbClr val="156082"/>
+      </a:accent1>
+      <a:accent2>
+        <a:srgbClr val="E97132"/>
+      </a:accent2>
+      <a:accent3>
+        <a:srgbClr val="196B24"/>
+      </a:accent3>
+      <a:accent4>
+        <a:srgbClr val="0F9ED5"/>
+      </a:accent4>
+      <a:accent5>
+        <a:srgbClr val="A02B93"/>
+      </a:accent5>
+      <a:accent6>
+        <a:srgbClr val="4EA72E"/>
+      </a:accent6>
+      <a:hlink>
+        <a:srgbClr val="467886"/>
+      </a:hlink>
+      <a:folHlink>
+        <a:srgbClr val="96607D"/>
+      </a:folHlink>
+    </a:clrScheme>
+    <a:fontScheme name="Office">
+      <a:majorFont>
+        <a:latin typeface="Aptos Display" panose="02110004020202020204"/>
+        <a:ea typeface=""/>
+        <a:cs typeface=""/>
+        <a:font script="Jpan" typeface="游ゴシック Light"/>
+        <a:font script="Hang" typeface="맑은 고딕"/>
+        <a:font script="Hans" typeface="等线 Light"/>
+        <a:font script="Hant" typeface="新細明體"/>
+        <a:font script="Arab" typeface="Times New Roman"/>
+        <a:font script="Hebr" typeface="Times New Roman"/>
+        <a:font script="Thai" typeface="Angsana New"/>
+        <a:font script="Ethi" typeface="Nyala"/>
+        <a:font script="Beng" typeface="Vrinda"/>
+        <a:font script="Gujr" typeface="Shruti"/>
+        <a:font script="Khmr" typeface="MoolBoran"/>
+        <a:font script="Knda" typeface="Tunga"/>
+        <a:font script="Guru" typeface="Raavi"/>
+        <a:font script="Cans" typeface="Euphemia"/>
+        <a:font script="Cher" typeface="Plantagenet Cherokee"/>
+        <a:font script="Yiii" typeface="Microsoft Yi Baiti"/>
+        <a:font script="Tibt" typeface="Microsoft Himalaya"/>
+        <a:font script="Thaa" typeface="MV Boli"/>
+        <a:font script="Deva" typeface="Mangal"/>
+        <a:font script="Telu" typeface="Gautami"/>
+        <a:font script="Taml" typeface="Latha"/>
+        <a:font script="Syrc" typeface="Estrangelo Edessa"/>
+        <a:font script="Orya" typeface="Kalinga"/>
+        <a:font script="Mlym" typeface="Kartika"/>
+        <a:font script="Laoo" typeface="DokChampa"/>
+        <a:font script="Sinh" typeface="Iskoola Pota"/>
+        <a:font script="Mong" typeface="Mongolian Baiti"/>
+        <a:font script="Viet" typeface="Times New Roman"/>
+        <a:font script="Uigh" typeface="Microsoft Uighur"/>
+        <a:font script="Geor" typeface="Sylfaen"/>
+        <a:font script="Armn" typeface="Arial"/>
+        <a:font script="Bugi" typeface="Leelawadee UI"/>
+        <a:font script="Bopo" typeface="Microsoft JhengHei"/>
+        <a:font script="Java" typeface="Javanese Text"/>
+        <a:font script="Lisu" typeface="Segoe UI"/>
+        <a:font script="Mymr" typeface="Myanmar Text"/>
+        <a:font script="Nkoo" typeface="Ebrima"/>
+        <a:font script="Olck" typeface="Nirmala UI"/>
+        <a:font script="Osma" typeface="Ebrima"/>
+        <a:font script="Phag" typeface="Phagspa"/>
+        <a:font script="Syrn" typeface="Estrangelo Edessa"/>
+        <a:font script="Syrj" typeface="Estrangelo Edessa"/>
+        <a:font script="Syre" typeface="Estrangelo Edessa"/>
+        <a:font script="Sora" typeface="Nirmala UI"/>
+        <a:font script="Tale" typeface="Microsoft Tai Le"/>
+        <a:font script="Talu" typeface="Microsoft New Tai Lue"/>
+        <a:font script="Tfng" typeface="Ebrima"/>
+      </a:majorFont>
+      <a:minorFont>
+        <a:latin typeface="Aptos" panose="02110004020202020204"/>
+        <a:ea typeface=""/>
+        <a:cs typeface=""/>
+        <a:font script="Jpan" typeface="游ゴシック"/>
+        <a:font script="Hang" typeface="맑은 고딕"/>
+        <a:font script="Hans" typeface="等线"/>
+        <a:font script="Hant" typeface="新細明體"/>
+        <a:font script="Arab" typeface="Arial"/>
+        <a:font script="Hebr" typeface="Arial"/>
+        <a:font script="Thai" typeface="Cordia New"/>
+        <a:font script="Ethi" typeface="Nyala"/>
+        <a:font script="Beng" typeface="Vrinda"/>
+        <a:font script="Gujr" typeface="Shruti"/>
+        <a:font script="Khmr" typeface="DaunPenh"/>
+        <a:font script="Knda" typeface="Tunga"/>
+        <a:font script="Guru" typeface="Raavi"/>
+        <a:font script="Cans" typeface="Euphemia"/>
+        <a:font script="Cher" typeface="Plantagenet Cherokee"/>
+        <a:font script="Yiii" typeface="Microsoft Yi Baiti"/>
+        <a:font script="Tibt" typeface="Microsoft Himalaya"/>
+        <a:font script="Thaa" typeface="MV Boli"/>
+        <a:font script="Deva" typeface="Mangal"/>
+        <a:font script="Telu" typeface="Gautami"/>
+        <a:font script="Taml" typeface="Latha"/>
+        <a:font script="Syrc" typeface="Estrangelo Edessa"/>
+        <a:font script="Orya" typeface="Kalinga"/>
+        <a:font script="Mlym" typeface="Kartika"/>
+        <a:font script="Laoo" typeface="DokChampa"/>
+        <a:font script="Sinh" typeface="Iskoola Pota"/>
+        <a:font script="Mong" typeface="Mongolian Baiti"/>
+        <a:font script="Viet" typeface="Arial"/>
+        <a:font script="Uigh" typeface="Microsoft Uighur"/>
+        <a:font script="Geor" typeface="Sylfaen"/>
+        <a:font script="Armn" typeface="Arial"/>
+        <a:font script="Bugi" typeface="Leelawadee UI"/>
+        <a:font script="Bopo" typeface="Microsoft JhengHei"/>
+        <a:font script="Java" typeface="Javanese Text"/>
+        <a:font script="Lisu" typeface="Segoe UI"/>
+        <a:font script="Mymr" typeface="Myanmar Text"/>
+        <a:font script="Nkoo" typeface="Ebrima"/>
+        <a:font script="Olck" typeface="Nirmala UI"/>
+        <a:font script="Osma" typeface="Ebrima"/>
+        <a:font script="Phag" typeface="Phagspa"/>
+        <a:font script="Syrn" typeface="Estrangelo Edessa"/>
+        <a:font script="Syrj" typeface="Estrangelo Edessa"/>
+        <a:font script="Syre" typeface="Estrangelo Edessa"/>
+        <a:font script="Sora" typeface="Nirmala UI"/>
+        <a:font script="Tale" typeface="Microsoft Tai Le"/>
+        <a:font script="Talu" typeface="Microsoft New Tai Lue"/>
+        <a:font script="Tfng" typeface="Ebrima"/>
+      </a:minorFont>
+    </a:fontScheme>
+    <a:fmtScheme name="Office">
+      <a:fillStyleLst>
+        <a:solidFill>
+          <a:schemeClr val="phClr"/>
+        </a:solidFill>
+        <a:gradFill rotWithShape="1">
+          <a:gsLst>
+            <a:gs pos="0">
+              <a:schemeClr val="phClr">
+                <a:lumMod val="110000"/>
+                <a:satMod val="105000"/>
+                <a:tint val="67000"/>
+              </a:schemeClr>
+            </a:gs>
+            <a:gs pos="50000">
+              <a:schemeClr val="phClr">
+                <a:lumMod val="105000"/>
+                <a:satMod val="103000"/>
+                <a:tint val="73000"/>
+              </a:schemeClr>
+            </a:gs>
+            <a:gs pos="100000">
+              <a:schemeClr val="phClr">
+                <a:lumMod val="105000"/>
+                <a:satMod val="109000"/>
+                <a:tint val="81000"/>
+              </a:schemeClr>
+            </a:gs>
+          </a:gsLst>
+          <a:lin ang="5400000" scaled="0"/>
+        </a:gradFill>
+        <a:gradFill rotWithShape="1">
+          <a:gsLst>
+            <a:gs pos="0">
+              <a:schemeClr val="phClr">
+                <a:satMod val="103000"/>
+                <a:lumMod val="102000"/>
+                <a:tint val="94000"/>
+              </a:schemeClr>
+            </a:gs>
+            <a:gs pos="50000">
+              <a:schemeClr val="phClr">
+                <a:satMod val="110000"/>
+                <a:lumMod val="100000"/>
+                <a:shade val="100000"/>
+              </a:schemeClr>
+            </a:gs>
+            <a:gs pos="100000">
+              <a:schemeClr val="phClr">
+                <a:lumMod val="99000"/>
+                <a:satMod val="120000"/>
+                <a:shade val="78000"/>
+              </a:schemeClr>
+            </a:gs>
+          </a:gsLst>
+          <a:lin ang="5400000" scaled="0"/>
+        </a:gradFill>
+      </a:fillStyleLst>
+      <a:lnStyleLst>
+        <a:ln w="12700" cap="flat" cmpd="sng" algn="ctr">
+          <a:solidFill>
+            <a:schemeClr val="phClr"/>
+          </a:solidFill>
+          <a:prstDash val="solid"/>
+          <a:miter lim="800000"/>
+        </a:ln>
+        <a:ln w="19050" cap="flat" cmpd="sng" algn="ctr">
+          <a:solidFill>
+            <a:schemeClr val="phClr"/>
+          </a:solidFill>
+          <a:prstDash val="solid"/>
+          <a:miter lim="800000"/>
+        </a:ln>
+        <a:ln w="25400" cap="flat" cmpd="sng" algn="ctr">
+          <a:solidFill>
+            <a:schemeClr val="phClr"/>
+          </a:solidFill>
+          <a:prstDash val="solid"/>
+          <a:miter lim="800000"/>
+        </a:ln>
+      </a:lnStyleLst>
+      <a:effectStyleLst>
+        <a:effectStyle>
+          <a:effectLst/>
+        </a:effectStyle>
+        <a:effectStyle>
+          <a:effectLst/>
+        </a:effectStyle>
+        <a:effectStyle>
+          <a:effectLst>
+            <a:outerShdw blurRad="57150" dist="19050" dir="5400000" algn="ctr" rotWithShape="0">
+              <a:srgbClr val="000000">
+                <a:alpha val="63000"/>
+              </a:srgbClr>
+            </a:outerShdw>
+          </a:effectLst>
+        </a:effectStyle>
+      </a:effectStyleLst>
+      <a:bgFillStyleLst>
+        <a:solidFill>
+          <a:schemeClr val="phClr"/>
+        </a:solidFill>
+        <a:solidFill>
+          <a:schemeClr val="phClr">
+            <a:tint val="95000"/>
+            <a:satMod val="170000"/>
+          </a:schemeClr>
+        </a:solidFill>
+        <a:gradFill rotWithShape="1">
+          <a:gsLst>
+            <a:gs pos="0">
+              <a:schemeClr val="phClr">
+                <a:tint val="93000"/>
+                <a:satMod val="150000"/>
+                <a:shade val="98000"/>
+                <a:lumMod val="102000"/>
+              </a:schemeClr>
+            </a:gs>
+            <a:gs pos="50000">
+              <a:schemeClr val="phClr">
+                <a:tint val="98000"/>
+                <a:satMod val="130000"/>
+                <a:shade val="90000"/>
+                <a:lumMod val="103000"/>
+              </a:schemeClr>
+            </a:gs>
+            <a:gs pos="100000">
+              <a:schemeClr val="phClr">
+                <a:shade val="63000"/>
+                <a:satMod val="120000"/>
+              </a:schemeClr>
+            </a:gs>
+          </a:gsLst>
+          <a:lin ang="5400000" scaled="0"/>
+        </a:gradFill>
+      </a:bgFillStyleLst>
+    </a:fmtScheme>
+  </a:themeElements>
+  <a:objectDefaults>
+    <a:lnDef>
+      <a:spPr/>
+      <a:bodyPr/>
+      <a:lstStyle/>
+      <a:style>
+        <a:lnRef idx="2">
+          <a:schemeClr val="accent1"/>
+        </a:lnRef>
+        <a:fillRef idx="0">
+          <a:schemeClr val="accent1"/>
+        </a:fillRef>
+        <a:effectRef idx="1">
+          <a:schemeClr val="accent1"/>
+        </a:effectRef>
+        <a:fontRef idx="minor">
+          <a:schemeClr val="tx1"/>
+        </a:fontRef>
+      </a:style>
+    </a:lnDef>
+  </a:objectDefaults>
+  <a:extraClrSchemeLst/>
+  <a:extLst>
+    <a:ext uri="{05A4C25C-085E-4340-85A3-A5531E510DB2}">
+      <thm15:themeFamily xmlns:thm15="http://schemas.microsoft.com/office/thememl/2012/main" name="Office Theme" id="{2E142A2C-CD16-42D6-873A-C26D2A0506FA}" vid="{1BDDFF52-6CD6-40A5-AB3C-68EB2F1E4D0A}"/>
+    </a:ext>
+  </a:extLst>
+</a:theme>
 </file>
</xml_diff>

<commit_message>
M05: clarify copy-paste mechanic for both channels, fix ambiguous Latihan wording, show two-phase exercise (build templates, then live on-the-spot generation)
</commit_message>
<xml_diff>
--- a/Content-Marketing/M05-Komunikasi-Pelanggan/K3-M05-Komunikasi-Pelanggan.pptx
+++ b/Content-Marketing/M05-Komunikasi-Pelanggan/K3-M05-Komunikasi-Pelanggan.pptx
@@ -2257,7 +2257,7 @@
                 <a:ea typeface="Helvetica" pitchFamily="34" charset="-122"/>
                 <a:cs typeface="Helvetica" pitchFamily="34" charset="-120"/>
               </a:rPr>
-              <a:t>◆  INTEGRASI: CLAUDE PROJECTS + GMAIL CONNECTOR</a:t>
+              <a:t>◆  CLAUDE PROJECTS (WAJIB) + GMAIL CONNECTOR (OPSIONAL)</a:t>
             </a:r>
             <a:endParaRPr lang="en-US" sz="1250" dirty="0"/>
           </a:p>
@@ -2299,7 +2299,7 @@
                 <a:ea typeface="Helvetica" pitchFamily="34" charset="-122"/>
                 <a:cs typeface="Helvetica" pitchFamily="34" charset="-120"/>
               </a:rPr>
-              <a:t>Level: Claude Projects (semua plan termasuk Free) · Setup: 5 menit sekali. Tambahkan brand voice CS ke Claude Project dari Modul 1 (sudah punya positioning &amp; identitas visual). Upload juga cm-template-wa.txt dan cm-template-email.txt ke Project Knowledge — supaya prompt yang menyebut "Skenario 1" atau "Email 2" langsung terbaca Claude. WhatsApp: generate lalu copy-paste manual. Email: aktifkan juga Gmail Connector (gratis, 60 detik) — Claude langsung membuat draft di inbox-mu, kamu tinggal review dan klik Send.</a:t>
+              <a:t>Level: Claude Projects (semua plan termasuk Free) · Setup: 5 menit sekali. Tambahkan brand voice CS ke Claude Project dari Modul 1. Upload juga cm-template-wa.txt dan cm-template-email.txt ke Project Knowledge. WhatsApp: belum ada WA Connector, jadi selalu generate lalu copy-paste manual. Email: dasarnya sama, tapi kalau mau, aktifkan Gmail Connector (gratis, 60 detik) — Claude langsung membuat draft di inbox-mu. Belum connect? Copy-paste manual tetap jalan sempurna.</a:t>
             </a:r>
             <a:endParaRPr lang="en-US" sz="1200" dirty="0"/>
           </a:p>
@@ -3426,7 +3426,7 @@
                 <a:ea typeface="Helvetica" pitchFamily="34" charset="-122"/>
                 <a:cs typeface="Helvetica" pitchFamily="34" charset="-120"/>
               </a:rPr>
-              <a:t>Kenapa berhasil: dengan Projects aktif, 1 kalimat instruksi sudah cukup — konteks bisnis sudah tersimpan.</a:t>
+              <a:t>Kenapa berhasil: dengan Projects aktif, 1 kalimat instruksi sudah cukup. Hasilnya kamu copy-paste manual ke WhatsApp (belum ada WA Connector).</a:t>
             </a:r>
             <a:endParaRPr lang="en-US" sz="1050" dirty="0"/>
           </a:p>
@@ -3499,7 +3499,7 @@
                 <a:ea typeface="Helvetica" pitchFamily="34" charset="-122"/>
                 <a:cs typeface="Helvetica" pitchFamily="34" charset="-120"/>
               </a:rPr>
-              <a:t>EMAIL — VIA GMAIL CONNECTOR</a:t>
+              <a:t>EMAIL — GMAIL CONNECTOR OPSIONAL</a:t>
             </a:r>
             <a:endParaRPr lang="en-US" sz="1150" dirty="0"/>
           </a:p>
@@ -3583,7 +3583,7 @@
                 <a:ea typeface="Helvetica" pitchFamily="34" charset="-122"/>
                 <a:cs typeface="Helvetica" pitchFamily="34" charset="-120"/>
               </a:rPr>
-              <a:t>Kenapa berhasil: Project sudah tahu tone &amp; pengirim, tinggal ganti detail promo — plus Gmail Connector = draft langsung di inbox.</a:t>
+              <a:t>Kenapa berhasil: Project sudah tahu tone &amp; pengirim. Ada Gmail Connector? Langsung jadi draft. Belum? Copy-paste manual — sama seperti WhatsApp.</a:t>
             </a:r>
             <a:endParaRPr lang="en-US" sz="1050" dirty="0"/>
           </a:p>
@@ -3976,7 +3976,7 @@
                 <a:ea typeface="Helvetica" pitchFamily="34" charset="-122"/>
                 <a:cs typeface="Helvetica" pitchFamily="34" charset="-120"/>
               </a:rPr>
-              <a:t>Tambahkan brand voice CS ke Project Modul 1, upload cm-template-wa.txt ke Project Knowledge, pilih skenario</a:t>
+              <a:t>Tambahkan brand voice CS ke Project Modul 1, lalu upload cm-template-wa.txt ke Project Knowledge</a:t>
             </a:r>
             <a:endParaRPr lang="en-US" sz="1100" dirty="0"/>
           </a:p>
@@ -4084,7 +4084,7 @@
                 <a:ea typeface="Helvetica" pitchFamily="34" charset="-122"/>
                 <a:cs typeface="Helvetica" pitchFamily="34" charset="-120"/>
               </a:rPr>
-              <a:t>Generate template untuk tiap skenario — Claude sudah tahu konteks bisnis</a:t>
+              <a:t>Generate 10 template dasar sekali di awal — Claude sudah tahu konteks bisnis</a:t>
             </a:r>
             <a:endParaRPr lang="en-US" sz="1100" dirty="0"/>
           </a:p>
@@ -4192,7 +4192,7 @@
                 <a:ea typeface="Helvetica" pitchFamily="34" charset="-122"/>
                 <a:cs typeface="Helvetica" pitchFamily="34" charset="-120"/>
               </a:rPr>
-              <a:t>Test tiap template, simpan 10 final di catatan WA atau Google Keep</a:t>
+              <a:t>Pas ada pembeli chat: ketik situasinya ke Claude — otomatis cocok ke skenario, generate balasan siap pakai</a:t>
             </a:r>
             <a:endParaRPr lang="en-US" sz="1100" dirty="0"/>
           </a:p>
@@ -4339,7 +4339,7 @@
                 <a:ea typeface="Helvetica" pitchFamily="34" charset="-122"/>
                 <a:cs typeface="Helvetica" pitchFamily="34" charset="-120"/>
               </a:rPr>
-              <a:t>Setup Gmail Connector — izinkan akses "read" dan "draft" (Claude tidak bisa kirim)</a:t>
+              <a:t>(Opsional) Setup Gmail Connector — atau lewati, nanti copy-paste manual</a:t>
             </a:r>
             <a:endParaRPr lang="en-US" sz="1100" dirty="0"/>
           </a:p>
@@ -4678,7 +4678,7 @@
         <p:spPr>
           <a:xfrm>
             <a:off x="502920" y="5495544"/>
-            <a:ext cx="11064240" cy="777240"/>
+            <a:ext cx="11064240" cy="960120"/>
           </a:xfrm>
           <a:prstGeom prst="roundRect">
             <a:avLst>
@@ -4712,7 +4712,7 @@
         <p:spPr>
           <a:xfrm>
             <a:off x="713232" y="5495544"/>
-            <a:ext cx="10643616" cy="777240"/>
+            <a:ext cx="10643616" cy="960120"/>
           </a:xfrm>
           <a:prstGeom prst="rect">
             <a:avLst/>
@@ -4739,7 +4739,7 @@
                 <a:ea typeface="Helvetica" pitchFamily="34" charset="-122"/>
                 <a:cs typeface="Helvetica" pitchFamily="34" charset="-120"/>
               </a:rPr>
-              <a:t>◆  KENAPA EMAIL 1 LANGKAH LEBIH PANJANG?  </a:t>
+              <a:t>◆  KENAPA WA SELALU MANUAL, EMAIL BISA OTOMATIS?  </a:t>
             </a:r>
             <a:r>
               <a:rPr lang="en-US" sz="1200" dirty="0">
@@ -4750,9 +4750,122 @@
                 <a:ea typeface="Helvetica" pitchFamily="34" charset="-122"/>
                 <a:cs typeface="Helvetica" pitchFamily="34" charset="-120"/>
               </a:rPr>
-              <a:t>Email butuh setup Gmail Connector sekali di awal — WA langsung jalan dari Claude Projects.</a:t>
+              <a:t>Belum ada WA Connector, jadi WA selalu copy-paste. Gmail Connector (opsional) bikin Email langsung jadi draft.</a:t>
             </a:r>
             <a:endParaRPr lang="en-US" sz="1200" dirty="0"/>
+          </a:p>
+        </p:txBody>
+      </p:sp>
+      <p:sp>
+        <p:nvSpPr>
+          <p:cNvPr id="33" name="Oval 32"/>
+          <p:cNvSpPr/>
+          <p:nvPr/>
+        </p:nvSpPr>
+        <p:spPr>
+          <a:xfrm>
+            <a:off x="502920" y="4645152"/>
+            <a:ext cx="292608" cy="292608"/>
+          </a:xfrm>
+          <a:prstGeom prst="ellipse">
+            <a:avLst/>
+          </a:prstGeom>
+          <a:solidFill>
+            <a:srgbClr val="1A7A44"/>
+          </a:solidFill>
+          <a:ln>
+            <a:noFill/>
+          </a:ln>
+          <a:effectLst/>
+        </p:spPr>
+        <p:style>
+          <a:lnRef idx="1">
+            <a:schemeClr val="accent1"/>
+          </a:lnRef>
+          <a:fillRef idx="3">
+            <a:schemeClr val="accent1"/>
+          </a:fillRef>
+          <a:effectRef idx="2">
+            <a:schemeClr val="accent1"/>
+          </a:effectRef>
+          <a:fontRef idx="minor">
+            <a:schemeClr val="lt1"/>
+          </a:fontRef>
+        </p:style>
+        <p:txBody>
+          <a:bodyPr rtlCol="0" anchor="ctr"/>
+          <a:lstStyle/>
+          <a:p>
+            <a:pPr algn="ctr"/>
+          </a:p>
+        </p:txBody>
+      </p:sp>
+      <p:sp>
+        <p:nvSpPr>
+          <p:cNvPr id="34" name="TextBox 33"/>
+          <p:cNvSpPr txBox="1"/>
+          <p:nvPr/>
+        </p:nvSpPr>
+        <p:spPr>
+          <a:xfrm>
+            <a:off x="502920" y="4645152"/>
+            <a:ext cx="292608" cy="292608"/>
+          </a:xfrm>
+          <a:prstGeom prst="rect">
+            <a:avLst/>
+          </a:prstGeom>
+          <a:noFill/>
+        </p:spPr>
+        <p:txBody>
+          <a:bodyPr wrap="none" anchor="ctr" lIns="0" rIns="0" tIns="0" bIns="0">
+            <a:spAutoFit/>
+          </a:bodyPr>
+          <a:lstStyle/>
+          <a:p>
+            <a:pPr algn="ctr"/>
+            <a:r>
+              <a:rPr sz="1150" b="1">
+                <a:solidFill>
+                  <a:srgbClr val="FFFFFF"/>
+                </a:solidFill>
+                <a:latin typeface="Helvetica"/>
+              </a:rPr>
+              <a:t>4</a:t>
+            </a:r>
+          </a:p>
+        </p:txBody>
+      </p:sp>
+      <p:sp>
+        <p:nvSpPr>
+          <p:cNvPr id="35" name="TextBox 34"/>
+          <p:cNvSpPr txBox="1"/>
+          <p:nvPr/>
+        </p:nvSpPr>
+        <p:spPr>
+          <a:xfrm>
+            <a:off x="905256" y="4526280"/>
+            <a:ext cx="4764024" cy="594360"/>
+          </a:xfrm>
+          <a:prstGeom prst="rect">
+            <a:avLst/>
+          </a:prstGeom>
+          <a:noFill/>
+        </p:spPr>
+        <p:txBody>
+          <a:bodyPr wrap="square" lIns="0" rIns="0" tIns="0" bIns="0">
+            <a:spAutoFit/>
+          </a:bodyPr>
+          <a:lstStyle/>
+          <a:p>
+            <a:r>
+              <a:rPr sz="1100">
+                <a:solidFill>
+                  <a:srgbClr val="23283A"/>
+                </a:solidFill>
+                <a:latin typeface="Helvetica"/>
+              </a:rPr>
+              <a:t>Copy-paste balasan ke WhatsApp. Simpan 10 template dasar di catatan WA/Google Keep sebagai referensi cepat</a:t>
+            </a:r>
           </a:p>
         </p:txBody>
       </p:sp>
@@ -5946,8 +6059,8 @@
         </p:nvSpPr>
         <p:spPr>
           <a:xfrm>
-            <a:off x="502920" y="2084832"/>
-            <a:ext cx="11064240" cy="1965960"/>
+            <a:off x="502920" y="2084831"/>
+            <a:ext cx="11064240" cy="3246120"/>
           </a:xfrm>
           <a:prstGeom prst="roundRect">
             <a:avLst>
@@ -6020,7 +6133,7 @@
         <p:spPr>
           <a:xfrm>
             <a:off x="713232" y="2542032"/>
-            <a:ext cx="10607040" cy="685800"/>
+            <a:ext cx="10607040" cy="731520"/>
           </a:xfrm>
           <a:prstGeom prst="rect">
             <a:avLst/>
@@ -6047,7 +6160,7 @@
                 <a:ea typeface="Helvetica" pitchFamily="34" charset="-122"/>
                 <a:cs typeface="Helvetica" pitchFamily="34" charset="-120"/>
               </a:rPr>
-              <a:t>Pastikan cm-template-wa.txt dan cm-template-email.txt sudah diupload ke Project Knowledge dari Project Modul 1. Jalankan prompt ini untuk generate template WA (gunakan minimal 5 kali dalam 1 minggu) dan 2 draft email. Kirim ke minimal 10 kontak, catat open rate dan respons.</a:t>
+              <a:t>Upload kedua file sekarang (bukan di Modul 1) ke Project yang sama dari Modul 1. Prompt 1: generate 10 template dasar sekali. Prompt 2: ketik situasi nyata ke Claude, otomatis cocok skenario. WA copy-paste, Email ke 10 kontak.</a:t>
             </a:r>
             <a:endParaRPr lang="en-US" sz="1200" dirty="0"/>
           </a:p>
@@ -6061,8 +6174,8 @@
         </p:nvSpPr>
         <p:spPr>
           <a:xfrm>
-            <a:off x="713232" y="3310128"/>
-            <a:ext cx="10607040" cy="685800"/>
+            <a:off x="713232" y="3584448"/>
+            <a:ext cx="10607040" cy="713232"/>
           </a:xfrm>
           <a:prstGeom prst="roundRect">
             <a:avLst>
@@ -6095,8 +6208,8 @@
         </p:nvSpPr>
         <p:spPr>
           <a:xfrm>
-            <a:off x="868680" y="3310128"/>
-            <a:ext cx="10296144" cy="685800"/>
+            <a:off x="868680" y="3584448"/>
+            <a:ext cx="10296144" cy="713232"/>
           </a:xfrm>
           <a:prstGeom prst="rect">
             <a:avLst/>
@@ -6137,8 +6250,8 @@
         </p:nvSpPr>
         <p:spPr>
           <a:xfrm>
-            <a:off x="502920" y="4325112"/>
-            <a:ext cx="11064240" cy="1417320"/>
+            <a:off x="502920" y="5394960"/>
+            <a:ext cx="11064240" cy="1234440"/>
           </a:xfrm>
           <a:prstGeom prst="roundRect">
             <a:avLst>
@@ -6166,7 +6279,7 @@
         </p:nvSpPr>
         <p:spPr>
           <a:xfrm>
-            <a:off x="713232" y="4489704"/>
+            <a:off x="713232" y="5559552"/>
             <a:ext cx="10607040" cy="274320"/>
           </a:xfrm>
           <a:prstGeom prst="rect">
@@ -6205,7 +6318,7 @@
         </p:nvSpPr>
         <p:spPr>
           <a:xfrm>
-            <a:off x="713232" y="4782312"/>
+            <a:off x="713232" y="5852160"/>
             <a:ext cx="10607040" cy="914400"/>
           </a:xfrm>
           <a:prstGeom prst="rect">
@@ -6233,7 +6346,7 @@
                 <a:ea typeface="Helvetica" pitchFamily="34" charset="-122"/>
                 <a:cs typeface="Helvetica" pitchFamily="34" charset="-120"/>
               </a:rPr>
-              <a:t>10 template WhatsApp on-brand siap pakai + 2 email bisnis siap kirim (launch + promo) tersimpan sebagai draft Gmail. 1 Claude Project aktif yang bisa generate konten baru untuk kedua kanal kapanpun.</a:t>
+              <a:t>10 template WhatsApp dasar + 2 email bisnis siap kirim (launch + promo) tersimpan sebagai draft Gmail. 1 Claude Project aktif yang generate balasan personal on-the-spot untuk kasus baru kapanpun.</a:t>
             </a:r>
             <a:endParaRPr lang="en-US" sz="1200" dirty="0"/>
           </a:p>
@@ -6256,6 +6369,131 @@
               <a:t>File pendukung: cm-template-wa.txt, cm-template-email.txt</a:t>
             </a:r>
             <a:endParaRPr lang="en-US" sz="1200" dirty="0"/>
+          </a:p>
+        </p:txBody>
+      </p:sp>
+      <p:sp>
+        <p:nvSpPr>
+          <p:cNvPr id="16" name="TextBox 15"/>
+          <p:cNvSpPr txBox="1"/>
+          <p:nvPr/>
+        </p:nvSpPr>
+        <p:spPr>
+          <a:xfrm>
+            <a:off x="713232" y="3346704"/>
+            <a:ext cx="10607040" cy="201168"/>
+          </a:xfrm>
+          <a:prstGeom prst="rect">
+            <a:avLst/>
+          </a:prstGeom>
+          <a:noFill/>
+        </p:spPr>
+        <p:txBody>
+          <a:bodyPr wrap="none" lIns="0" rIns="0" tIns="0" bIns="0">
+            <a:spAutoFit/>
+          </a:bodyPr>
+          <a:lstStyle/>
+          <a:p>
+            <a:r>
+              <a:rPr sz="1000" b="1">
+                <a:solidFill>
+                  <a:srgbClr val="1A7A44"/>
+                </a:solidFill>
+                <a:latin typeface="Helvetica"/>
+              </a:rPr>
+              <a:t>PROMPT 1 — GENERATE TEMPLATE DASAR (SEKALI DI AWAL)</a:t>
+            </a:r>
+          </a:p>
+        </p:txBody>
+      </p:sp>
+      <p:sp>
+        <p:nvSpPr>
+          <p:cNvPr id="17" name="TextBox 16"/>
+          <p:cNvSpPr txBox="1"/>
+          <p:nvPr/>
+        </p:nvSpPr>
+        <p:spPr>
+          <a:xfrm>
+            <a:off x="713232" y="4389120"/>
+            <a:ext cx="10607040" cy="201168"/>
+          </a:xfrm>
+          <a:prstGeom prst="rect">
+            <a:avLst/>
+          </a:prstGeom>
+          <a:noFill/>
+        </p:spPr>
+        <p:txBody>
+          <a:bodyPr wrap="none" lIns="0" rIns="0" tIns="0" bIns="0">
+            <a:spAutoFit/>
+          </a:bodyPr>
+          <a:lstStyle/>
+          <a:p>
+            <a:r>
+              <a:rPr sz="1000" b="1">
+                <a:solidFill>
+                  <a:srgbClr val="1A7A44"/>
+                </a:solidFill>
+                <a:latin typeface="Helvetica"/>
+              </a:rPr>
+              <a:t>PROMPT 2 — PAKAI UNTUK KASUS NYATA (DIULANG TIAP SITUASI BARU)</a:t>
+            </a:r>
+          </a:p>
+        </p:txBody>
+      </p:sp>
+      <p:sp>
+        <p:nvSpPr>
+          <p:cNvPr id="18" name="Rounded Rectangle 17"/>
+          <p:cNvSpPr/>
+          <p:nvPr/>
+        </p:nvSpPr>
+        <p:spPr>
+          <a:xfrm>
+            <a:off x="713232" y="4608576"/>
+            <a:ext cx="10607040" cy="566928"/>
+          </a:xfrm>
+          <a:prstGeom prst="roundRect">
+            <a:avLst>
+              <a:gd name="adj" fmla="val 10667"/>
+            </a:avLst>
+          </a:prstGeom>
+          <a:solidFill>
+            <a:srgbClr val="FFFFFF"/>
+          </a:solidFill>
+          <a:ln w="12700">
+            <a:solidFill>
+              <a:srgbClr val="B8E6C9"/>
+            </a:solidFill>
+          </a:ln>
+          <a:effectLst/>
+        </p:spPr>
+        <p:style>
+          <a:lnRef idx="1">
+            <a:schemeClr val="accent1"/>
+          </a:lnRef>
+          <a:fillRef idx="3">
+            <a:schemeClr val="accent1"/>
+          </a:fillRef>
+          <a:effectRef idx="2">
+            <a:schemeClr val="accent1"/>
+          </a:effectRef>
+          <a:fontRef idx="minor">
+            <a:schemeClr val="lt1"/>
+          </a:fontRef>
+        </p:style>
+        <p:txBody>
+          <a:bodyPr rtlCol="0" anchor="ctr" lIns="155448" rIns="155448" tIns="73152" bIns="73152" wrap="square"/>
+          <a:lstStyle/>
+          <a:p>
+            <a:pPr algn="ctr"/>
+            <a:r>
+              <a:rPr sz="950" i="1">
+                <a:solidFill>
+                  <a:srgbClr val="1A7A44"/>
+                </a:solidFill>
+                <a:latin typeface="Helvetica"/>
+              </a:rPr>
+              <a:t>"Balas WA: pembeli nanya kenapa pesanannya belum dikirim padahal sudah pesan dari 2 hari lalu, nadanya agak kesal."</a:t>
+            </a:r>
           </a:p>
         </p:txBody>
       </p:sp>

</xml_diff>

<commit_message>
M05: fix Hari 1-5 sequence across modules, drop 'per Kanal' from PPTX titles, split Latihan into 3 explicit exercises (setup brand voice / generate templates / reuse for real cases) each with its own goal and output
</commit_message>
<xml_diff>
--- a/Content-Marketing/M05-Komunikasi-Pelanggan/K3-M05-Komunikasi-Pelanggan.pptx
+++ b/Content-Marketing/M05-Komunikasi-Pelanggan/K3-M05-Komunikasi-Pelanggan.pptx
@@ -15,6 +15,7 @@
     <p:sldId id="260" r:id="rId6"/>
     <p:sldId id="261" r:id="rId7"/>
     <p:sldId id="262" r:id="rId8"/>
+    <p:sldId id="263" r:id="rId14"/>
   </p:sldIdLst>
   <p:sldSz cx="12192000" cy="6858000"/>
   <p:notesSz cx="6858000" cy="12192000"/>
@@ -3269,7 +3270,7 @@
                 <a:ea typeface="Helvetica" pitchFamily="34" charset="-122"/>
                 <a:cs typeface="Helvetica" pitchFamily="34" charset="-120"/>
               </a:rPr>
-              <a:t>Prompt Siap Pakai per Kanal</a:t>
+              <a:t>Prompt Siap Pakai</a:t>
             </a:r>
             <a:endParaRPr lang="en-US" sz="2200" dirty="0"/>
           </a:p>
@@ -3829,7 +3830,7 @@
                 <a:ea typeface="Helvetica" pitchFamily="34" charset="-122"/>
                 <a:cs typeface="Helvetica" pitchFamily="34" charset="-120"/>
               </a:rPr>
-              <a:t>Cara Kerja per Kanal</a:t>
+              <a:t>Cara Kerja</a:t>
             </a:r>
             <a:endParaRPr lang="en-US" sz="2200" dirty="0"/>
           </a:p>
@@ -4311,7 +4312,7 @@
         </p:nvSpPr>
         <p:spPr>
           <a:xfrm>
-            <a:off x="6574536" y="2407320"/>
+            <a:off x="6574536" y="2343256"/>
             <a:ext cx="4764024" cy="594360"/>
           </a:xfrm>
           <a:prstGeom prst="rect">
@@ -4527,7 +4528,7 @@
         </p:nvSpPr>
         <p:spPr>
           <a:xfrm>
-            <a:off x="6574536" y="3833784"/>
+            <a:off x="6574536" y="3810488"/>
             <a:ext cx="4764024" cy="594360"/>
           </a:xfrm>
           <a:prstGeom prst="rect">
@@ -4635,7 +4636,7 @@
         </p:nvSpPr>
         <p:spPr>
           <a:xfrm>
-            <a:off x="6574536" y="4547016"/>
+            <a:off x="6574536" y="4482952"/>
             <a:ext cx="4764024" cy="594360"/>
           </a:xfrm>
           <a:prstGeom prst="rect">
@@ -4797,6 +4798,7 @@
           <a:lstStyle/>
           <a:p>
             <a:pPr algn="ctr"/>
+            <a:endParaRPr/>
           </a:p>
         </p:txBody>
       </p:sp>
@@ -4817,7 +4819,7 @@
           <a:noFill/>
         </p:spPr>
         <p:txBody>
-          <a:bodyPr wrap="none" anchor="ctr" lIns="0" rIns="0" tIns="0" bIns="0">
+          <a:bodyPr wrap="none" lIns="0" tIns="0" rIns="0" bIns="0" anchor="ctr">
             <a:spAutoFit/>
           </a:bodyPr>
           <a:lstStyle/>
@@ -4843,16 +4845,16 @@
         </p:nvSpPr>
         <p:spPr>
           <a:xfrm>
-            <a:off x="905256" y="4526280"/>
-            <a:ext cx="4764024" cy="594360"/>
-          </a:xfrm>
-          <a:prstGeom prst="rect">
-            <a:avLst/>
-          </a:prstGeom>
-          <a:noFill/>
-        </p:spPr>
-        <p:txBody>
-          <a:bodyPr wrap="square" lIns="0" rIns="0" tIns="0" bIns="0">
+            <a:off x="905256" y="4654183"/>
+            <a:ext cx="4764024" cy="338554"/>
+          </a:xfrm>
+          <a:prstGeom prst="rect">
+            <a:avLst/>
+          </a:prstGeom>
+          <a:noFill/>
+        </p:spPr>
+        <p:txBody>
+          <a:bodyPr wrap="square" lIns="0" tIns="0" rIns="0" bIns="0" anchor="ctr">
             <a:spAutoFit/>
           </a:bodyPr>
           <a:lstStyle/>
@@ -6006,7 +6008,7 @@
                 <a:ea typeface="Helvetica" pitchFamily="34" charset="-122"/>
                 <a:cs typeface="Helvetica" pitchFamily="34" charset="-120"/>
               </a:rPr>
-              <a:t>DARI LATIHAN KE KOMUNIKASI SIAP KIRIM</a:t>
+              <a:t>TIGA LATIHAN, TIGA OUTPUT JELAS</a:t>
             </a:r>
             <a:endParaRPr lang="en-US" sz="1250" dirty="0"/>
           </a:p>
@@ -6045,7 +6047,7 @@
                 <a:ea typeface="Helvetica" pitchFamily="34" charset="-122"/>
                 <a:cs typeface="Helvetica" pitchFamily="34" charset="-120"/>
               </a:rPr>
-              <a:t>Latihan &amp; Output yang Diharapkan</a:t>
+              <a:t>Latihan 1 &amp; 2: Setup Brand Voice + Generate Template</a:t>
             </a:r>
             <a:endParaRPr lang="en-US" sz="2200" dirty="0"/>
           </a:p>
@@ -6060,7 +6062,7 @@
         <p:spPr>
           <a:xfrm>
             <a:off x="502920" y="2084831"/>
-            <a:ext cx="11064240" cy="3246120"/>
+            <a:ext cx="11064240" cy="1691640"/>
           </a:xfrm>
           <a:prstGeom prst="roundRect">
             <a:avLst>
@@ -6118,7 +6120,7 @@
                 <a:ea typeface="Helvetica" pitchFamily="34" charset="-122"/>
                 <a:cs typeface="Helvetica" pitchFamily="34" charset="-120"/>
               </a:rPr>
-              <a:t>■  LATIHAN</a:t>
+              <a:t>■  LATIHAN 1 — SETUP BRAND VOICE CS</a:t>
             </a:r>
             <a:endParaRPr lang="en-US" sz="1300" dirty="0"/>
           </a:p>
@@ -6133,7 +6135,7 @@
         <p:spPr>
           <a:xfrm>
             <a:off x="713232" y="2542032"/>
-            <a:ext cx="10607040" cy="731520"/>
+            <a:ext cx="10607040" cy="411480"/>
           </a:xfrm>
           <a:prstGeom prst="rect">
             <a:avLst/>
@@ -6160,7 +6162,7 @@
                 <a:ea typeface="Helvetica" pitchFamily="34" charset="-122"/>
                 <a:cs typeface="Helvetica" pitchFamily="34" charset="-120"/>
               </a:rPr>
-              <a:t>Upload kedua file sekarang (bukan di Modul 1) ke Project yang sama dari Modul 1. Prompt 1: generate 10 template dasar sekali. Prompt 2: ketik situasi nyata ke Claude, otomatis cocok skenario. WA copy-paste, Email ke 10 kontak.</a:t>
+              <a:t>Buka Project yang sama dari Modul 1 → Project Instructions → tambahkan teks di bawah, jangan hapus positioning yang sudah ada.</a:t>
             </a:r>
             <a:endParaRPr lang="en-US" sz="1200" dirty="0"/>
           </a:p>
@@ -6174,8 +6176,8 @@
         </p:nvSpPr>
         <p:spPr>
           <a:xfrm>
-            <a:off x="713232" y="3584448"/>
-            <a:ext cx="10607040" cy="713232"/>
+            <a:off x="713232" y="2999232"/>
+            <a:ext cx="10607040" cy="502920"/>
           </a:xfrm>
           <a:prstGeom prst="roundRect">
             <a:avLst>
@@ -6208,8 +6210,8 @@
         </p:nvSpPr>
         <p:spPr>
           <a:xfrm>
-            <a:off x="868680" y="3584448"/>
-            <a:ext cx="10296144" cy="713232"/>
+            <a:off x="868680" y="2999232"/>
+            <a:ext cx="10296144" cy="502920"/>
           </a:xfrm>
           <a:prstGeom prst="rect">
             <a:avLst/>
@@ -6236,7 +6238,7 @@
                 <a:ea typeface="Helvetica" pitchFamily="34" charset="-122"/>
                 <a:cs typeface="Helvetica" pitchFamily="34" charset="-120"/>
               </a:rPr>
-              <a:t>Tambahkan brand voice: tone santai-hangat, sapaan "Kak", batasan emoji 1-2 per pesan, nama pengirim &amp; jabatan untuk email. Lalu buatkan 10 template WhatsApp untuk skenario di cm-template-wa.txt, dan 2 draft email (launch produk baru + flash sale) dari cm-template-email.txt — simpan sebagai draft di Gmail saya.</a:t>
+              <a:t>Brand voice untuk komunikasi pelanggan: tone santai-hangat, sapaan "Kak", batasan emoji 1-2/pesan. Email: nama pengirim [nama], jabatan [Owner/dst].</a:t>
             </a:r>
             <a:endParaRPr lang="en-US" sz="950" dirty="0"/>
           </a:p>
@@ -6244,220 +6246,56 @@
       </p:sp>
       <p:sp>
         <p:nvSpPr>
-          <p:cNvPr id="13" name="Shape 11"/>
-          <p:cNvSpPr/>
-          <p:nvPr/>
-        </p:nvSpPr>
-        <p:spPr>
-          <a:xfrm>
-            <a:off x="502920" y="5394960"/>
-            <a:ext cx="11064240" cy="1234440"/>
+          <p:cNvPr id="19" name="TextBox 18"/>
+          <p:cNvSpPr txBox="1"/>
+          <p:nvPr/>
+        </p:nvSpPr>
+        <p:spPr>
+          <a:xfrm>
+            <a:off x="713232" y="3566160"/>
+            <a:ext cx="10607040" cy="274320"/>
+          </a:xfrm>
+          <a:prstGeom prst="rect">
+            <a:avLst/>
+          </a:prstGeom>
+          <a:noFill/>
+        </p:spPr>
+        <p:txBody>
+          <a:bodyPr wrap="square" lIns="0" rIns="0" tIns="0" bIns="0">
+            <a:spAutoFit/>
+          </a:bodyPr>
+          <a:lstStyle/>
+          <a:p>
+            <a:r>
+              <a:rPr sz="1000" b="1">
+                <a:solidFill>
+                  <a:srgbClr val="1A7A44"/>
+                </a:solidFill>
+                <a:latin typeface="Helvetica"/>
+              </a:rPr>
+              <a:t>✅ Output: Project Instructions ter-update — dipakai otomatis di semua chat berikutnya</a:t>
+            </a:r>
+          </a:p>
+        </p:txBody>
+      </p:sp>
+      <p:sp>
+        <p:nvSpPr>
+          <p:cNvPr id="20" name="Rounded Rectangle 19"/>
+          <p:cNvSpPr/>
+          <p:nvPr/>
+        </p:nvSpPr>
+        <p:spPr>
+          <a:xfrm>
+            <a:off x="502920" y="3913632"/>
+            <a:ext cx="11064240" cy="2606040"/>
           </a:xfrm>
           <a:prstGeom prst="roundRect">
             <a:avLst>
-              <a:gd name="adj" fmla="val 7742"/>
+              <a:gd name="adj" fmla="val 6000"/>
             </a:avLst>
           </a:prstGeom>
           <a:solidFill>
-            <a:srgbClr val="141D33"/>
-          </a:solidFill>
-          <a:ln/>
-        </p:spPr>
-        <p:txBody>
-          <a:bodyPr/>
-          <a:lstStyle/>
-          <a:p>
-            <a:endParaRPr lang="en-ID"/>
-          </a:p>
-        </p:txBody>
-      </p:sp>
-      <p:sp>
-        <p:nvSpPr>
-          <p:cNvPr id="14" name="Text 12"/>
-          <p:cNvSpPr/>
-          <p:nvPr/>
-        </p:nvSpPr>
-        <p:spPr>
-          <a:xfrm>
-            <a:off x="713232" y="5559552"/>
-            <a:ext cx="10607040" cy="274320"/>
-          </a:xfrm>
-          <a:prstGeom prst="rect">
-            <a:avLst/>
-          </a:prstGeom>
-          <a:noFill/>
-          <a:ln/>
-        </p:spPr>
-        <p:txBody>
-          <a:bodyPr wrap="square" lIns="0" tIns="0" rIns="0" bIns="0" rtlCol="0" anchor="ctr"/>
-          <a:lstStyle/>
-          <a:p>
-            <a:pPr marL="0" indent="0">
-              <a:buNone/>
-            </a:pPr>
-            <a:r>
-              <a:rPr lang="en-US" sz="1300" b="1" dirty="0">
-                <a:solidFill>
-                  <a:srgbClr val="8B7CF6"/>
-                </a:solidFill>
-                <a:latin typeface="Helvetica" pitchFamily="34" charset="0"/>
-                <a:ea typeface="Helvetica" pitchFamily="34" charset="-122"/>
-                <a:cs typeface="Helvetica" pitchFamily="34" charset="-120"/>
-              </a:rPr>
-              <a:t>OUTPUT YANG DIHARAPKAN</a:t>
-            </a:r>
-            <a:endParaRPr lang="en-US" sz="1300" dirty="0"/>
-          </a:p>
-        </p:txBody>
-      </p:sp>
-      <p:sp>
-        <p:nvSpPr>
-          <p:cNvPr id="15" name="Text 13"/>
-          <p:cNvSpPr/>
-          <p:nvPr/>
-        </p:nvSpPr>
-        <p:spPr>
-          <a:xfrm>
-            <a:off x="713232" y="5852160"/>
-            <a:ext cx="10607040" cy="914400"/>
-          </a:xfrm>
-          <a:prstGeom prst="rect">
-            <a:avLst/>
-          </a:prstGeom>
-          <a:noFill/>
-          <a:ln/>
-        </p:spPr>
-        <p:txBody>
-          <a:bodyPr wrap="square" lIns="0" tIns="0" rIns="0" bIns="0" rtlCol="0" anchor="ctr"/>
-          <a:lstStyle/>
-          <a:p>
-            <a:pPr marL="0" indent="0">
-              <a:lnSpc>
-                <a:spcPct val="130000"/>
-              </a:lnSpc>
-              <a:buNone/>
-            </a:pPr>
-            <a:r>
-              <a:rPr lang="en-US" sz="1200" dirty="0">
-                <a:solidFill>
-                  <a:srgbClr val="B7C0D8"/>
-                </a:solidFill>
-                <a:latin typeface="Helvetica" pitchFamily="34" charset="0"/>
-                <a:ea typeface="Helvetica" pitchFamily="34" charset="-122"/>
-                <a:cs typeface="Helvetica" pitchFamily="34" charset="-120"/>
-              </a:rPr>
-              <a:t>10 template WhatsApp dasar + 2 email bisnis siap kirim (launch + promo) tersimpan sebagai draft Gmail. 1 Claude Project aktif yang generate balasan personal on-the-spot untuk kasus baru kapanpun.</a:t>
-            </a:r>
-            <a:endParaRPr lang="en-US" sz="1200" dirty="0"/>
-          </a:p>
-          <a:p>
-            <a:pPr marL="0" indent="0">
-              <a:lnSpc>
-                <a:spcPct val="130000"/>
-              </a:lnSpc>
-              <a:buNone/>
-            </a:pPr>
-            <a:r>
-              <a:rPr lang="en-US" sz="1200" dirty="0">
-                <a:solidFill>
-                  <a:srgbClr val="B7C0D8"/>
-                </a:solidFill>
-                <a:latin typeface="Helvetica" pitchFamily="34" charset="0"/>
-                <a:ea typeface="Helvetica" pitchFamily="34" charset="-122"/>
-                <a:cs typeface="Helvetica" pitchFamily="34" charset="-120"/>
-              </a:rPr>
-              <a:t>File pendukung: cm-template-wa.txt, cm-template-email.txt</a:t>
-            </a:r>
-            <a:endParaRPr lang="en-US" sz="1200" dirty="0"/>
-          </a:p>
-        </p:txBody>
-      </p:sp>
-      <p:sp>
-        <p:nvSpPr>
-          <p:cNvPr id="16" name="TextBox 15"/>
-          <p:cNvSpPr txBox="1"/>
-          <p:nvPr/>
-        </p:nvSpPr>
-        <p:spPr>
-          <a:xfrm>
-            <a:off x="713232" y="3346704"/>
-            <a:ext cx="10607040" cy="201168"/>
-          </a:xfrm>
-          <a:prstGeom prst="rect">
-            <a:avLst/>
-          </a:prstGeom>
-          <a:noFill/>
-        </p:spPr>
-        <p:txBody>
-          <a:bodyPr wrap="none" lIns="0" rIns="0" tIns="0" bIns="0">
-            <a:spAutoFit/>
-          </a:bodyPr>
-          <a:lstStyle/>
-          <a:p>
-            <a:r>
-              <a:rPr sz="1000" b="1">
-                <a:solidFill>
-                  <a:srgbClr val="1A7A44"/>
-                </a:solidFill>
-                <a:latin typeface="Helvetica"/>
-              </a:rPr>
-              <a:t>PROMPT 1 — GENERATE TEMPLATE DASAR (SEKALI DI AWAL)</a:t>
-            </a:r>
-          </a:p>
-        </p:txBody>
-      </p:sp>
-      <p:sp>
-        <p:nvSpPr>
-          <p:cNvPr id="17" name="TextBox 16"/>
-          <p:cNvSpPr txBox="1"/>
-          <p:nvPr/>
-        </p:nvSpPr>
-        <p:spPr>
-          <a:xfrm>
-            <a:off x="713232" y="4389120"/>
-            <a:ext cx="10607040" cy="201168"/>
-          </a:xfrm>
-          <a:prstGeom prst="rect">
-            <a:avLst/>
-          </a:prstGeom>
-          <a:noFill/>
-        </p:spPr>
-        <p:txBody>
-          <a:bodyPr wrap="none" lIns="0" rIns="0" tIns="0" bIns="0">
-            <a:spAutoFit/>
-          </a:bodyPr>
-          <a:lstStyle/>
-          <a:p>
-            <a:r>
-              <a:rPr sz="1000" b="1">
-                <a:solidFill>
-                  <a:srgbClr val="1A7A44"/>
-                </a:solidFill>
-                <a:latin typeface="Helvetica"/>
-              </a:rPr>
-              <a:t>PROMPT 2 — PAKAI UNTUK KASUS NYATA (DIULANG TIAP SITUASI BARU)</a:t>
-            </a:r>
-          </a:p>
-        </p:txBody>
-      </p:sp>
-      <p:sp>
-        <p:nvSpPr>
-          <p:cNvPr id="18" name="Rounded Rectangle 17"/>
-          <p:cNvSpPr/>
-          <p:nvPr/>
-        </p:nvSpPr>
-        <p:spPr>
-          <a:xfrm>
-            <a:off x="713232" y="4608576"/>
-            <a:ext cx="10607040" cy="566928"/>
-          </a:xfrm>
-          <a:prstGeom prst="roundRect">
-            <a:avLst>
-              <a:gd name="adj" fmla="val 10667"/>
-            </a:avLst>
-          </a:prstGeom>
-          <a:solidFill>
-            <a:srgbClr val="FFFFFF"/>
+            <a:srgbClr val="EAFAF0"/>
           </a:solidFill>
           <a:ln w="12700">
             <a:solidFill>
@@ -6481,6 +6319,125 @@
           </a:fontRef>
         </p:style>
         <p:txBody>
+          <a:bodyPr rtlCol="0" anchor="ctr"/>
+          <a:lstStyle/>
+          <a:p>
+            <a:pPr algn="ctr"/>
+            <a:r>
+              <a:t/>
+            </a:r>
+          </a:p>
+        </p:txBody>
+      </p:sp>
+      <p:sp>
+        <p:nvSpPr>
+          <p:cNvPr id="21" name="TextBox 20"/>
+          <p:cNvSpPr txBox="1"/>
+          <p:nvPr/>
+        </p:nvSpPr>
+        <p:spPr>
+          <a:xfrm>
+            <a:off x="713232" y="4078224"/>
+            <a:ext cx="10607040" cy="274320"/>
+          </a:xfrm>
+          <a:prstGeom prst="rect">
+            <a:avLst/>
+          </a:prstGeom>
+          <a:noFill/>
+        </p:spPr>
+        <p:txBody>
+          <a:bodyPr wrap="none" lIns="0" rIns="0" tIns="0" bIns="0">
+            <a:spAutoFit/>
+          </a:bodyPr>
+          <a:lstStyle/>
+          <a:p>
+            <a:r>
+              <a:rPr sz="1300" b="1">
+                <a:solidFill>
+                  <a:srgbClr val="1A7A44"/>
+                </a:solidFill>
+                <a:latin typeface="Helvetica"/>
+              </a:rPr>
+              <a:t>■  LATIHAN 2 — GENERATE TEMPLATE DASAR</a:t>
+            </a:r>
+          </a:p>
+        </p:txBody>
+      </p:sp>
+      <p:sp>
+        <p:nvSpPr>
+          <p:cNvPr id="22" name="TextBox 21"/>
+          <p:cNvSpPr txBox="1"/>
+          <p:nvPr/>
+        </p:nvSpPr>
+        <p:spPr>
+          <a:xfrm>
+            <a:off x="713232" y="4370832"/>
+            <a:ext cx="10607040" cy="594360"/>
+          </a:xfrm>
+          <a:prstGeom prst="rect">
+            <a:avLst/>
+          </a:prstGeom>
+          <a:noFill/>
+        </p:spPr>
+        <p:txBody>
+          <a:bodyPr wrap="square" lIns="0" rIns="0" tIns="0" bIns="0">
+            <a:spAutoFit/>
+          </a:bodyPr>
+          <a:lstStyle/>
+          <a:p>
+            <a:r>
+              <a:rPr sz="1200">
+                <a:solidFill>
+                  <a:srgbClr val="23283A"/>
+                </a:solidFill>
+                <a:latin typeface="Helvetica"/>
+              </a:rPr>
+              <a:t>Upload cm-template-wa.txt (siap pakai) dan cm-template-email.txt ke Project Knowledge. Isi dulu bagian EMAIL 1 (Launch) &amp; EMAIL 2 (Flash Sale) — detail promo ini spesifik untuk campaign sekarang, belum ada di Project manapun.</a:t>
+            </a:r>
+          </a:p>
+        </p:txBody>
+      </p:sp>
+      <p:sp>
+        <p:nvSpPr>
+          <p:cNvPr id="23" name="Rounded Rectangle 22"/>
+          <p:cNvSpPr/>
+          <p:nvPr/>
+        </p:nvSpPr>
+        <p:spPr>
+          <a:xfrm>
+            <a:off x="713232" y="5010912"/>
+            <a:ext cx="10607040" cy="594360"/>
+          </a:xfrm>
+          <a:prstGeom prst="roundRect">
+            <a:avLst>
+              <a:gd name="adj" fmla="val 10667"/>
+            </a:avLst>
+          </a:prstGeom>
+          <a:solidFill>
+            <a:srgbClr val="FFFFFF"/>
+          </a:solidFill>
+          <a:ln w="12700">
+            <a:solidFill>
+              <a:srgbClr val="B8E6C9"/>
+            </a:solidFill>
+          </a:ln>
+          <a:effectLst/>
+        </p:spPr>
+        <p:style>
+          <a:lnRef idx="1">
+            <a:schemeClr val="accent1"/>
+          </a:lnRef>
+          <a:fillRef idx="3">
+            <a:schemeClr val="accent1"/>
+          </a:fillRef>
+          <a:effectRef idx="2">
+            <a:schemeClr val="accent1"/>
+          </a:effectRef>
+          <a:fontRef idx="minor">
+            <a:schemeClr val="lt1"/>
+          </a:fontRef>
+        </p:style>
+        <p:txBody>
           <a:bodyPr rtlCol="0" anchor="ctr" lIns="155448" rIns="155448" tIns="73152" bIns="73152" wrap="square"/>
           <a:lstStyle/>
           <a:p>
@@ -6492,7 +6449,620 @@
                 </a:solidFill>
                 <a:latin typeface="Helvetica"/>
               </a:rPr>
+              <a:t>Buatkan 10 template WhatsApp untuk skenario di cm-template-wa.txt, dan 2 draft email (launch + flash sale) dari cm-template-email.txt — simpan sebagai draft di Gmail saya.</a:t>
+            </a:r>
+          </a:p>
+        </p:txBody>
+      </p:sp>
+      <p:sp>
+        <p:nvSpPr>
+          <p:cNvPr id="24" name="TextBox 23"/>
+          <p:cNvSpPr txBox="1"/>
+          <p:nvPr/>
+        </p:nvSpPr>
+        <p:spPr>
+          <a:xfrm>
+            <a:off x="713232" y="5650992"/>
+            <a:ext cx="10607040" cy="274320"/>
+          </a:xfrm>
+          <a:prstGeom prst="rect">
+            <a:avLst/>
+          </a:prstGeom>
+          <a:noFill/>
+        </p:spPr>
+        <p:txBody>
+          <a:bodyPr wrap="square" lIns="0" rIns="0" tIns="0" bIns="0">
+            <a:spAutoFit/>
+          </a:bodyPr>
+          <a:lstStyle/>
+          <a:p>
+            <a:r>
+              <a:rPr sz="1000" b="1">
+                <a:solidFill>
+                  <a:srgbClr val="1A7A44"/>
+                </a:solidFill>
+                <a:latin typeface="Helvetica"/>
+              </a:rPr>
+              <a:t>✅ Output: 10 template WA dasar + 2 email draft tersimpan di Gmail — jadi acuan Latihan 3</a:t>
+            </a:r>
+          </a:p>
+        </p:txBody>
+      </p:sp>
+    </p:spTree>
+  </p:cSld>
+  <p:clrMapOvr>
+    <a:masterClrMapping/>
+  </p:clrMapOvr>
+</p:sld>
+</file>
+
+<file path=ppt/slides/slide8.xml><?xml version="1.0" encoding="utf-8"?>
+<p:sld xmlns:a="http://schemas.openxmlformats.org/drawingml/2006/main" xmlns:p="http://schemas.openxmlformats.org/presentationml/2006/main" xmlns:r="http://schemas.openxmlformats.org/officeDocument/2006/relationships">
+  <p:cSld>
+    <p:spTree>
+      <p:nvGrpSpPr>
+        <p:cNvPr id="1" name=""/>
+        <p:cNvGrpSpPr/>
+        <p:nvPr/>
+      </p:nvGrpSpPr>
+      <p:grpSpPr/>
+      <p:sp>
+        <p:nvSpPr>
+          <p:cNvPr id="19" name="Rounded Rectangle 18"/>
+          <p:cNvSpPr/>
+          <p:nvPr/>
+        </p:nvSpPr>
+        <p:spPr>
+          <a:xfrm>
+            <a:off x="502920" y="2084831"/>
+            <a:ext cx="11064240" cy="2377440"/>
+          </a:xfrm>
+          <a:prstGeom prst="roundRect">
+            <a:avLst>
+              <a:gd name="adj" fmla="val 6000"/>
+            </a:avLst>
+          </a:prstGeom>
+          <a:solidFill>
+            <a:srgbClr val="EAFAF0"/>
+          </a:solidFill>
+          <a:ln w="12700">
+            <a:solidFill>
+              <a:srgbClr val="B8E6C9"/>
+            </a:solidFill>
+          </a:ln>
+          <a:effectLst/>
+        </p:spPr>
+        <p:style>
+          <a:lnRef idx="1">
+            <a:schemeClr val="accent1"/>
+          </a:lnRef>
+          <a:fillRef idx="3">
+            <a:schemeClr val="accent1"/>
+          </a:fillRef>
+          <a:effectRef idx="2">
+            <a:schemeClr val="accent1"/>
+          </a:effectRef>
+          <a:fontRef idx="minor">
+            <a:schemeClr val="lt1"/>
+          </a:fontRef>
+        </p:style>
+        <p:txBody>
+          <a:bodyPr rtlCol="0" anchor="ctr"/>
+          <a:lstStyle/>
+          <a:p>
+            <a:pPr algn="ctr"/>
+            <a:r>
+              <a:t/>
+            </a:r>
+          </a:p>
+        </p:txBody>
+      </p:sp>
+      <p:sp>
+        <p:nvSpPr>
+          <p:cNvPr id="2" name="Shape 0"/>
+          <p:cNvSpPr/>
+          <p:nvPr/>
+        </p:nvSpPr>
+        <p:spPr>
+          <a:xfrm>
+            <a:off x="0" y="0"/>
+            <a:ext cx="12191695" cy="960120"/>
+          </a:xfrm>
+          <a:prstGeom prst="rect">
+            <a:avLst/>
+          </a:prstGeom>
+          <a:solidFill>
+            <a:srgbClr val="0D1321"/>
+          </a:solidFill>
+          <a:ln/>
+        </p:spPr>
+        <p:txBody>
+          <a:bodyPr/>
+          <a:lstStyle/>
+          <a:p>
+            <a:endParaRPr lang="en-ID"/>
+          </a:p>
+        </p:txBody>
+      </p:sp>
+      <p:sp>
+        <p:nvSpPr>
+          <p:cNvPr id="3" name="Shape 1"/>
+          <p:cNvSpPr/>
+          <p:nvPr/>
+        </p:nvSpPr>
+        <p:spPr>
+          <a:xfrm>
+            <a:off x="0" y="960120"/>
+            <a:ext cx="12191695" cy="41148"/>
+          </a:xfrm>
+          <a:prstGeom prst="rect">
+            <a:avLst/>
+          </a:prstGeom>
+          <a:solidFill>
+            <a:srgbClr val="6849F6"/>
+          </a:solidFill>
+          <a:ln/>
+        </p:spPr>
+        <p:txBody>
+          <a:bodyPr/>
+          <a:lstStyle/>
+          <a:p>
+            <a:endParaRPr lang="en-ID"/>
+          </a:p>
+        </p:txBody>
+      </p:sp>
+      <p:sp>
+        <p:nvSpPr>
+          <p:cNvPr id="4" name="Text 2"/>
+          <p:cNvSpPr/>
+          <p:nvPr/>
+        </p:nvSpPr>
+        <p:spPr>
+          <a:xfrm>
+            <a:off x="502920" y="256032"/>
+            <a:ext cx="3657600" cy="457200"/>
+          </a:xfrm>
+          <a:prstGeom prst="rect">
+            <a:avLst/>
+          </a:prstGeom>
+          <a:noFill/>
+          <a:ln/>
+        </p:spPr>
+        <p:txBody>
+          <a:bodyPr wrap="square" lIns="0" tIns="0" rIns="0" bIns="0" rtlCol="0" anchor="ctr"/>
+          <a:lstStyle/>
+          <a:p>
+            <a:pPr marL="0" indent="0">
+              <a:buNone/>
+            </a:pPr>
+            <a:r>
+              <a:rPr lang="en-US" sz="2000" b="1" dirty="0">
+                <a:solidFill>
+                  <a:srgbClr val="FFFFFF"/>
+                </a:solidFill>
+                <a:latin typeface="Helvetica" pitchFamily="34" charset="0"/>
+                <a:ea typeface="Helvetica" pitchFamily="34" charset="-122"/>
+                <a:cs typeface="Helvetica" pitchFamily="34" charset="-120"/>
+              </a:rPr>
+              <a:t>belajar</a:t>
+            </a:r>
+            <a:r>
+              <a:rPr lang="en-US" sz="2000" b="1" dirty="0">
+                <a:solidFill>
+                  <a:srgbClr val="8B7CF6"/>
+                </a:solidFill>
+                <a:latin typeface="Helvetica" pitchFamily="34" charset="0"/>
+                <a:ea typeface="Helvetica" pitchFamily="34" charset="-122"/>
+                <a:cs typeface="Helvetica" pitchFamily="34" charset="-120"/>
+              </a:rPr>
+              <a:t>claude</a:t>
+            </a:r>
+            <a:endParaRPr lang="en-US" sz="2000" dirty="0"/>
+          </a:p>
+        </p:txBody>
+      </p:sp>
+      <p:sp>
+        <p:nvSpPr>
+          <p:cNvPr id="5" name="Text 3"/>
+          <p:cNvSpPr/>
+          <p:nvPr/>
+        </p:nvSpPr>
+        <p:spPr>
+          <a:xfrm>
+            <a:off x="5943600" y="274320"/>
+            <a:ext cx="5760720" cy="411480"/>
+          </a:xfrm>
+          <a:prstGeom prst="rect">
+            <a:avLst/>
+          </a:prstGeom>
+          <a:noFill/>
+          <a:ln/>
+        </p:spPr>
+        <p:txBody>
+          <a:bodyPr wrap="square" lIns="0" tIns="0" rIns="0" bIns="0" rtlCol="0" anchor="ctr"/>
+          <a:lstStyle/>
+          <a:p>
+            <a:pPr marL="0" indent="0" algn="r">
+              <a:buNone/>
+            </a:pPr>
+            <a:r>
+              <a:rPr lang="en-US" sz="1250" dirty="0">
+                <a:solidFill>
+                  <a:srgbClr val="9AA2B4"/>
+                </a:solidFill>
+                <a:latin typeface="Helvetica" pitchFamily="34" charset="0"/>
+                <a:ea typeface="Helvetica" pitchFamily="34" charset="-122"/>
+                <a:cs typeface="Helvetica" pitchFamily="34" charset="-120"/>
+              </a:rPr>
+              <a:t>Modul 05 — Komunikasi Pelanggan (WA + Email)</a:t>
+            </a:r>
+            <a:endParaRPr lang="en-US" sz="1250" dirty="0"/>
+          </a:p>
+        </p:txBody>
+      </p:sp>
+      <p:sp>
+        <p:nvSpPr>
+          <p:cNvPr id="6" name="Text 4"/>
+          <p:cNvSpPr/>
+          <p:nvPr/>
+        </p:nvSpPr>
+        <p:spPr>
+          <a:xfrm>
+            <a:off x="502920" y="1170432"/>
+            <a:ext cx="11064240" cy="274320"/>
+          </a:xfrm>
+          <a:prstGeom prst="rect">
+            <a:avLst/>
+          </a:prstGeom>
+          <a:noFill/>
+          <a:ln/>
+        </p:spPr>
+        <p:txBody>
+          <a:bodyPr wrap="square" lIns="0" tIns="0" rIns="0" bIns="0" rtlCol="0" anchor="ctr"/>
+          <a:lstStyle/>
+          <a:p>
+            <a:pPr marL="0" indent="0">
+              <a:buNone/>
+            </a:pPr>
+            <a:r>
+              <a:rPr lang="en-US" sz="1250" b="1" kern="0" spc="40" dirty="0">
+                <a:solidFill>
+                  <a:srgbClr val="4B36C7"/>
+                </a:solidFill>
+                <a:latin typeface="Helvetica" pitchFamily="34" charset="0"/>
+                <a:ea typeface="Helvetica" pitchFamily="34" charset="-122"/>
+                <a:cs typeface="Helvetica" pitchFamily="34" charset="-120"/>
+              </a:rPr>
+              <a:t>DARI TEMPLATE KE BALASAN NYATA</a:t>
+            </a:r>
+            <a:endParaRPr lang="en-US" sz="1250" dirty="0"/>
+          </a:p>
+        </p:txBody>
+      </p:sp>
+      <p:sp>
+        <p:nvSpPr>
+          <p:cNvPr id="7" name="Text 5"/>
+          <p:cNvSpPr/>
+          <p:nvPr/>
+        </p:nvSpPr>
+        <p:spPr>
+          <a:xfrm>
+            <a:off x="502920" y="1444752"/>
+            <a:ext cx="11064240" cy="548640"/>
+          </a:xfrm>
+          <a:prstGeom prst="rect">
+            <a:avLst/>
+          </a:prstGeom>
+          <a:noFill/>
+          <a:ln/>
+        </p:spPr>
+        <p:txBody>
+          <a:bodyPr wrap="square" lIns="0" tIns="0" rIns="0" bIns="0" rtlCol="0" anchor="ctr"/>
+          <a:lstStyle/>
+          <a:p>
+            <a:pPr marL="0" indent="0">
+              <a:buNone/>
+            </a:pPr>
+            <a:r>
+              <a:rPr lang="en-US" sz="2200" b="1" dirty="0">
+                <a:solidFill>
+                  <a:srgbClr val="0D1321"/>
+                </a:solidFill>
+                <a:latin typeface="Helvetica" pitchFamily="34" charset="0"/>
+                <a:ea typeface="Helvetica" pitchFamily="34" charset="-122"/>
+                <a:cs typeface="Helvetica" pitchFamily="34" charset="-120"/>
+              </a:rPr>
+              <a:t>Latihan 3: Reuse untuk Kasus Nyata</a:t>
+            </a:r>
+            <a:endParaRPr lang="en-US" sz="2200" dirty="0"/>
+          </a:p>
+        </p:txBody>
+      </p:sp>
+      <p:sp>
+        <p:nvSpPr>
+          <p:cNvPr id="13" name="Shape 11"/>
+          <p:cNvSpPr/>
+          <p:nvPr/>
+        </p:nvSpPr>
+        <p:spPr>
+          <a:xfrm>
+            <a:off x="502920" y="4663440"/>
+            <a:ext cx="11064240" cy="1691640"/>
+          </a:xfrm>
+          <a:prstGeom prst="roundRect">
+            <a:avLst>
+              <a:gd name="adj" fmla="val 7742"/>
+            </a:avLst>
+          </a:prstGeom>
+          <a:solidFill>
+            <a:srgbClr val="141D33"/>
+          </a:solidFill>
+          <a:ln/>
+        </p:spPr>
+        <p:txBody>
+          <a:bodyPr/>
+          <a:lstStyle/>
+          <a:p>
+            <a:endParaRPr lang="en-ID"/>
+          </a:p>
+        </p:txBody>
+      </p:sp>
+      <p:sp>
+        <p:nvSpPr>
+          <p:cNvPr id="14" name="Text 12"/>
+          <p:cNvSpPr/>
+          <p:nvPr/>
+        </p:nvSpPr>
+        <p:spPr>
+          <a:xfrm>
+            <a:off x="713232" y="4828032"/>
+            <a:ext cx="10607040" cy="274320"/>
+          </a:xfrm>
+          <a:prstGeom prst="rect">
+            <a:avLst/>
+          </a:prstGeom>
+          <a:noFill/>
+          <a:ln/>
+        </p:spPr>
+        <p:txBody>
+          <a:bodyPr wrap="square" lIns="0" tIns="0" rIns="0" bIns="0" rtlCol="0" anchor="ctr"/>
+          <a:lstStyle/>
+          <a:p>
+            <a:pPr marL="0" indent="0">
+              <a:buNone/>
+            </a:pPr>
+            <a:r>
+              <a:rPr lang="en-US" sz="1300" b="1" dirty="0">
+                <a:solidFill>
+                  <a:srgbClr val="8B7CF6"/>
+                </a:solidFill>
+                <a:latin typeface="Helvetica" pitchFamily="34" charset="0"/>
+                <a:ea typeface="Helvetica" pitchFamily="34" charset="-122"/>
+                <a:cs typeface="Helvetica" pitchFamily="34" charset="-120"/>
+              </a:rPr>
+              <a:t>OUTPUT MODUL (KESELURUHAN)</a:t>
+            </a:r>
+            <a:endParaRPr lang="en-US" sz="1300" dirty="0"/>
+          </a:p>
+        </p:txBody>
+      </p:sp>
+      <p:sp>
+        <p:nvSpPr>
+          <p:cNvPr id="15" name="Text 13"/>
+          <p:cNvSpPr/>
+          <p:nvPr/>
+        </p:nvSpPr>
+        <p:spPr>
+          <a:xfrm>
+            <a:off x="713232" y="5120640"/>
+            <a:ext cx="10607040" cy="1097280"/>
+          </a:xfrm>
+          <a:prstGeom prst="rect">
+            <a:avLst/>
+          </a:prstGeom>
+          <a:noFill/>
+          <a:ln/>
+        </p:spPr>
+        <p:txBody>
+          <a:bodyPr wrap="square" lIns="0" tIns="0" rIns="0" bIns="0" rtlCol="0" anchor="ctr"/>
+          <a:lstStyle/>
+          <a:p>
+            <a:pPr marL="0" indent="0">
+              <a:lnSpc>
+                <a:spcPct val="130000"/>
+              </a:lnSpc>
+              <a:buNone/>
+            </a:pPr>
+            <a:r>
+              <a:rPr lang="en-US" sz="1100" dirty="0">
+                <a:solidFill>
+                  <a:srgbClr val="B7C0D8"/>
+                </a:solidFill>
+                <a:latin typeface="Helvetica" pitchFamily="34" charset="0"/>
+                <a:ea typeface="Helvetica" pitchFamily="34" charset="-122"/>
+                <a:cs typeface="Helvetica" pitchFamily="34" charset="-120"/>
+              </a:rPr>
+              <a:t>1 Claude Project dengan brand voice CS aktif (Latihan 1) + 10 template WhatsApp dasar dan 2 email draft di Gmail (Latihan 2) + kemampuan generate balasan on-the-spot untuk kasus baru kapanpun (Latihan 3).</a:t>
+            </a:r>
+            <a:endParaRPr lang="en-US" sz="1100" dirty="0"/>
+          </a:p>
+          <a:p>
+            <a:pPr marL="0" indent="0">
+              <a:lnSpc>
+                <a:spcPct val="130000"/>
+              </a:lnSpc>
+              <a:buNone/>
+            </a:pPr>
+            <a:r>
+              <a:rPr lang="en-US" sz="1100" dirty="0">
+                <a:solidFill>
+                  <a:srgbClr val="B7C0D8"/>
+                </a:solidFill>
+                <a:latin typeface="Helvetica" pitchFamily="34" charset="0"/>
+                <a:ea typeface="Helvetica" pitchFamily="34" charset="-122"/>
+                <a:cs typeface="Helvetica" pitchFamily="34" charset="-120"/>
+              </a:rPr>
+              <a:t>File pendukung: cm-template-wa.txt, cm-template-email.txt</a:t>
+            </a:r>
+            <a:endParaRPr lang="en-US" sz="1100" dirty="0"/>
+          </a:p>
+        </p:txBody>
+      </p:sp>
+      <p:sp>
+        <p:nvSpPr>
+          <p:cNvPr id="18" name="Rounded Rectangle 17"/>
+          <p:cNvSpPr/>
+          <p:nvPr/>
+        </p:nvSpPr>
+        <p:spPr>
+          <a:xfrm>
+            <a:off x="713232" y="3456432"/>
+            <a:ext cx="10607040" cy="566928"/>
+          </a:xfrm>
+          <a:prstGeom prst="roundRect">
+            <a:avLst>
+              <a:gd name="adj" fmla="val 10667"/>
+            </a:avLst>
+          </a:prstGeom>
+          <a:solidFill>
+            <a:srgbClr val="FFFFFF"/>
+          </a:solidFill>
+          <a:ln w="12700">
+            <a:solidFill>
+              <a:srgbClr val="B8E6C9"/>
+            </a:solidFill>
+          </a:ln>
+          <a:effectLst/>
+        </p:spPr>
+        <p:style>
+          <a:lnRef idx="1">
+            <a:schemeClr val="accent1"/>
+          </a:lnRef>
+          <a:fillRef idx="3">
+            <a:schemeClr val="accent1"/>
+          </a:fillRef>
+          <a:effectRef idx="2">
+            <a:schemeClr val="accent1"/>
+          </a:effectRef>
+          <a:fontRef idx="minor">
+            <a:schemeClr val="lt1"/>
+          </a:fontRef>
+        </p:style>
+        <p:txBody>
+          <a:bodyPr wrap="square" lIns="155448" tIns="73152" rIns="155448" bIns="73152" rtlCol="0" anchor="ctr"/>
+          <a:lstStyle/>
+          <a:p>
+            <a:pPr algn="ctr"/>
+            <a:r>
+              <a:rPr sz="950" i="1">
+                <a:solidFill>
+                  <a:srgbClr val="1A7A44"/>
+                </a:solidFill>
+                <a:latin typeface="Helvetica"/>
+              </a:rPr>
               <a:t>"Balas WA: pembeli nanya kenapa pesanannya belum dikirim padahal sudah pesan dari 2 hari lalu, nadanya agak kesal."</a:t>
+            </a:r>
+          </a:p>
+        </p:txBody>
+      </p:sp>
+      <p:sp>
+        <p:nvSpPr>
+          <p:cNvPr id="20" name="TextBox 19"/>
+          <p:cNvSpPr txBox="1"/>
+          <p:nvPr/>
+        </p:nvSpPr>
+        <p:spPr>
+          <a:xfrm>
+            <a:off x="713232" y="2249424"/>
+            <a:ext cx="10607040" cy="274320"/>
+          </a:xfrm>
+          <a:prstGeom prst="rect">
+            <a:avLst/>
+          </a:prstGeom>
+          <a:noFill/>
+        </p:spPr>
+        <p:txBody>
+          <a:bodyPr wrap="none" lIns="0" rIns="0" tIns="0" bIns="0">
+            <a:spAutoFit/>
+          </a:bodyPr>
+          <a:lstStyle/>
+          <a:p>
+            <a:r>
+              <a:rPr sz="1300" b="1">
+                <a:solidFill>
+                  <a:srgbClr val="1A7A44"/>
+                </a:solidFill>
+                <a:latin typeface="Helvetica"/>
+              </a:rPr>
+              <a:t>■  LATIHAN 3 — REUSE UNTUK KASUS NYATA</a:t>
+            </a:r>
+          </a:p>
+        </p:txBody>
+      </p:sp>
+      <p:sp>
+        <p:nvSpPr>
+          <p:cNvPr id="21" name="TextBox 20"/>
+          <p:cNvSpPr txBox="1"/>
+          <p:nvPr/>
+        </p:nvSpPr>
+        <p:spPr>
+          <a:xfrm>
+            <a:off x="713232" y="2542032"/>
+            <a:ext cx="10607040" cy="777240"/>
+          </a:xfrm>
+          <a:prstGeom prst="rect">
+            <a:avLst/>
+          </a:prstGeom>
+          <a:noFill/>
+        </p:spPr>
+        <p:txBody>
+          <a:bodyPr wrap="square" lIns="0" rIns="0" tIns="0" bIns="0">
+            <a:spAutoFit/>
+          </a:bodyPr>
+          <a:lstStyle/>
+          <a:p>
+            <a:r>
+              <a:rPr sz="1200">
+                <a:solidFill>
+                  <a:srgbClr val="23283A"/>
+                </a:solidFill>
+                <a:latin typeface="Helvetica"/>
+              </a:rPr>
+              <a:t>Begitu ada pembeli chat beneran, jangan buka file template — ketik situasinya langsung ke Claude, otomatis cocok ke skenario yang sesuai. Ulangi minimal 5x/minggu (WA), kirim email ke minimal 10 kontak, catat hasilnya.</a:t>
+            </a:r>
+          </a:p>
+        </p:txBody>
+      </p:sp>
+      <p:sp>
+        <p:nvSpPr>
+          <p:cNvPr id="22" name="TextBox 21"/>
+          <p:cNvSpPr txBox="1"/>
+          <p:nvPr/>
+        </p:nvSpPr>
+        <p:spPr>
+          <a:xfrm>
+            <a:off x="713232" y="4114800"/>
+            <a:ext cx="10607040" cy="274320"/>
+          </a:xfrm>
+          <a:prstGeom prst="rect">
+            <a:avLst/>
+          </a:prstGeom>
+          <a:noFill/>
+        </p:spPr>
+        <p:txBody>
+          <a:bodyPr wrap="square" lIns="0" rIns="0" tIns="0" bIns="0">
+            <a:spAutoFit/>
+          </a:bodyPr>
+          <a:lstStyle/>
+          <a:p>
+            <a:r>
+              <a:rPr sz="1000" b="1">
+                <a:solidFill>
+                  <a:srgbClr val="1A7A44"/>
+                </a:solidFill>
+                <a:latin typeface="Helvetica"/>
+              </a:rPr>
+              <a:t>✅ Output: balasan personal siap pakai, on-the-spot, untuk kasus baru kapanpun</a:t>
             </a:r>
           </a:p>
         </p:txBody>

</xml_diff>

<commit_message>
M05: make Email optional/bonus, drop it from the required exercise — Latihan now covers WhatsApp only (setup, generate, reuse), Email content kept as reference for students who want to try it. Also fixed Latihan 3 example to match an actual scenario in cm-template-wa.txt
</commit_message>
<xml_diff>
--- a/Content-Marketing/M05-Komunikasi-Pelanggan/K3-M05-Komunikasi-Pelanggan.pptx
+++ b/Content-Marketing/M05-Komunikasi-Pelanggan/K3-M05-Komunikasi-Pelanggan.pptx
@@ -2300,7 +2300,7 @@
                 <a:ea typeface="Helvetica" pitchFamily="34" charset="-122"/>
                 <a:cs typeface="Helvetica" pitchFamily="34" charset="-120"/>
               </a:rPr>
-              <a:t>Level: Claude Projects (semua plan termasuk Free) · Setup: 5 menit sekali. Tambahkan brand voice CS ke Claude Project dari Modul 1. Upload juga cm-template-wa.txt dan cm-template-email.txt ke Project Knowledge. WhatsApp: belum ada WA Connector, jadi selalu generate lalu copy-paste manual. Email: dasarnya sama, tapi kalau mau, aktifkan Gmail Connector (gratis, 60 detik) — Claude langsung membuat draft di inbox-mu. Belum connect? Copy-paste manual tetap jalan sempurna.</a:t>
+              <a:t>Level: Claude Projects (semua plan termasuk Free) · Setup: 5 menit sekali. Tambahkan brand voice CS ke Claude Project dari Modul 1. Upload cm-template-wa.txt ke Project Knowledge. Belum ada WA Connector, jadi selalu generate lalu copy-paste manual. Mau coba Email juga (opsional)? cm-template-email.txt dipakai dengan cara yang sama, plus Gmail Connector kalau mau draft otomatis.</a:t>
             </a:r>
             <a:endParaRPr lang="en-US" sz="1200" dirty="0"/>
           </a:p>
@@ -4232,7 +4232,7 @@
                 <a:ea typeface="Helvetica" pitchFamily="34" charset="-122"/>
                 <a:cs typeface="Helvetica" pitchFamily="34" charset="-120"/>
               </a:rPr>
-              <a:t>EMAIL VIA GMAIL CONNECTOR</a:t>
+              <a:t>EMAIL (OPSIONAL)</a:t>
             </a:r>
             <a:endParaRPr lang="en-US" sz="1250" dirty="0"/>
           </a:p>
@@ -4448,7 +4448,7 @@
                 <a:ea typeface="Helvetica" pitchFamily="34" charset="-122"/>
                 <a:cs typeface="Helvetica" pitchFamily="34" charset="-120"/>
               </a:rPr>
-              <a:t>Isi cm-template-email.txt bagian relevan (nama produk, harga promo, tanggal, CTA — info bisnis sudah di Project), lalu upload ke Project Knowledge</a:t>
+              <a:t>(Opsional, bonus) Isi cm-template-email.txt bagian relevan, lalu upload ke Project Knowledge</a:t>
             </a:r>
             <a:endParaRPr lang="en-US" sz="1100" dirty="0"/>
           </a:p>
@@ -6287,7 +6287,7 @@
         <p:spPr>
           <a:xfrm>
             <a:off x="502920" y="3913632"/>
-            <a:ext cx="11064240" cy="2606040"/>
+            <a:ext cx="11064240" cy="1737360"/>
           </a:xfrm>
           <a:prstGeom prst="roundRect">
             <a:avLst>
@@ -6392,7 +6392,7 @@
                 </a:solidFill>
                 <a:latin typeface="Helvetica"/>
               </a:rPr>
-              <a:t>Upload cm-template-wa.txt (siap pakai) dan cm-template-email.txt ke Project Knowledge. Isi dulu bagian EMAIL 1 (Launch) &amp; EMAIL 2 (Flash Sale) — detail promo ini spesifik untuk campaign sekarang, belum ada di Project manapun.</a:t>
+              <a:t>Upload cm-template-wa.txt ke Project Knowledge — sudah siap pakai, tidak perlu diisi apapun.</a:t>
             </a:r>
           </a:p>
         </p:txBody>
@@ -6449,7 +6449,7 @@
                 </a:solidFill>
                 <a:latin typeface="Helvetica"/>
               </a:rPr>
-              <a:t>Buatkan 10 template WhatsApp untuk skenario di cm-template-wa.txt, dan 2 draft email (launch + flash sale) dari cm-template-email.txt — simpan sebagai draft di Gmail saya.</a:t>
+              <a:t>Buatkan 10 template WhatsApp untuk skenario di cm-template-wa.txt.</a:t>
             </a:r>
           </a:p>
         </p:txBody>
@@ -6483,7 +6483,7 @@
                 </a:solidFill>
                 <a:latin typeface="Helvetica"/>
               </a:rPr>
-              <a:t>✅ Output: 10 template WA dasar + 2 email draft tersimpan di Gmail — jadi acuan Latihan 3</a:t>
+              <a:t>✅ Output: 10 template WA dasar tersimpan — jadi acuan Latihan 3</a:t>
             </a:r>
           </a:p>
         </p:txBody>
@@ -6882,7 +6882,7 @@
                 <a:ea typeface="Helvetica" pitchFamily="34" charset="-122"/>
                 <a:cs typeface="Helvetica" pitchFamily="34" charset="-120"/>
               </a:rPr>
-              <a:t>1 Claude Project dengan brand voice CS aktif (Latihan 1) + 10 template WhatsApp dasar dan 2 email draft di Gmail (Latihan 2) + kemampuan generate balasan on-the-spot untuk kasus baru kapanpun (Latihan 3).</a:t>
+              <a:t>1 Claude Project dengan brand voice CS aktif (Latihan 1) + 10 template WhatsApp dasar (Latihan 2) + kemampuan generate balasan on-the-spot untuk kasus baru kapanpun (Latihan 3).</a:t>
             </a:r>
             <a:endParaRPr lang="en-US" sz="1100" dirty="0"/>
           </a:p>
@@ -6902,7 +6902,7 @@
                 <a:ea typeface="Helvetica" pitchFamily="34" charset="-122"/>
                 <a:cs typeface="Helvetica" pitchFamily="34" charset="-120"/>
               </a:rPr>
-              <a:t>File pendukung: cm-template-wa.txt, cm-template-email.txt</a:t>
+              <a:t>File pendukung: cm-template-wa.txt. Mau coba Email juga? cm-template-email.txt siap dipakai (opsional).</a:t>
             </a:r>
             <a:endParaRPr lang="en-US" sz="1100" dirty="0"/>
           </a:p>
@@ -6960,7 +6960,7 @@
                 </a:solidFill>
                 <a:latin typeface="Helvetica"/>
               </a:rPr>
-              <a:t>"Balas WA: pembeli nanya kenapa pesanannya belum dikirim padahal sudah pesan dari 2 hari lalu, nadanya agak kesal."</a:t>
+              <a:t>"Balas WA: pembeli minta diskon tambahan karena mau beli 5 pcs sekaligus."</a:t>
             </a:r>
           </a:p>
         </p:txBody>
@@ -7028,7 +7028,7 @@
                 </a:solidFill>
                 <a:latin typeface="Helvetica"/>
               </a:rPr>
-              <a:t>Begitu ada pembeli chat beneran, jangan buka file template — ketik situasinya langsung ke Claude, otomatis cocok ke skenario yang sesuai. Ulangi minimal 5x/minggu (WA), kirim email ke minimal 10 kontak, catat hasilnya.</a:t>
+              <a:t>Begitu ada pembeli chat beneran, jangan buka file template — ketik situasinya langsung ke Claude, otomatis cocok ke skenario yang sesuai. Ulangi minimal 5x/minggu, catat respons pelanggan.</a:t>
             </a:r>
           </a:p>
         </p:txBody>

</xml_diff>

<commit_message>
M05: generalize the 6-types info-grid from email-specific to channel-agnostic customer communication situations
</commit_message>
<xml_diff>
--- a/Content-Marketing/M05-Komunikasi-Pelanggan/K3-M05-Komunikasi-Pelanggan.pptx
+++ b/Content-Marketing/M05-Komunikasi-Pelanggan/K3-M05-Komunikasi-Pelanggan.pptx
@@ -5111,7 +5111,7 @@
                 <a:ea typeface="Helvetica" pitchFamily="34" charset="-122"/>
                 <a:cs typeface="Helvetica" pitchFamily="34" charset="-120"/>
               </a:rPr>
-              <a:t>6 Jenis Email Bisnis yang Perlu Dikuasai</a:t>
+              <a:t>6 Situasi Komunikasi Pelanggan yang Perlu Dikuasai</a:t>
             </a:r>
             <a:endParaRPr lang="en-US" sz="2200" dirty="0"/>
           </a:p>
@@ -5529,7 +5529,7 @@
                 <a:ea typeface="Helvetica" pitchFamily="34" charset="-122"/>
                 <a:cs typeface="Helvetica" pitchFamily="34" charset="-120"/>
               </a:rPr>
-              <a:t>NEWSLETTER BULANAN</a:t>
+              <a:t>UPDATE/CERITA BERKALA</a:t>
             </a:r>
             <a:endParaRPr lang="en-US" sz="1150" dirty="0"/>
           </a:p>
@@ -5801,7 +5801,7 @@
                 <a:ea typeface="Helvetica" pitchFamily="34" charset="-122"/>
                 <a:cs typeface="Helvetica" pitchFamily="34" charset="-120"/>
               </a:rPr>
-              <a:t>Email B2B untuk ajak kolaborasi</a:t>
+              <a:t>B2B untuk ajak kolaborasi</a:t>
             </a:r>
             <a:endParaRPr lang="en-US" sz="1050" dirty="0"/>
           </a:p>

</xml_diff>

<commit_message>
M05: remove Email entirely, WhatsApp-only module
- Module title/desc/tip-box/mistakes list all de-Email'd
- Replaced 6-card scenario grid with 10-card grid matching cm-template-wa.txt's real scenarios (adds complaint handling)
- Removed Cara Kerja: Email step-row and Contoh Prompt: Email block
- Deleted cm-template-email.txt - cm-template-wa.txt is now the sole supporting file
- Updated public preview (content-marketing.html) and admin.html module labels
- Reworked all 8 PPTX slides to match, re-rendered and visually verified each

Checkpoint 104
</commit_message>
<xml_diff>
--- a/Content-Marketing/M05-Komunikasi-Pelanggan/K3-M05-Komunikasi-Pelanggan.pptx
+++ b/Content-Marketing/M05-Komunikasi-Pelanggan/K3-M05-Komunikasi-Pelanggan.pptx
@@ -5,7 +5,7 @@
     <p:sldMasterId id="2147483648" r:id="rId1"/>
   </p:sldMasterIdLst>
   <p:notesMasterIdLst>
-    <p:notesMasterId r:id="rId9"/>
+    <p:notesMasterId r:id="rId10"/>
   </p:notesMasterIdLst>
   <p:sldIdLst>
     <p:sldId id="256" r:id="rId2"/>
@@ -15,7 +15,7 @@
     <p:sldId id="260" r:id="rId6"/>
     <p:sldId id="261" r:id="rId7"/>
     <p:sldId id="262" r:id="rId8"/>
-    <p:sldId id="263" r:id="rId14"/>
+    <p:sldId id="263" r:id="rId9"/>
   </p:sldIdLst>
   <p:sldSz cx="12192000" cy="6858000"/>
   <p:notesSz cx="6858000" cy="12192000"/>
@@ -1361,7 +1361,7 @@
         </p:nvSpPr>
         <p:spPr>
           <a:xfrm>
-            <a:off x="548640" y="2606040"/>
+            <a:off x="548640" y="2687576"/>
             <a:ext cx="7772400" cy="914400"/>
           </a:xfrm>
           <a:prstGeom prst="rect">
@@ -1403,7 +1403,7 @@
         </p:nvSpPr>
         <p:spPr>
           <a:xfrm>
-            <a:off x="548640" y="3611880"/>
+            <a:off x="548640" y="3693416"/>
             <a:ext cx="7772400" cy="457200"/>
           </a:xfrm>
           <a:prstGeom prst="rect">
@@ -1428,7 +1428,7 @@
                 <a:ea typeface="Helvetica" pitchFamily="34" charset="-122"/>
                 <a:cs typeface="Helvetica" pitchFamily="34" charset="-120"/>
               </a:rPr>
-              <a:t>WhatsApp + Email</a:t>
+              <a:t>WhatsApp</a:t>
             </a:r>
             <a:endParaRPr lang="en-US" sz="2400" dirty="0"/>
           </a:p>
@@ -1467,7 +1467,7 @@
                 <a:ea typeface="Helvetica" pitchFamily="34" charset="-122"/>
                 <a:cs typeface="Helvetica" pitchFamily="34" charset="-120"/>
               </a:rPr>
-              <a:t>Satu brand voice, dua kanal — tanpa briefing ulang</a:t>
+              <a:t>Satu brand voice, respons konsisten setiap saat</a:t>
             </a:r>
             <a:endParaRPr lang="en-US" sz="1550" dirty="0"/>
           </a:p>
@@ -1635,7 +1635,7 @@
                 <a:ea typeface="Helvetica" pitchFamily="34" charset="-122"/>
                 <a:cs typeface="Helvetica" pitchFamily="34" charset="-120"/>
               </a:rPr>
-              <a:t>Modul 05 — Komunikasi Pelanggan (WA + Email)</a:t>
+              <a:t>Modul 05 — Komunikasi Pelanggan (WhatsApp)</a:t>
             </a:r>
             <a:endParaRPr lang="en-US" sz="1250" dirty="0"/>
           </a:p>
@@ -1674,7 +1674,7 @@
                 <a:ea typeface="Helvetica" pitchFamily="34" charset="-122"/>
                 <a:cs typeface="Helvetica" pitchFamily="34" charset="-120"/>
               </a:rPr>
-              <a:t>SATU PROFIL BISNIS, DUA KANAL</a:t>
+              <a:t>SATU PROFIL BISNIS, RESPONS KONSISTEN</a:t>
             </a:r>
             <a:endParaRPr lang="en-US" sz="1250" dirty="0"/>
           </a:p>
@@ -1831,7 +1831,7 @@
                 <a:ea typeface="Helvetica" pitchFamily="34" charset="-122"/>
                 <a:cs typeface="Helvetica" pitchFamily="34" charset="-120"/>
               </a:rPr>
-              <a:t>Semua orang di tim balas dengan gaya yang sama, di WA maupun Email</a:t>
+              <a:t>Semua orang di tim balas dengan gaya yang sama</a:t>
             </a:r>
             <a:endParaRPr lang="en-US" sz="1050" dirty="0"/>
           </a:p>
@@ -2258,7 +2258,7 @@
                 <a:ea typeface="Helvetica" pitchFamily="34" charset="-122"/>
                 <a:cs typeface="Helvetica" pitchFamily="34" charset="-120"/>
               </a:rPr>
-              <a:t>◆  CLAUDE PROJECTS (WAJIB) + GMAIL CONNECTOR (OPSIONAL)</a:t>
+              <a:t>◆  CLAUDE PROJECTS — SATU-SATUNYA YANG KAMU BUTUHKAN</a:t>
             </a:r>
             <a:endParaRPr lang="en-US" sz="1250" dirty="0"/>
           </a:p>
@@ -2300,7 +2300,7 @@
                 <a:ea typeface="Helvetica" pitchFamily="34" charset="-122"/>
                 <a:cs typeface="Helvetica" pitchFamily="34" charset="-120"/>
               </a:rPr>
-              <a:t>Level: Claude Projects (semua plan termasuk Free) · Setup: 5 menit sekali. Tambahkan brand voice CS ke Claude Project dari Modul 1. Upload cm-template-wa.txt ke Project Knowledge. Belum ada WA Connector, jadi selalu generate lalu copy-paste manual. Mau coba Email juga (opsional)? cm-template-email.txt dipakai dengan cara yang sama, plus Gmail Connector kalau mau draft otomatis.</a:t>
+              <a:t>Level: Claude Projects (semua plan termasuk Free) · Setup: 5 menit sekali. Tambahkan brand voice khusus komunikasi pelanggan — sapaan, batasan, tone untuk CS — ke Claude Project dari Modul 1, yang sudah punya positioning dan identitas visual bisnismu. Upload cm-template-wa.txt ke Project Knowledge — file ini sengaja tidak berisi info bisnis lagi, cuma 10 skenario. Belum ada WA Connector — jadi generate di chat, lalu copy-paste manual ke WhatsApp-mu, selalu begitu.</a:t>
             </a:r>
             <a:endParaRPr lang="en-US" sz="1200" dirty="0"/>
           </a:p>
@@ -2468,7 +2468,7 @@
                 <a:ea typeface="Helvetica" pitchFamily="34" charset="-122"/>
                 <a:cs typeface="Helvetica" pitchFamily="34" charset="-120"/>
               </a:rPr>
-              <a:t>Modul 05 — Komunikasi Pelanggan (WA + Email)</a:t>
+              <a:t>Modul 05 — Komunikasi Pelanggan (WhatsApp)</a:t>
             </a:r>
             <a:endParaRPr lang="en-US" sz="1250" dirty="0"/>
           </a:p>
@@ -2619,7 +2619,7 @@
                 <a:ea typeface="Helvetica" pitchFamily="34" charset="-122"/>
                 <a:cs typeface="Helvetica" pitchFamily="34" charset="-120"/>
               </a:rPr>
-              <a:t>KESALAHAN UMUM DI WA &amp; EMAIL</a:t>
+              <a:t>KESALAHAN UMUM DI WHATSAPP</a:t>
             </a:r>
             <a:endParaRPr lang="en-US" sz="1250" dirty="0"/>
           </a:p>
@@ -2700,7 +2700,7 @@
                 <a:ea typeface="Helvetica" pitchFamily="34" charset="-122"/>
                 <a:cs typeface="Helvetica" pitchFamily="34" charset="-120"/>
               </a:rPr>
-              <a:t>Terlalu formal dan kaku — pembeli modern tidak suka merasa bicara dengan bot, terutama di WA</a:t>
+              <a:t>Terlalu formal dan kaku — pembeli modern tidak suka merasa bicara dengan bot</a:t>
             </a:r>
             <a:endParaRPr lang="en-US" sz="1100" dirty="0"/>
           </a:p>
@@ -2781,7 +2781,7 @@
                 <a:ea typeface="Helvetica" pitchFamily="34" charset="-122"/>
                 <a:cs typeface="Helvetica" pitchFamily="34" charset="-120"/>
               </a:rPr>
-              <a:t>Tidak ada CTA yang jelas — tiap pesan/email harus ada next step yang jelas</a:t>
+              <a:t>Tidak ada CTA yang jelas — tiap pesan harus ada next step yang jelas</a:t>
             </a:r>
             <a:endParaRPr lang="en-US" sz="1100" dirty="0"/>
           </a:p>
@@ -2943,7 +2943,7 @@
                 <a:ea typeface="Helvetica" pitchFamily="34" charset="-122"/>
                 <a:cs typeface="Helvetica" pitchFamily="34" charset="-120"/>
               </a:rPr>
-              <a:t>Terlalu panjang — WA maksimal 5 baris, Email maksimal 200 kata; keduanya medium untuk di-scan</a:t>
+              <a:t>Terlalu panjang — maksimal 5 baris, WA adalah medium untuk di-scan, bukan dibaca penuh</a:t>
             </a:r>
             <a:endParaRPr lang="en-US" sz="1100" dirty="0"/>
           </a:p>
@@ -3024,7 +3024,7 @@
                 <a:ea typeface="Helvetica" pitchFamily="34" charset="-122"/>
                 <a:cs typeface="Helvetica" pitchFamily="34" charset="-120"/>
               </a:rPr>
-              <a:t>Subjek email generik — "Newsletter Bulan Juli" tidak ada yang mau buka</a:t>
+              <a:t>Respon terlalu lambat — pembeli modern expect balasan dalam hitungan menit, bukan jam</a:t>
             </a:r>
             <a:endParaRPr lang="en-US" sz="1100" dirty="0"/>
           </a:p>
@@ -3192,7 +3192,7 @@
                 <a:ea typeface="Helvetica" pitchFamily="34" charset="-122"/>
                 <a:cs typeface="Helvetica" pitchFamily="34" charset="-120"/>
               </a:rPr>
-              <a:t>Modul 05 — Komunikasi Pelanggan (WA + Email)</a:t>
+              <a:t>Modul 05 — Komunikasi Pelanggan (WhatsApp)</a:t>
             </a:r>
             <a:endParaRPr lang="en-US" sz="1250" dirty="0"/>
           </a:p>
@@ -3285,7 +3285,7 @@
         <p:spPr>
           <a:xfrm>
             <a:off x="502920" y="2121408"/>
-            <a:ext cx="5166360" cy="2743200"/>
+            <a:ext cx="11064240" cy="1783080"/>
           </a:xfrm>
           <a:prstGeom prst="roundRect">
             <a:avLst>
@@ -3318,8 +3318,8 @@
         </p:nvSpPr>
         <p:spPr>
           <a:xfrm>
-            <a:off x="704088" y="2304288"/>
-            <a:ext cx="4764024" cy="274320"/>
+            <a:off x="713232" y="2304288"/>
+            <a:ext cx="10607040" cy="274320"/>
           </a:xfrm>
           <a:prstGeom prst="rect">
             <a:avLst/>
@@ -3357,8 +3357,8 @@
         </p:nvSpPr>
         <p:spPr>
           <a:xfrm>
-            <a:off x="704088" y="2651760"/>
-            <a:ext cx="4764024" cy="1554480"/>
+            <a:off x="713232" y="2606040"/>
+            <a:ext cx="10607040" cy="685800"/>
           </a:xfrm>
           <a:prstGeom prst="rect">
             <a:avLst/>
@@ -3399,8 +3399,8 @@
         </p:nvSpPr>
         <p:spPr>
           <a:xfrm>
-            <a:off x="704088" y="4270248"/>
-            <a:ext cx="4764024" cy="502920"/>
+            <a:off x="713232" y="3429000"/>
+            <a:ext cx="10607040" cy="502920"/>
           </a:xfrm>
           <a:prstGeom prst="rect">
             <a:avLst/>
@@ -3428,163 +3428,6 @@
                 <a:cs typeface="Helvetica" pitchFamily="34" charset="-120"/>
               </a:rPr>
               <a:t>Kenapa berhasil: dengan Projects aktif, 1 kalimat instruksi sudah cukup. Hasilnya kamu copy-paste manual ke WhatsApp (belum ada WA Connector).</a:t>
-            </a:r>
-            <a:endParaRPr lang="en-US" sz="1050" dirty="0"/>
-          </a:p>
-        </p:txBody>
-      </p:sp>
-      <p:sp>
-        <p:nvSpPr>
-          <p:cNvPr id="12" name="Shape 10"/>
-          <p:cNvSpPr/>
-          <p:nvPr/>
-        </p:nvSpPr>
-        <p:spPr>
-          <a:xfrm>
-            <a:off x="6172200" y="2121408"/>
-            <a:ext cx="5166360" cy="2743200"/>
-          </a:xfrm>
-          <a:prstGeom prst="roundRect">
-            <a:avLst>
-              <a:gd name="adj" fmla="val 4000"/>
-            </a:avLst>
-          </a:prstGeom>
-          <a:solidFill>
-            <a:srgbClr val="EFF6FF"/>
-          </a:solidFill>
-          <a:ln w="12700">
-            <a:solidFill>
-              <a:srgbClr val="BFDBFE"/>
-            </a:solidFill>
-            <a:prstDash val="solid"/>
-          </a:ln>
-        </p:spPr>
-        <p:txBody>
-          <a:bodyPr/>
-          <a:lstStyle/>
-          <a:p>
-            <a:endParaRPr lang="en-ID"/>
-          </a:p>
-        </p:txBody>
-      </p:sp>
-      <p:sp>
-        <p:nvSpPr>
-          <p:cNvPr id="13" name="Text 11"/>
-          <p:cNvSpPr/>
-          <p:nvPr/>
-        </p:nvSpPr>
-        <p:spPr>
-          <a:xfrm>
-            <a:off x="6373368" y="2304288"/>
-            <a:ext cx="4764024" cy="274320"/>
-          </a:xfrm>
-          <a:prstGeom prst="rect">
-            <a:avLst/>
-          </a:prstGeom>
-          <a:noFill/>
-          <a:ln/>
-        </p:spPr>
-        <p:txBody>
-          <a:bodyPr wrap="square" lIns="0" tIns="0" rIns="0" bIns="0" rtlCol="0" anchor="ctr"/>
-          <a:lstStyle/>
-          <a:p>
-            <a:pPr marL="0" indent="0">
-              <a:buNone/>
-            </a:pPr>
-            <a:r>
-              <a:rPr lang="en-US" sz="1150" b="1" kern="0" spc="30" dirty="0">
-                <a:solidFill>
-                  <a:srgbClr val="1D4ED8"/>
-                </a:solidFill>
-                <a:latin typeface="Helvetica" pitchFamily="34" charset="0"/>
-                <a:ea typeface="Helvetica" pitchFamily="34" charset="-122"/>
-                <a:cs typeface="Helvetica" pitchFamily="34" charset="-120"/>
-              </a:rPr>
-              <a:t>EMAIL — GMAIL CONNECTOR OPSIONAL</a:t>
-            </a:r>
-            <a:endParaRPr lang="en-US" sz="1150" dirty="0"/>
-          </a:p>
-        </p:txBody>
-      </p:sp>
-      <p:sp>
-        <p:nvSpPr>
-          <p:cNvPr id="14" name="Text 12"/>
-          <p:cNvSpPr/>
-          <p:nvPr/>
-        </p:nvSpPr>
-        <p:spPr>
-          <a:xfrm>
-            <a:off x="6373368" y="2651760"/>
-            <a:ext cx="4764024" cy="1554480"/>
-          </a:xfrm>
-          <a:prstGeom prst="rect">
-            <a:avLst/>
-          </a:prstGeom>
-          <a:noFill/>
-          <a:ln/>
-        </p:spPr>
-        <p:txBody>
-          <a:bodyPr wrap="square" lIns="0" tIns="0" rIns="0" bIns="0" rtlCol="0" anchor="ctr"/>
-          <a:lstStyle/>
-          <a:p>
-            <a:pPr marL="0" indent="0">
-              <a:lnSpc>
-                <a:spcPct val="125000"/>
-              </a:lnSpc>
-              <a:buNone/>
-            </a:pPr>
-            <a:r>
-              <a:rPr lang="en-US" sz="1150" i="1" dirty="0">
-                <a:solidFill>
-                  <a:srgbClr val="23283A"/>
-                </a:solidFill>
-                <a:latin typeface="Helvetica" pitchFamily="34" charset="0"/>
-                <a:ea typeface="Helvetica" pitchFamily="34" charset="-122"/>
-                <a:cs typeface="Helvetica" pitchFamily="34" charset="-120"/>
-              </a:rPr>
-              <a:t>"[Project sudah punya profil bisnis, tone, nama pengirim, jabatan] cm-template-email.txt Email 2 sudah saya lengkapi: Flash Sale Frozen Soto, diskon 25%, kode SOTO25, berlaku 3 hari. Tulis email promosi, subjek maks 9 kata, isi maks 150 kata, CTA ke bit.ly/dapurrara. Simpan sebagai draft di Gmail saya."</a:t>
-            </a:r>
-            <a:endParaRPr lang="en-US" sz="1150" dirty="0"/>
-          </a:p>
-        </p:txBody>
-      </p:sp>
-      <p:sp>
-        <p:nvSpPr>
-          <p:cNvPr id="15" name="Text 13"/>
-          <p:cNvSpPr/>
-          <p:nvPr/>
-        </p:nvSpPr>
-        <p:spPr>
-          <a:xfrm>
-            <a:off x="6373368" y="4270248"/>
-            <a:ext cx="4764024" cy="502920"/>
-          </a:xfrm>
-          <a:prstGeom prst="rect">
-            <a:avLst/>
-          </a:prstGeom>
-          <a:noFill/>
-          <a:ln/>
-        </p:spPr>
-        <p:txBody>
-          <a:bodyPr wrap="square" lIns="0" tIns="0" rIns="0" bIns="0" rtlCol="0" anchor="ctr"/>
-          <a:lstStyle/>
-          <a:p>
-            <a:pPr marL="0" indent="0">
-              <a:lnSpc>
-                <a:spcPct val="125000"/>
-              </a:lnSpc>
-              <a:buNone/>
-            </a:pPr>
-            <a:r>
-              <a:rPr lang="en-US" sz="1050" dirty="0">
-                <a:solidFill>
-                  <a:srgbClr val="1E4C8A"/>
-                </a:solidFill>
-                <a:latin typeface="Helvetica" pitchFamily="34" charset="0"/>
-                <a:ea typeface="Helvetica" pitchFamily="34" charset="-122"/>
-                <a:cs typeface="Helvetica" pitchFamily="34" charset="-120"/>
-              </a:rPr>
-              <a:t>Kenapa berhasil: Project sudah tahu tone &amp; pengirim. Ada Gmail Connector? Langsung jadi draft. Belum? Copy-paste manual — sama seperti WhatsApp.</a:t>
             </a:r>
             <a:endParaRPr lang="en-US" sz="1050" dirty="0"/>
           </a:p>
@@ -3752,7 +3595,7 @@
                 <a:ea typeface="Helvetica" pitchFamily="34" charset="-122"/>
                 <a:cs typeface="Helvetica" pitchFamily="34" charset="-120"/>
               </a:rPr>
-              <a:t>Modul 05 — Komunikasi Pelanggan (WA + Email)</a:t>
+              <a:t>Modul 05 — Komunikasi Pelanggan (WhatsApp)</a:t>
             </a:r>
             <a:endParaRPr lang="en-US" sz="1250" dirty="0"/>
           </a:p>
@@ -3950,7 +3793,7 @@
         <p:spPr>
           <a:xfrm>
             <a:off x="905256" y="2389848"/>
-            <a:ext cx="4764024" cy="594360"/>
+            <a:ext cx="10332720" cy="594360"/>
           </a:xfrm>
           <a:prstGeom prst="rect">
             <a:avLst/>
@@ -4058,7 +3901,7 @@
         <p:spPr>
           <a:xfrm>
             <a:off x="905256" y="3103080"/>
-            <a:ext cx="4764024" cy="594360"/>
+            <a:ext cx="10332720" cy="594360"/>
           </a:xfrm>
           <a:prstGeom prst="rect">
             <a:avLst/>
@@ -4166,7 +4009,7 @@
         <p:spPr>
           <a:xfrm>
             <a:off x="905256" y="3816312"/>
-            <a:ext cx="4764024" cy="594360"/>
+            <a:ext cx="10332720" cy="594360"/>
           </a:xfrm>
           <a:prstGeom prst="rect">
             <a:avLst/>
@@ -4196,564 +4039,6 @@
               <a:t>Pas ada pembeli chat: ketik situasinya ke Claude — otomatis cocok ke skenario, generate balasan siap pakai</a:t>
             </a:r>
             <a:endParaRPr lang="en-US" sz="1100" dirty="0"/>
-          </a:p>
-        </p:txBody>
-      </p:sp>
-      <p:sp>
-        <p:nvSpPr>
-          <p:cNvPr id="18" name="Text 16"/>
-          <p:cNvSpPr/>
-          <p:nvPr/>
-        </p:nvSpPr>
-        <p:spPr>
-          <a:xfrm>
-            <a:off x="6172200" y="2121408"/>
-            <a:ext cx="5166360" cy="274320"/>
-          </a:xfrm>
-          <a:prstGeom prst="rect">
-            <a:avLst/>
-          </a:prstGeom>
-          <a:noFill/>
-          <a:ln/>
-        </p:spPr>
-        <p:txBody>
-          <a:bodyPr wrap="square" lIns="0" tIns="0" rIns="0" bIns="0" rtlCol="0" anchor="ctr"/>
-          <a:lstStyle/>
-          <a:p>
-            <a:pPr marL="0" indent="0">
-              <a:buNone/>
-            </a:pPr>
-            <a:r>
-              <a:rPr lang="en-US" sz="1250" b="1" kern="0" spc="30" dirty="0">
-                <a:solidFill>
-                  <a:srgbClr val="1D4ED8"/>
-                </a:solidFill>
-                <a:latin typeface="Helvetica" pitchFamily="34" charset="0"/>
-                <a:ea typeface="Helvetica" pitchFamily="34" charset="-122"/>
-                <a:cs typeface="Helvetica" pitchFamily="34" charset="-120"/>
-              </a:rPr>
-              <a:t>EMAIL (OPSIONAL)</a:t>
-            </a:r>
-            <a:endParaRPr lang="en-US" sz="1250" dirty="0"/>
-          </a:p>
-        </p:txBody>
-      </p:sp>
-      <p:sp>
-        <p:nvSpPr>
-          <p:cNvPr id="19" name="Shape 17"/>
-          <p:cNvSpPr/>
-          <p:nvPr/>
-        </p:nvSpPr>
-        <p:spPr>
-          <a:xfrm>
-            <a:off x="6172200" y="2505456"/>
-            <a:ext cx="292608" cy="292608"/>
-          </a:xfrm>
-          <a:prstGeom prst="ellipse">
-            <a:avLst/>
-          </a:prstGeom>
-          <a:solidFill>
-            <a:srgbClr val="1D4ED8"/>
-          </a:solidFill>
-          <a:ln/>
-        </p:spPr>
-        <p:txBody>
-          <a:bodyPr/>
-          <a:lstStyle/>
-          <a:p>
-            <a:endParaRPr lang="en-ID"/>
-          </a:p>
-        </p:txBody>
-      </p:sp>
-      <p:sp>
-        <p:nvSpPr>
-          <p:cNvPr id="20" name="Text 18"/>
-          <p:cNvSpPr/>
-          <p:nvPr/>
-        </p:nvSpPr>
-        <p:spPr>
-          <a:xfrm>
-            <a:off x="6172200" y="2505456"/>
-            <a:ext cx="292608" cy="292608"/>
-          </a:xfrm>
-          <a:prstGeom prst="rect">
-            <a:avLst/>
-          </a:prstGeom>
-          <a:noFill/>
-          <a:ln/>
-        </p:spPr>
-        <p:txBody>
-          <a:bodyPr wrap="square" lIns="0" tIns="0" rIns="0" bIns="0" rtlCol="0" anchor="ctr"/>
-          <a:lstStyle/>
-          <a:p>
-            <a:pPr marL="0" indent="0" algn="ctr">
-              <a:buNone/>
-            </a:pPr>
-            <a:r>
-              <a:rPr lang="en-US" sz="1150" b="1" dirty="0">
-                <a:solidFill>
-                  <a:srgbClr val="FFFFFF"/>
-                </a:solidFill>
-                <a:latin typeface="Helvetica" pitchFamily="34" charset="0"/>
-                <a:ea typeface="Helvetica" pitchFamily="34" charset="-122"/>
-                <a:cs typeface="Helvetica" pitchFamily="34" charset="-120"/>
-              </a:rPr>
-              <a:t>1</a:t>
-            </a:r>
-            <a:endParaRPr lang="en-US" sz="1150" dirty="0"/>
-          </a:p>
-        </p:txBody>
-      </p:sp>
-      <p:sp>
-        <p:nvSpPr>
-          <p:cNvPr id="21" name="Text 19"/>
-          <p:cNvSpPr/>
-          <p:nvPr/>
-        </p:nvSpPr>
-        <p:spPr>
-          <a:xfrm>
-            <a:off x="6574536" y="2343256"/>
-            <a:ext cx="4764024" cy="594360"/>
-          </a:xfrm>
-          <a:prstGeom prst="rect">
-            <a:avLst/>
-          </a:prstGeom>
-          <a:noFill/>
-          <a:ln/>
-        </p:spPr>
-        <p:txBody>
-          <a:bodyPr wrap="square" lIns="0" tIns="0" rIns="0" bIns="0" rtlCol="0" anchor="ctr"/>
-          <a:lstStyle/>
-          <a:p>
-            <a:pPr marL="0" indent="0">
-              <a:lnSpc>
-                <a:spcPct val="120000"/>
-              </a:lnSpc>
-              <a:buNone/>
-            </a:pPr>
-            <a:r>
-              <a:rPr lang="en-US" sz="1100" dirty="0">
-                <a:solidFill>
-                  <a:srgbClr val="23283A"/>
-                </a:solidFill>
-                <a:latin typeface="Helvetica" pitchFamily="34" charset="0"/>
-                <a:ea typeface="Helvetica" pitchFamily="34" charset="-122"/>
-                <a:cs typeface="Helvetica" pitchFamily="34" charset="-120"/>
-              </a:rPr>
-              <a:t>(Opsional) Setup Gmail Connector — atau lewati, nanti copy-paste manual</a:t>
-            </a:r>
-            <a:endParaRPr lang="en-US" sz="1100" dirty="0"/>
-          </a:p>
-        </p:txBody>
-      </p:sp>
-      <p:sp>
-        <p:nvSpPr>
-          <p:cNvPr id="22" name="Shape 20"/>
-          <p:cNvSpPr/>
-          <p:nvPr/>
-        </p:nvSpPr>
-        <p:spPr>
-          <a:xfrm>
-            <a:off x="6172200" y="3218688"/>
-            <a:ext cx="292608" cy="292608"/>
-          </a:xfrm>
-          <a:prstGeom prst="ellipse">
-            <a:avLst/>
-          </a:prstGeom>
-          <a:solidFill>
-            <a:srgbClr val="1D4ED8"/>
-          </a:solidFill>
-          <a:ln/>
-        </p:spPr>
-        <p:txBody>
-          <a:bodyPr/>
-          <a:lstStyle/>
-          <a:p>
-            <a:endParaRPr lang="en-ID"/>
-          </a:p>
-        </p:txBody>
-      </p:sp>
-      <p:sp>
-        <p:nvSpPr>
-          <p:cNvPr id="23" name="Text 21"/>
-          <p:cNvSpPr/>
-          <p:nvPr/>
-        </p:nvSpPr>
-        <p:spPr>
-          <a:xfrm>
-            <a:off x="6172200" y="3218688"/>
-            <a:ext cx="292608" cy="292608"/>
-          </a:xfrm>
-          <a:prstGeom prst="rect">
-            <a:avLst/>
-          </a:prstGeom>
-          <a:noFill/>
-          <a:ln/>
-        </p:spPr>
-        <p:txBody>
-          <a:bodyPr wrap="square" lIns="0" tIns="0" rIns="0" bIns="0" rtlCol="0" anchor="ctr"/>
-          <a:lstStyle/>
-          <a:p>
-            <a:pPr marL="0" indent="0" algn="ctr">
-              <a:buNone/>
-            </a:pPr>
-            <a:r>
-              <a:rPr lang="en-US" sz="1150" b="1" dirty="0">
-                <a:solidFill>
-                  <a:srgbClr val="FFFFFF"/>
-                </a:solidFill>
-                <a:latin typeface="Helvetica" pitchFamily="34" charset="0"/>
-                <a:ea typeface="Helvetica" pitchFamily="34" charset="-122"/>
-                <a:cs typeface="Helvetica" pitchFamily="34" charset="-120"/>
-              </a:rPr>
-              <a:t>2</a:t>
-            </a:r>
-            <a:endParaRPr lang="en-US" sz="1150" dirty="0"/>
-          </a:p>
-        </p:txBody>
-      </p:sp>
-      <p:sp>
-        <p:nvSpPr>
-          <p:cNvPr id="24" name="Text 22"/>
-          <p:cNvSpPr/>
-          <p:nvPr/>
-        </p:nvSpPr>
-        <p:spPr>
-          <a:xfrm>
-            <a:off x="6574536" y="3120552"/>
-            <a:ext cx="4764024" cy="594360"/>
-          </a:xfrm>
-          <a:prstGeom prst="rect">
-            <a:avLst/>
-          </a:prstGeom>
-          <a:noFill/>
-          <a:ln/>
-        </p:spPr>
-        <p:txBody>
-          <a:bodyPr wrap="square" lIns="0" tIns="0" rIns="0" bIns="0" rtlCol="0" anchor="ctr"/>
-          <a:lstStyle/>
-          <a:p>
-            <a:pPr marL="0" indent="0">
-              <a:lnSpc>
-                <a:spcPct val="120000"/>
-              </a:lnSpc>
-              <a:buNone/>
-            </a:pPr>
-            <a:r>
-              <a:rPr lang="en-US" sz="1100" dirty="0">
-                <a:solidFill>
-                  <a:srgbClr val="23283A"/>
-                </a:solidFill>
-                <a:latin typeface="Helvetica" pitchFamily="34" charset="0"/>
-                <a:ea typeface="Helvetica" pitchFamily="34" charset="-122"/>
-                <a:cs typeface="Helvetica" pitchFamily="34" charset="-120"/>
-              </a:rPr>
-              <a:t>(Opsional, bonus) Isi cm-template-email.txt bagian relevan, lalu upload ke Project Knowledge</a:t>
-            </a:r>
-            <a:endParaRPr lang="en-US" sz="1100" dirty="0"/>
-          </a:p>
-        </p:txBody>
-      </p:sp>
-      <p:sp>
-        <p:nvSpPr>
-          <p:cNvPr id="25" name="Shape 23"/>
-          <p:cNvSpPr/>
-          <p:nvPr/>
-        </p:nvSpPr>
-        <p:spPr>
-          <a:xfrm>
-            <a:off x="6172200" y="3931920"/>
-            <a:ext cx="292608" cy="292608"/>
-          </a:xfrm>
-          <a:prstGeom prst="ellipse">
-            <a:avLst/>
-          </a:prstGeom>
-          <a:solidFill>
-            <a:srgbClr val="1D4ED8"/>
-          </a:solidFill>
-          <a:ln/>
-        </p:spPr>
-        <p:txBody>
-          <a:bodyPr/>
-          <a:lstStyle/>
-          <a:p>
-            <a:endParaRPr lang="en-ID"/>
-          </a:p>
-        </p:txBody>
-      </p:sp>
-      <p:sp>
-        <p:nvSpPr>
-          <p:cNvPr id="26" name="Text 24"/>
-          <p:cNvSpPr/>
-          <p:nvPr/>
-        </p:nvSpPr>
-        <p:spPr>
-          <a:xfrm>
-            <a:off x="6172200" y="3931920"/>
-            <a:ext cx="292608" cy="292608"/>
-          </a:xfrm>
-          <a:prstGeom prst="rect">
-            <a:avLst/>
-          </a:prstGeom>
-          <a:noFill/>
-          <a:ln/>
-        </p:spPr>
-        <p:txBody>
-          <a:bodyPr wrap="square" lIns="0" tIns="0" rIns="0" bIns="0" rtlCol="0" anchor="ctr"/>
-          <a:lstStyle/>
-          <a:p>
-            <a:pPr marL="0" indent="0" algn="ctr">
-              <a:buNone/>
-            </a:pPr>
-            <a:r>
-              <a:rPr lang="en-US" sz="1150" b="1" dirty="0">
-                <a:solidFill>
-                  <a:srgbClr val="FFFFFF"/>
-                </a:solidFill>
-                <a:latin typeface="Helvetica" pitchFamily="34" charset="0"/>
-                <a:ea typeface="Helvetica" pitchFamily="34" charset="-122"/>
-                <a:cs typeface="Helvetica" pitchFamily="34" charset="-120"/>
-              </a:rPr>
-              <a:t>3</a:t>
-            </a:r>
-            <a:endParaRPr lang="en-US" sz="1150" dirty="0"/>
-          </a:p>
-        </p:txBody>
-      </p:sp>
-      <p:sp>
-        <p:nvSpPr>
-          <p:cNvPr id="27" name="Text 25"/>
-          <p:cNvSpPr/>
-          <p:nvPr/>
-        </p:nvSpPr>
-        <p:spPr>
-          <a:xfrm>
-            <a:off x="6574536" y="3810488"/>
-            <a:ext cx="4764024" cy="594360"/>
-          </a:xfrm>
-          <a:prstGeom prst="rect">
-            <a:avLst/>
-          </a:prstGeom>
-          <a:noFill/>
-          <a:ln/>
-        </p:spPr>
-        <p:txBody>
-          <a:bodyPr wrap="square" lIns="0" tIns="0" rIns="0" bIns="0" rtlCol="0" anchor="ctr"/>
-          <a:lstStyle/>
-          <a:p>
-            <a:pPr marL="0" indent="0">
-              <a:lnSpc>
-                <a:spcPct val="120000"/>
-              </a:lnSpc>
-              <a:buNone/>
-            </a:pPr>
-            <a:r>
-              <a:rPr lang="en-US" sz="1100" dirty="0">
-                <a:solidFill>
-                  <a:srgbClr val="23283A"/>
-                </a:solidFill>
-                <a:latin typeface="Helvetica" pitchFamily="34" charset="0"/>
-                <a:ea typeface="Helvetica" pitchFamily="34" charset="-122"/>
-                <a:cs typeface="Helvetica" pitchFamily="34" charset="-120"/>
-              </a:rPr>
-              <a:t>Paste isian ke Claude, minta tulis email + "simpan sebagai draft di Gmail saya"</a:t>
-            </a:r>
-            <a:endParaRPr lang="en-US" sz="1100" dirty="0"/>
-          </a:p>
-        </p:txBody>
-      </p:sp>
-      <p:sp>
-        <p:nvSpPr>
-          <p:cNvPr id="28" name="Shape 26"/>
-          <p:cNvSpPr/>
-          <p:nvPr/>
-        </p:nvSpPr>
-        <p:spPr>
-          <a:xfrm>
-            <a:off x="6172200" y="4645152"/>
-            <a:ext cx="292608" cy="292608"/>
-          </a:xfrm>
-          <a:prstGeom prst="ellipse">
-            <a:avLst/>
-          </a:prstGeom>
-          <a:solidFill>
-            <a:srgbClr val="1D4ED8"/>
-          </a:solidFill>
-          <a:ln/>
-        </p:spPr>
-        <p:txBody>
-          <a:bodyPr/>
-          <a:lstStyle/>
-          <a:p>
-            <a:endParaRPr lang="en-ID"/>
-          </a:p>
-        </p:txBody>
-      </p:sp>
-      <p:sp>
-        <p:nvSpPr>
-          <p:cNvPr id="29" name="Text 27"/>
-          <p:cNvSpPr/>
-          <p:nvPr/>
-        </p:nvSpPr>
-        <p:spPr>
-          <a:xfrm>
-            <a:off x="6172200" y="4645152"/>
-            <a:ext cx="292608" cy="292608"/>
-          </a:xfrm>
-          <a:prstGeom prst="rect">
-            <a:avLst/>
-          </a:prstGeom>
-          <a:noFill/>
-          <a:ln/>
-        </p:spPr>
-        <p:txBody>
-          <a:bodyPr wrap="square" lIns="0" tIns="0" rIns="0" bIns="0" rtlCol="0" anchor="ctr"/>
-          <a:lstStyle/>
-          <a:p>
-            <a:pPr marL="0" indent="0" algn="ctr">
-              <a:buNone/>
-            </a:pPr>
-            <a:r>
-              <a:rPr lang="en-US" sz="1150" b="1" dirty="0">
-                <a:solidFill>
-                  <a:srgbClr val="FFFFFF"/>
-                </a:solidFill>
-                <a:latin typeface="Helvetica" pitchFamily="34" charset="0"/>
-                <a:ea typeface="Helvetica" pitchFamily="34" charset="-122"/>
-                <a:cs typeface="Helvetica" pitchFamily="34" charset="-120"/>
-              </a:rPr>
-              <a:t>4</a:t>
-            </a:r>
-            <a:endParaRPr lang="en-US" sz="1150" dirty="0"/>
-          </a:p>
-        </p:txBody>
-      </p:sp>
-      <p:sp>
-        <p:nvSpPr>
-          <p:cNvPr id="30" name="Text 28"/>
-          <p:cNvSpPr/>
-          <p:nvPr/>
-        </p:nvSpPr>
-        <p:spPr>
-          <a:xfrm>
-            <a:off x="6574536" y="4482952"/>
-            <a:ext cx="4764024" cy="594360"/>
-          </a:xfrm>
-          <a:prstGeom prst="rect">
-            <a:avLst/>
-          </a:prstGeom>
-          <a:noFill/>
-          <a:ln/>
-        </p:spPr>
-        <p:txBody>
-          <a:bodyPr wrap="square" lIns="0" tIns="0" rIns="0" bIns="0" rtlCol="0" anchor="ctr"/>
-          <a:lstStyle/>
-          <a:p>
-            <a:pPr marL="0" indent="0">
-              <a:lnSpc>
-                <a:spcPct val="120000"/>
-              </a:lnSpc>
-              <a:buNone/>
-            </a:pPr>
-            <a:r>
-              <a:rPr lang="en-US" sz="1100" dirty="0">
-                <a:solidFill>
-                  <a:srgbClr val="23283A"/>
-                </a:solidFill>
-                <a:latin typeface="Helvetica" pitchFamily="34" charset="0"/>
-                <a:ea typeface="Helvetica" pitchFamily="34" charset="-122"/>
-                <a:cs typeface="Helvetica" pitchFamily="34" charset="-120"/>
-              </a:rPr>
-              <a:t>Buka Gmail, review draft, lalu kirim dan pantau open rate</a:t>
-            </a:r>
-            <a:endParaRPr lang="en-US" sz="1100" dirty="0"/>
-          </a:p>
-        </p:txBody>
-      </p:sp>
-      <p:sp>
-        <p:nvSpPr>
-          <p:cNvPr id="31" name="Shape 29"/>
-          <p:cNvSpPr/>
-          <p:nvPr/>
-        </p:nvSpPr>
-        <p:spPr>
-          <a:xfrm>
-            <a:off x="502920" y="5495544"/>
-            <a:ext cx="11064240" cy="960120"/>
-          </a:xfrm>
-          <a:prstGeom prst="roundRect">
-            <a:avLst>
-              <a:gd name="adj" fmla="val 11765"/>
-            </a:avLst>
-          </a:prstGeom>
-          <a:solidFill>
-            <a:srgbClr val="F3F0FF"/>
-          </a:solidFill>
-          <a:ln w="12700">
-            <a:solidFill>
-              <a:srgbClr val="DCD3FB"/>
-            </a:solidFill>
-            <a:prstDash val="solid"/>
-          </a:ln>
-        </p:spPr>
-        <p:txBody>
-          <a:bodyPr/>
-          <a:lstStyle/>
-          <a:p>
-            <a:endParaRPr lang="en-ID"/>
-          </a:p>
-        </p:txBody>
-      </p:sp>
-      <p:sp>
-        <p:nvSpPr>
-          <p:cNvPr id="32" name="Text 30"/>
-          <p:cNvSpPr/>
-          <p:nvPr/>
-        </p:nvSpPr>
-        <p:spPr>
-          <a:xfrm>
-            <a:off x="713232" y="5495544"/>
-            <a:ext cx="10643616" cy="960120"/>
-          </a:xfrm>
-          <a:prstGeom prst="rect">
-            <a:avLst/>
-          </a:prstGeom>
-          <a:noFill/>
-          <a:ln/>
-        </p:spPr>
-        <p:txBody>
-          <a:bodyPr wrap="square" lIns="0" tIns="0" rIns="0" bIns="0" rtlCol="0" anchor="ctr"/>
-          <a:lstStyle/>
-          <a:p>
-            <a:pPr marL="0" indent="0">
-              <a:lnSpc>
-                <a:spcPct val="120000"/>
-              </a:lnSpc>
-              <a:buNone/>
-            </a:pPr>
-            <a:r>
-              <a:rPr lang="en-US" sz="1200" b="1" dirty="0">
-                <a:solidFill>
-                  <a:srgbClr val="4B36C7"/>
-                </a:solidFill>
-                <a:latin typeface="Helvetica" pitchFamily="34" charset="0"/>
-                <a:ea typeface="Helvetica" pitchFamily="34" charset="-122"/>
-                <a:cs typeface="Helvetica" pitchFamily="34" charset="-120"/>
-              </a:rPr>
-              <a:t>◆  KENAPA WA SELALU MANUAL, EMAIL BISA OTOMATIS?  </a:t>
-            </a:r>
-            <a:r>
-              <a:rPr lang="en-US" sz="1200" dirty="0">
-                <a:solidFill>
-                  <a:srgbClr val="23283A"/>
-                </a:solidFill>
-                <a:latin typeface="Helvetica" pitchFamily="34" charset="0"/>
-                <a:ea typeface="Helvetica" pitchFamily="34" charset="-122"/>
-                <a:cs typeface="Helvetica" pitchFamily="34" charset="-120"/>
-              </a:rPr>
-              <a:t>Belum ada WA Connector, jadi WA selalu copy-paste. Gmail Connector (opsional) bikin Email langsung jadi draft.</a:t>
-            </a:r>
-            <a:endParaRPr lang="en-US" sz="1200" dirty="0"/>
           </a:p>
         </p:txBody>
       </p:sp>
@@ -4846,7 +4131,7 @@
         <p:spPr>
           <a:xfrm>
             <a:off x="905256" y="4654183"/>
-            <a:ext cx="4764024" cy="338554"/>
+            <a:ext cx="10332720" cy="338554"/>
           </a:xfrm>
           <a:prstGeom prst="rect">
             <a:avLst/>
@@ -5033,7 +4318,7 @@
                 <a:ea typeface="Helvetica" pitchFamily="34" charset="-122"/>
                 <a:cs typeface="Helvetica" pitchFamily="34" charset="-120"/>
               </a:rPr>
-              <a:t>Modul 05 — Komunikasi Pelanggan (WA + Email)</a:t>
+              <a:t>Modul 05 — Komunikasi Pelanggan (WhatsApp)</a:t>
             </a:r>
             <a:endParaRPr lang="en-US" sz="1250" dirty="0"/>
           </a:p>
@@ -5072,7 +4357,7 @@
                 <a:ea typeface="Helvetica" pitchFamily="34" charset="-122"/>
                 <a:cs typeface="Helvetica" pitchFamily="34" charset="-120"/>
               </a:rPr>
-              <a:t>SATU TEMPLATE FILE, ENAM SKENARIO</a:t>
+              <a:t>SATU TEMPLATE FILE, SEPULUH SKENARIO</a:t>
             </a:r>
             <a:endParaRPr lang="en-US" sz="1250" dirty="0"/>
           </a:p>
@@ -5111,7 +4396,7 @@
                 <a:ea typeface="Helvetica" pitchFamily="34" charset="-122"/>
                 <a:cs typeface="Helvetica" pitchFamily="34" charset="-120"/>
               </a:rPr>
-              <a:t>6 Situasi Komunikasi Pelanggan yang Perlu Dikuasai</a:t>
+              <a:t>10 Skenario WhatsApp yang Perlu Dikuasai</a:t>
             </a:r>
             <a:endParaRPr lang="en-US" sz="2200" dirty="0"/>
           </a:p>
@@ -5119,14 +4404,14 @@
       </p:sp>
       <p:sp>
         <p:nvSpPr>
-          <p:cNvPr id="8" name="Shape 6"/>
-          <p:cNvSpPr/>
-          <p:nvPr/>
-        </p:nvSpPr>
-        <p:spPr>
-          <a:xfrm>
-            <a:off x="502920" y="2148840"/>
-            <a:ext cx="3529584" cy="1234440"/>
+          <p:cNvPr id="8" name="Rounded Rectangle 7"/>
+          <p:cNvSpPr/>
+          <p:nvPr/>
+        </p:nvSpPr>
+        <p:spPr>
+          <a:xfrm>
+            <a:off x="502920" y="2121408"/>
+            <a:ext cx="2103120" cy="1417320"/>
           </a:xfrm>
           <a:prstGeom prst="roundRect">
             <a:avLst>
@@ -5140,108 +4425,112 @@
             <a:solidFill>
               <a:srgbClr val="BFDBFE"/>
             </a:solidFill>
-            <a:prstDash val="solid"/>
           </a:ln>
-        </p:spPr>
-        <p:txBody>
-          <a:bodyPr/>
-          <a:lstStyle/>
-          <a:p>
-            <a:endParaRPr lang="en-ID"/>
-          </a:p>
-        </p:txBody>
-      </p:sp>
-      <p:sp>
-        <p:nvSpPr>
-          <p:cNvPr id="9" name="Text 7"/>
-          <p:cNvSpPr/>
-          <p:nvPr/>
-        </p:nvSpPr>
-        <p:spPr>
-          <a:xfrm>
-            <a:off x="667512" y="2295144"/>
-            <a:ext cx="3200400" cy="365760"/>
-          </a:xfrm>
-          <a:prstGeom prst="rect">
-            <a:avLst/>
-          </a:prstGeom>
-          <a:noFill/>
-          <a:ln/>
-        </p:spPr>
-        <p:txBody>
-          <a:bodyPr wrap="square" lIns="0" tIns="0" rIns="0" bIns="0" rtlCol="0" anchor="ctr"/>
-          <a:lstStyle/>
-          <a:p>
-            <a:pPr marL="0" indent="0">
-              <a:buNone/>
-            </a:pPr>
-            <a:r>
-              <a:rPr lang="en-US" sz="1150" b="1" dirty="0">
+          <a:effectLst/>
+        </p:spPr>
+        <p:style>
+          <a:lnRef idx="1">
+            <a:schemeClr val="accent1"/>
+          </a:lnRef>
+          <a:fillRef idx="3">
+            <a:schemeClr val="accent1"/>
+          </a:fillRef>
+          <a:effectRef idx="2">
+            <a:schemeClr val="accent1"/>
+          </a:effectRef>
+          <a:fontRef idx="minor">
+            <a:schemeClr val="lt1"/>
+          </a:fontRef>
+        </p:style>
+        <p:txBody>
+          <a:bodyPr rtlCol="0" anchor="ctr"/>
+          <a:lstStyle/>
+          <a:p>
+            <a:pPr algn="ctr"/>
+            <a:r>
+              <a:t/>
+            </a:r>
+          </a:p>
+        </p:txBody>
+      </p:sp>
+      <p:sp>
+        <p:nvSpPr>
+          <p:cNvPr id="9" name="TextBox 8"/>
+          <p:cNvSpPr txBox="1"/>
+          <p:nvPr/>
+        </p:nvSpPr>
+        <p:spPr>
+          <a:xfrm>
+            <a:off x="649224" y="2249424"/>
+            <a:ext cx="1810511" cy="502920"/>
+          </a:xfrm>
+          <a:prstGeom prst="rect">
+            <a:avLst/>
+          </a:prstGeom>
+          <a:noFill/>
+        </p:spPr>
+        <p:txBody>
+          <a:bodyPr wrap="square" lIns="0" rIns="0" tIns="0" bIns="0">
+            <a:spAutoFit/>
+          </a:bodyPr>
+          <a:lstStyle/>
+          <a:p>
+            <a:r>
+              <a:rPr sz="1100" b="1">
                 <a:solidFill>
                   <a:srgbClr val="1D4ED8"/>
                 </a:solidFill>
-                <a:latin typeface="Helvetica" pitchFamily="34" charset="0"/>
-                <a:ea typeface="Helvetica" pitchFamily="34" charset="-122"/>
-                <a:cs typeface="Helvetica" pitchFamily="34" charset="-120"/>
-              </a:rPr>
-              <a:t>LAUNCH PRODUK BARU</a:t>
-            </a:r>
-            <a:endParaRPr lang="en-US" sz="1150" dirty="0"/>
-          </a:p>
-        </p:txBody>
-      </p:sp>
-      <p:sp>
-        <p:nvSpPr>
-          <p:cNvPr id="10" name="Text 8"/>
-          <p:cNvSpPr/>
-          <p:nvPr/>
-        </p:nvSpPr>
-        <p:spPr>
-          <a:xfrm>
-            <a:off x="667512" y="2679192"/>
-            <a:ext cx="3200400" cy="594360"/>
-          </a:xfrm>
-          <a:prstGeom prst="rect">
-            <a:avLst/>
-          </a:prstGeom>
-          <a:noFill/>
-          <a:ln/>
-        </p:spPr>
-        <p:txBody>
-          <a:bodyPr wrap="square" lIns="0" tIns="0" rIns="0" bIns="0" rtlCol="0" anchor="ctr"/>
-          <a:lstStyle/>
-          <a:p>
-            <a:pPr marL="0" indent="0">
-              <a:lnSpc>
-                <a:spcPct val="120000"/>
-              </a:lnSpc>
-              <a:buNone/>
-            </a:pPr>
-            <a:r>
-              <a:rPr lang="en-US" sz="1050" dirty="0">
+                <a:latin typeface="Helvetica"/>
+              </a:rPr>
+              <a:t>INQUIRY PERTAMA</a:t>
+            </a:r>
+          </a:p>
+        </p:txBody>
+      </p:sp>
+      <p:sp>
+        <p:nvSpPr>
+          <p:cNvPr id="10" name="TextBox 9"/>
+          <p:cNvSpPr txBox="1"/>
+          <p:nvPr/>
+        </p:nvSpPr>
+        <p:spPr>
+          <a:xfrm>
+            <a:off x="649224" y="2779776"/>
+            <a:ext cx="1810511" cy="685800"/>
+          </a:xfrm>
+          <a:prstGeom prst="rect">
+            <a:avLst/>
+          </a:prstGeom>
+          <a:noFill/>
+        </p:spPr>
+        <p:txBody>
+          <a:bodyPr wrap="square" lIns="0" rIns="0" tIns="0" bIns="0">
+            <a:spAutoFit/>
+          </a:bodyPr>
+          <a:lstStyle/>
+          <a:p>
+            <a:r>
+              <a:rPr sz="950">
                 <a:solidFill>
                   <a:srgbClr val="23283A"/>
                 </a:solidFill>
-                <a:latin typeface="Helvetica" pitchFamily="34" charset="0"/>
-                <a:ea typeface="Helvetica" pitchFamily="34" charset="-122"/>
-                <a:cs typeface="Helvetica" pitchFamily="34" charset="-120"/>
-              </a:rPr>
-              <a:t>Hook kuat + 3 keunggulan + CTA ke link pembelian</a:t>
-            </a:r>
-            <a:endParaRPr lang="en-US" sz="1050" dirty="0"/>
-          </a:p>
-        </p:txBody>
-      </p:sp>
-      <p:sp>
-        <p:nvSpPr>
-          <p:cNvPr id="11" name="Shape 9"/>
-          <p:cNvSpPr/>
-          <p:nvPr/>
-        </p:nvSpPr>
-        <p:spPr>
-          <a:xfrm>
-            <a:off x="4142232" y="2148840"/>
-            <a:ext cx="3529584" cy="1234440"/>
+                <a:latin typeface="Helvetica"/>
+              </a:rPr>
+              <a:t>Sambut hangat + arahkan ke katalog/order</a:t>
+            </a:r>
+          </a:p>
+        </p:txBody>
+      </p:sp>
+      <p:sp>
+        <p:nvSpPr>
+          <p:cNvPr id="11" name="Rounded Rectangle 10"/>
+          <p:cNvSpPr/>
+          <p:nvPr/>
+        </p:nvSpPr>
+        <p:spPr>
+          <a:xfrm>
+            <a:off x="2743200" y="2121408"/>
+            <a:ext cx="2103120" cy="1417320"/>
           </a:xfrm>
           <a:prstGeom prst="roundRect">
             <a:avLst>
@@ -5255,108 +4544,112 @@
             <a:solidFill>
               <a:srgbClr val="BFDBFE"/>
             </a:solidFill>
-            <a:prstDash val="solid"/>
           </a:ln>
-        </p:spPr>
-        <p:txBody>
-          <a:bodyPr/>
-          <a:lstStyle/>
-          <a:p>
-            <a:endParaRPr lang="en-ID"/>
-          </a:p>
-        </p:txBody>
-      </p:sp>
-      <p:sp>
-        <p:nvSpPr>
-          <p:cNvPr id="12" name="Text 10"/>
-          <p:cNvSpPr/>
-          <p:nvPr/>
-        </p:nvSpPr>
-        <p:spPr>
-          <a:xfrm>
-            <a:off x="4306824" y="2295144"/>
-            <a:ext cx="3200400" cy="365760"/>
-          </a:xfrm>
-          <a:prstGeom prst="rect">
-            <a:avLst/>
-          </a:prstGeom>
-          <a:noFill/>
-          <a:ln/>
-        </p:spPr>
-        <p:txBody>
-          <a:bodyPr wrap="square" lIns="0" tIns="0" rIns="0" bIns="0" rtlCol="0" anchor="ctr"/>
-          <a:lstStyle/>
-          <a:p>
-            <a:pPr marL="0" indent="0">
-              <a:buNone/>
-            </a:pPr>
-            <a:r>
-              <a:rPr lang="en-US" sz="1150" b="1" dirty="0">
+          <a:effectLst/>
+        </p:spPr>
+        <p:style>
+          <a:lnRef idx="1">
+            <a:schemeClr val="accent1"/>
+          </a:lnRef>
+          <a:fillRef idx="3">
+            <a:schemeClr val="accent1"/>
+          </a:fillRef>
+          <a:effectRef idx="2">
+            <a:schemeClr val="accent1"/>
+          </a:effectRef>
+          <a:fontRef idx="minor">
+            <a:schemeClr val="lt1"/>
+          </a:fontRef>
+        </p:style>
+        <p:txBody>
+          <a:bodyPr rtlCol="0" anchor="ctr"/>
+          <a:lstStyle/>
+          <a:p>
+            <a:pPr algn="ctr"/>
+            <a:r>
+              <a:t/>
+            </a:r>
+          </a:p>
+        </p:txBody>
+      </p:sp>
+      <p:sp>
+        <p:nvSpPr>
+          <p:cNvPr id="12" name="TextBox 11"/>
+          <p:cNvSpPr txBox="1"/>
+          <p:nvPr/>
+        </p:nvSpPr>
+        <p:spPr>
+          <a:xfrm>
+            <a:off x="2889504" y="2249424"/>
+            <a:ext cx="1810511" cy="502920"/>
+          </a:xfrm>
+          <a:prstGeom prst="rect">
+            <a:avLst/>
+          </a:prstGeom>
+          <a:noFill/>
+        </p:spPr>
+        <p:txBody>
+          <a:bodyPr wrap="square" lIns="0" rIns="0" tIns="0" bIns="0">
+            <a:spAutoFit/>
+          </a:bodyPr>
+          <a:lstStyle/>
+          <a:p>
+            <a:r>
+              <a:rPr sz="1100" b="1">
                 <a:solidFill>
                   <a:srgbClr val="1D4ED8"/>
                 </a:solidFill>
-                <a:latin typeface="Helvetica" pitchFamily="34" charset="0"/>
-                <a:ea typeface="Helvetica" pitchFamily="34" charset="-122"/>
-                <a:cs typeface="Helvetica" pitchFamily="34" charset="-120"/>
-              </a:rPr>
-              <a:t>FLASH SALE / PROMO</a:t>
-            </a:r>
-            <a:endParaRPr lang="en-US" sz="1150" dirty="0"/>
-          </a:p>
-        </p:txBody>
-      </p:sp>
-      <p:sp>
-        <p:nvSpPr>
-          <p:cNvPr id="13" name="Text 11"/>
-          <p:cNvSpPr/>
-          <p:nvPr/>
-        </p:nvSpPr>
-        <p:spPr>
-          <a:xfrm>
-            <a:off x="4306824" y="2679192"/>
-            <a:ext cx="3200400" cy="594360"/>
-          </a:xfrm>
-          <a:prstGeom prst="rect">
-            <a:avLst/>
-          </a:prstGeom>
-          <a:noFill/>
-          <a:ln/>
-        </p:spPr>
-        <p:txBody>
-          <a:bodyPr wrap="square" lIns="0" tIns="0" rIns="0" bIns="0" rtlCol="0" anchor="ctr"/>
-          <a:lstStyle/>
-          <a:p>
-            <a:pPr marL="0" indent="0">
-              <a:lnSpc>
-                <a:spcPct val="120000"/>
-              </a:lnSpc>
-              <a:buNone/>
-            </a:pPr>
-            <a:r>
-              <a:rPr lang="en-US" sz="1050" dirty="0">
+                <a:latin typeface="Helvetica"/>
+              </a:rPr>
+              <a:t>KONFIRMASI PESANAN</a:t>
+            </a:r>
+          </a:p>
+        </p:txBody>
+      </p:sp>
+      <p:sp>
+        <p:nvSpPr>
+          <p:cNvPr id="13" name="TextBox 12"/>
+          <p:cNvSpPr txBox="1"/>
+          <p:nvPr/>
+        </p:nvSpPr>
+        <p:spPr>
+          <a:xfrm>
+            <a:off x="2889504" y="2779776"/>
+            <a:ext cx="1810511" cy="685800"/>
+          </a:xfrm>
+          <a:prstGeom prst="rect">
+            <a:avLst/>
+          </a:prstGeom>
+          <a:noFill/>
+        </p:spPr>
+        <p:txBody>
+          <a:bodyPr wrap="square" lIns="0" rIns="0" tIns="0" bIns="0">
+            <a:spAutoFit/>
+          </a:bodyPr>
+          <a:lstStyle/>
+          <a:p>
+            <a:r>
+              <a:rPr sz="950">
                 <a:solidFill>
                   <a:srgbClr val="23283A"/>
                 </a:solidFill>
-                <a:latin typeface="Helvetica" pitchFamily="34" charset="0"/>
-                <a:ea typeface="Helvetica" pitchFamily="34" charset="-122"/>
-                <a:cs typeface="Helvetica" pitchFamily="34" charset="-120"/>
-              </a:rPr>
-              <a:t>Urgensi + detail promo + deadline jelas</a:t>
-            </a:r>
-            <a:endParaRPr lang="en-US" sz="1050" dirty="0"/>
-          </a:p>
-        </p:txBody>
-      </p:sp>
-      <p:sp>
-        <p:nvSpPr>
-          <p:cNvPr id="14" name="Shape 12"/>
-          <p:cNvSpPr/>
-          <p:nvPr/>
-        </p:nvSpPr>
-        <p:spPr>
-          <a:xfrm>
-            <a:off x="7781544" y="2148840"/>
-            <a:ext cx="3529584" cy="1234440"/>
+                <a:latin typeface="Helvetica"/>
+              </a:rPr>
+              <a:t>Info diterima + estimasi proses</a:t>
+            </a:r>
+          </a:p>
+        </p:txBody>
+      </p:sp>
+      <p:sp>
+        <p:nvSpPr>
+          <p:cNvPr id="14" name="Rounded Rectangle 13"/>
+          <p:cNvSpPr/>
+          <p:nvPr/>
+        </p:nvSpPr>
+        <p:spPr>
+          <a:xfrm>
+            <a:off x="4983479" y="2121408"/>
+            <a:ext cx="2103120" cy="1417320"/>
           </a:xfrm>
           <a:prstGeom prst="roundRect">
             <a:avLst>
@@ -5370,108 +4663,112 @@
             <a:solidFill>
               <a:srgbClr val="BFDBFE"/>
             </a:solidFill>
-            <a:prstDash val="solid"/>
           </a:ln>
-        </p:spPr>
-        <p:txBody>
-          <a:bodyPr/>
-          <a:lstStyle/>
-          <a:p>
-            <a:endParaRPr lang="en-ID"/>
-          </a:p>
-        </p:txBody>
-      </p:sp>
-      <p:sp>
-        <p:nvSpPr>
-          <p:cNvPr id="15" name="Text 13"/>
-          <p:cNvSpPr/>
-          <p:nvPr/>
-        </p:nvSpPr>
-        <p:spPr>
-          <a:xfrm>
-            <a:off x="7946136" y="2295144"/>
-            <a:ext cx="3200400" cy="365760"/>
-          </a:xfrm>
-          <a:prstGeom prst="rect">
-            <a:avLst/>
-          </a:prstGeom>
-          <a:noFill/>
-          <a:ln/>
-        </p:spPr>
-        <p:txBody>
-          <a:bodyPr wrap="square" lIns="0" tIns="0" rIns="0" bIns="0" rtlCol="0" anchor="ctr"/>
-          <a:lstStyle/>
-          <a:p>
-            <a:pPr marL="0" indent="0">
-              <a:buNone/>
-            </a:pPr>
-            <a:r>
-              <a:rPr lang="en-US" sz="1150" b="1" dirty="0">
+          <a:effectLst/>
+        </p:spPr>
+        <p:style>
+          <a:lnRef idx="1">
+            <a:schemeClr val="accent1"/>
+          </a:lnRef>
+          <a:fillRef idx="3">
+            <a:schemeClr val="accent1"/>
+          </a:fillRef>
+          <a:effectRef idx="2">
+            <a:schemeClr val="accent1"/>
+          </a:effectRef>
+          <a:fontRef idx="minor">
+            <a:schemeClr val="lt1"/>
+          </a:fontRef>
+        </p:style>
+        <p:txBody>
+          <a:bodyPr rtlCol="0" anchor="ctr"/>
+          <a:lstStyle/>
+          <a:p>
+            <a:pPr algn="ctr"/>
+            <a:r>
+              <a:t/>
+            </a:r>
+          </a:p>
+        </p:txBody>
+      </p:sp>
+      <p:sp>
+        <p:nvSpPr>
+          <p:cNvPr id="15" name="TextBox 14"/>
+          <p:cNvSpPr txBox="1"/>
+          <p:nvPr/>
+        </p:nvSpPr>
+        <p:spPr>
+          <a:xfrm>
+            <a:off x="5129783" y="2249424"/>
+            <a:ext cx="1810511" cy="502920"/>
+          </a:xfrm>
+          <a:prstGeom prst="rect">
+            <a:avLst/>
+          </a:prstGeom>
+          <a:noFill/>
+        </p:spPr>
+        <p:txBody>
+          <a:bodyPr wrap="square" lIns="0" rIns="0" tIns="0" bIns="0">
+            <a:spAutoFit/>
+          </a:bodyPr>
+          <a:lstStyle/>
+          <a:p>
+            <a:r>
+              <a:rPr sz="1100" b="1">
                 <a:solidFill>
                   <a:srgbClr val="1D4ED8"/>
                 </a:solidFill>
-                <a:latin typeface="Helvetica" pitchFamily="34" charset="0"/>
-                <a:ea typeface="Helvetica" pitchFamily="34" charset="-122"/>
-                <a:cs typeface="Helvetica" pitchFamily="34" charset="-120"/>
-              </a:rPr>
-              <a:t>FOLLOW-UP PEMBELIAN</a:t>
-            </a:r>
-            <a:endParaRPr lang="en-US" sz="1150" dirty="0"/>
-          </a:p>
-        </p:txBody>
-      </p:sp>
-      <p:sp>
-        <p:nvSpPr>
-          <p:cNvPr id="16" name="Text 14"/>
-          <p:cNvSpPr/>
-          <p:nvPr/>
-        </p:nvSpPr>
-        <p:spPr>
-          <a:xfrm>
-            <a:off x="7946136" y="2679192"/>
-            <a:ext cx="3200400" cy="594360"/>
-          </a:xfrm>
-          <a:prstGeom prst="rect">
-            <a:avLst/>
-          </a:prstGeom>
-          <a:noFill/>
-          <a:ln/>
-        </p:spPr>
-        <p:txBody>
-          <a:bodyPr wrap="square" lIns="0" tIns="0" rIns="0" bIns="0" rtlCol="0" anchor="ctr"/>
-          <a:lstStyle/>
-          <a:p>
-            <a:pPr marL="0" indent="0">
-              <a:lnSpc>
-                <a:spcPct val="120000"/>
-              </a:lnSpc>
-              <a:buNone/>
-            </a:pPr>
-            <a:r>
-              <a:rPr lang="en-US" sz="1050" dirty="0">
+                <a:latin typeface="Helvetica"/>
+              </a:rPr>
+              <a:t>INFO PENGIRIMAN</a:t>
+            </a:r>
+          </a:p>
+        </p:txBody>
+      </p:sp>
+      <p:sp>
+        <p:nvSpPr>
+          <p:cNvPr id="16" name="TextBox 15"/>
+          <p:cNvSpPr txBox="1"/>
+          <p:nvPr/>
+        </p:nvSpPr>
+        <p:spPr>
+          <a:xfrm>
+            <a:off x="5129783" y="2779776"/>
+            <a:ext cx="1810511" cy="685800"/>
+          </a:xfrm>
+          <a:prstGeom prst="rect">
+            <a:avLst/>
+          </a:prstGeom>
+          <a:noFill/>
+        </p:spPr>
+        <p:txBody>
+          <a:bodyPr wrap="square" lIns="0" rIns="0" tIns="0" bIns="0">
+            <a:spAutoFit/>
+          </a:bodyPr>
+          <a:lstStyle/>
+          <a:p>
+            <a:r>
+              <a:rPr sz="950">
                 <a:solidFill>
                   <a:srgbClr val="23283A"/>
                 </a:solidFill>
-                <a:latin typeface="Helvetica" pitchFamily="34" charset="0"/>
-                <a:ea typeface="Helvetica" pitchFamily="34" charset="-122"/>
-                <a:cs typeface="Helvetica" pitchFamily="34" charset="-120"/>
-              </a:rPr>
-              <a:t>Minta review + tawarkan produk komplementer</a:t>
-            </a:r>
-            <a:endParaRPr lang="en-US" sz="1050" dirty="0"/>
-          </a:p>
-        </p:txBody>
-      </p:sp>
-      <p:sp>
-        <p:nvSpPr>
-          <p:cNvPr id="17" name="Shape 15"/>
-          <p:cNvSpPr/>
-          <p:nvPr/>
-        </p:nvSpPr>
-        <p:spPr>
-          <a:xfrm>
-            <a:off x="502920" y="3520440"/>
-            <a:ext cx="3529584" cy="1234440"/>
+                <a:latin typeface="Helvetica"/>
+              </a:rPr>
+              <a:t>Nomor resi + estimasi tiba</a:t>
+            </a:r>
+          </a:p>
+        </p:txBody>
+      </p:sp>
+      <p:sp>
+        <p:nvSpPr>
+          <p:cNvPr id="17" name="Rounded Rectangle 16"/>
+          <p:cNvSpPr/>
+          <p:nvPr/>
+        </p:nvSpPr>
+        <p:spPr>
+          <a:xfrm>
+            <a:off x="7223759" y="2121408"/>
+            <a:ext cx="2103120" cy="1417320"/>
           </a:xfrm>
           <a:prstGeom prst="roundRect">
             <a:avLst>
@@ -5485,108 +4782,112 @@
             <a:solidFill>
               <a:srgbClr val="BFDBFE"/>
             </a:solidFill>
-            <a:prstDash val="solid"/>
           </a:ln>
-        </p:spPr>
-        <p:txBody>
-          <a:bodyPr/>
-          <a:lstStyle/>
-          <a:p>
-            <a:endParaRPr lang="en-ID"/>
-          </a:p>
-        </p:txBody>
-      </p:sp>
-      <p:sp>
-        <p:nvSpPr>
-          <p:cNvPr id="18" name="Text 16"/>
-          <p:cNvSpPr/>
-          <p:nvPr/>
-        </p:nvSpPr>
-        <p:spPr>
-          <a:xfrm>
-            <a:off x="667512" y="3666744"/>
-            <a:ext cx="3200400" cy="365760"/>
-          </a:xfrm>
-          <a:prstGeom prst="rect">
-            <a:avLst/>
-          </a:prstGeom>
-          <a:noFill/>
-          <a:ln/>
-        </p:spPr>
-        <p:txBody>
-          <a:bodyPr wrap="square" lIns="0" tIns="0" rIns="0" bIns="0" rtlCol="0" anchor="ctr"/>
-          <a:lstStyle/>
-          <a:p>
-            <a:pPr marL="0" indent="0">
-              <a:buNone/>
-            </a:pPr>
-            <a:r>
-              <a:rPr lang="en-US" sz="1150" b="1" dirty="0">
+          <a:effectLst/>
+        </p:spPr>
+        <p:style>
+          <a:lnRef idx="1">
+            <a:schemeClr val="accent1"/>
+          </a:lnRef>
+          <a:fillRef idx="3">
+            <a:schemeClr val="accent1"/>
+          </a:fillRef>
+          <a:effectRef idx="2">
+            <a:schemeClr val="accent1"/>
+          </a:effectRef>
+          <a:fontRef idx="minor">
+            <a:schemeClr val="lt1"/>
+          </a:fontRef>
+        </p:style>
+        <p:txBody>
+          <a:bodyPr rtlCol="0" anchor="ctr"/>
+          <a:lstStyle/>
+          <a:p>
+            <a:pPr algn="ctr"/>
+            <a:r>
+              <a:t/>
+            </a:r>
+          </a:p>
+        </p:txBody>
+      </p:sp>
+      <p:sp>
+        <p:nvSpPr>
+          <p:cNvPr id="18" name="TextBox 17"/>
+          <p:cNvSpPr txBox="1"/>
+          <p:nvPr/>
+        </p:nvSpPr>
+        <p:spPr>
+          <a:xfrm>
+            <a:off x="7370063" y="2249424"/>
+            <a:ext cx="1810511" cy="502920"/>
+          </a:xfrm>
+          <a:prstGeom prst="rect">
+            <a:avLst/>
+          </a:prstGeom>
+          <a:noFill/>
+        </p:spPr>
+        <p:txBody>
+          <a:bodyPr wrap="square" lIns="0" rIns="0" tIns="0" bIns="0">
+            <a:spAutoFit/>
+          </a:bodyPr>
+          <a:lstStyle/>
+          <a:p>
+            <a:r>
+              <a:rPr sz="1100" b="1">
                 <a:solidFill>
                   <a:srgbClr val="1D4ED8"/>
                 </a:solidFill>
-                <a:latin typeface="Helvetica" pitchFamily="34" charset="0"/>
-                <a:ea typeface="Helvetica" pitchFamily="34" charset="-122"/>
-                <a:cs typeface="Helvetica" pitchFamily="34" charset="-120"/>
-              </a:rPr>
-              <a:t>UPDATE/CERITA BERKALA</a:t>
-            </a:r>
-            <a:endParaRPr lang="en-US" sz="1150" dirty="0"/>
-          </a:p>
-        </p:txBody>
-      </p:sp>
-      <p:sp>
-        <p:nvSpPr>
-          <p:cNvPr id="19" name="Text 17"/>
-          <p:cNvSpPr/>
-          <p:nvPr/>
-        </p:nvSpPr>
-        <p:spPr>
-          <a:xfrm>
-            <a:off x="667512" y="4050792"/>
-            <a:ext cx="3200400" cy="594360"/>
-          </a:xfrm>
-          <a:prstGeom prst="rect">
-            <a:avLst/>
-          </a:prstGeom>
-          <a:noFill/>
-          <a:ln/>
-        </p:spPr>
-        <p:txBody>
-          <a:bodyPr wrap="square" lIns="0" tIns="0" rIns="0" bIns="0" rtlCol="0" anchor="ctr"/>
-          <a:lstStyle/>
-          <a:p>
-            <a:pPr marL="0" indent="0">
-              <a:lnSpc>
-                <a:spcPct val="120000"/>
-              </a:lnSpc>
-              <a:buNone/>
-            </a:pPr>
-            <a:r>
-              <a:rPr lang="en-US" sz="1050" dirty="0">
+                <a:latin typeface="Helvetica"/>
+              </a:rPr>
+              <a:t>FOLLOW-UP PEMBAYARAN</a:t>
+            </a:r>
+          </a:p>
+        </p:txBody>
+      </p:sp>
+      <p:sp>
+        <p:nvSpPr>
+          <p:cNvPr id="19" name="TextBox 18"/>
+          <p:cNvSpPr txBox="1"/>
+          <p:nvPr/>
+        </p:nvSpPr>
+        <p:spPr>
+          <a:xfrm>
+            <a:off x="7370063" y="2779776"/>
+            <a:ext cx="1810511" cy="685800"/>
+          </a:xfrm>
+          <a:prstGeom prst="rect">
+            <a:avLst/>
+          </a:prstGeom>
+          <a:noFill/>
+        </p:spPr>
+        <p:txBody>
+          <a:bodyPr wrap="square" lIns="0" rIns="0" tIns="0" bIns="0">
+            <a:spAutoFit/>
+          </a:bodyPr>
+          <a:lstStyle/>
+          <a:p>
+            <a:r>
+              <a:rPr sz="950">
                 <a:solidFill>
                   <a:srgbClr val="23283A"/>
                 </a:solidFill>
-                <a:latin typeface="Helvetica" pitchFamily="34" charset="0"/>
-                <a:ea typeface="Helvetica" pitchFamily="34" charset="-122"/>
-                <a:cs typeface="Helvetica" pitchFamily="34" charset="-120"/>
-              </a:rPr>
-              <a:t>Highlight + tips + produk unggulan</a:t>
-            </a:r>
-            <a:endParaRPr lang="en-US" sz="1050" dirty="0"/>
-          </a:p>
-        </p:txBody>
-      </p:sp>
-      <p:sp>
-        <p:nvSpPr>
-          <p:cNvPr id="20" name="Shape 18"/>
-          <p:cNvSpPr/>
-          <p:nvPr/>
-        </p:nvSpPr>
-        <p:spPr>
-          <a:xfrm>
-            <a:off x="4142232" y="3520440"/>
-            <a:ext cx="3529584" cy="1234440"/>
+                <a:latin typeface="Helvetica"/>
+              </a:rPr>
+              <a:t>Reminder ramah + tenggat waktu</a:t>
+            </a:r>
+          </a:p>
+        </p:txBody>
+      </p:sp>
+      <p:sp>
+        <p:nvSpPr>
+          <p:cNvPr id="20" name="Rounded Rectangle 19"/>
+          <p:cNvSpPr/>
+          <p:nvPr/>
+        </p:nvSpPr>
+        <p:spPr>
+          <a:xfrm>
+            <a:off x="9464040" y="2121408"/>
+            <a:ext cx="2103120" cy="1417320"/>
           </a:xfrm>
           <a:prstGeom prst="roundRect">
             <a:avLst>
@@ -5600,108 +4901,112 @@
             <a:solidFill>
               <a:srgbClr val="BFDBFE"/>
             </a:solidFill>
-            <a:prstDash val="solid"/>
           </a:ln>
-        </p:spPr>
-        <p:txBody>
-          <a:bodyPr/>
-          <a:lstStyle/>
-          <a:p>
-            <a:endParaRPr lang="en-ID"/>
-          </a:p>
-        </p:txBody>
-      </p:sp>
-      <p:sp>
-        <p:nvSpPr>
-          <p:cNvPr id="21" name="Text 19"/>
-          <p:cNvSpPr/>
-          <p:nvPr/>
-        </p:nvSpPr>
-        <p:spPr>
-          <a:xfrm>
-            <a:off x="4306824" y="3666744"/>
-            <a:ext cx="3200400" cy="365760"/>
-          </a:xfrm>
-          <a:prstGeom prst="rect">
-            <a:avLst/>
-          </a:prstGeom>
-          <a:noFill/>
-          <a:ln/>
-        </p:spPr>
-        <p:txBody>
-          <a:bodyPr wrap="square" lIns="0" tIns="0" rIns="0" bIns="0" rtlCol="0" anchor="ctr"/>
-          <a:lstStyle/>
-          <a:p>
-            <a:pPr marL="0" indent="0">
-              <a:buNone/>
-            </a:pPr>
-            <a:r>
-              <a:rPr lang="en-US" sz="1150" b="1" dirty="0">
+          <a:effectLst/>
+        </p:spPr>
+        <p:style>
+          <a:lnRef idx="1">
+            <a:schemeClr val="accent1"/>
+          </a:lnRef>
+          <a:fillRef idx="3">
+            <a:schemeClr val="accent1"/>
+          </a:fillRef>
+          <a:effectRef idx="2">
+            <a:schemeClr val="accent1"/>
+          </a:effectRef>
+          <a:fontRef idx="minor">
+            <a:schemeClr val="lt1"/>
+          </a:fontRef>
+        </p:style>
+        <p:txBody>
+          <a:bodyPr rtlCol="0" anchor="ctr"/>
+          <a:lstStyle/>
+          <a:p>
+            <a:pPr algn="ctr"/>
+            <a:r>
+              <a:t/>
+            </a:r>
+          </a:p>
+        </p:txBody>
+      </p:sp>
+      <p:sp>
+        <p:nvSpPr>
+          <p:cNvPr id="21" name="TextBox 20"/>
+          <p:cNvSpPr txBox="1"/>
+          <p:nvPr/>
+        </p:nvSpPr>
+        <p:spPr>
+          <a:xfrm>
+            <a:off x="9610344" y="2249424"/>
+            <a:ext cx="1810511" cy="502920"/>
+          </a:xfrm>
+          <a:prstGeom prst="rect">
+            <a:avLst/>
+          </a:prstGeom>
+          <a:noFill/>
+        </p:spPr>
+        <p:txBody>
+          <a:bodyPr wrap="square" lIns="0" rIns="0" tIns="0" bIns="0">
+            <a:spAutoFit/>
+          </a:bodyPr>
+          <a:lstStyle/>
+          <a:p>
+            <a:r>
+              <a:rPr sz="1100" b="1">
                 <a:solidFill>
                   <a:srgbClr val="1D4ED8"/>
                 </a:solidFill>
-                <a:latin typeface="Helvetica" pitchFamily="34" charset="0"/>
-                <a:ea typeface="Helvetica" pitchFamily="34" charset="-122"/>
-                <a:cs typeface="Helvetica" pitchFamily="34" charset="-120"/>
-              </a:rPr>
-              <a:t>REACTIVATION</a:t>
-            </a:r>
-            <a:endParaRPr lang="en-US" sz="1150" dirty="0"/>
-          </a:p>
-        </p:txBody>
-      </p:sp>
-      <p:sp>
-        <p:nvSpPr>
-          <p:cNvPr id="22" name="Text 20"/>
-          <p:cNvSpPr/>
-          <p:nvPr/>
-        </p:nvSpPr>
-        <p:spPr>
-          <a:xfrm>
-            <a:off x="4306824" y="4050792"/>
-            <a:ext cx="3200400" cy="594360"/>
-          </a:xfrm>
-          <a:prstGeom prst="rect">
-            <a:avLst/>
-          </a:prstGeom>
-          <a:noFill/>
-          <a:ln/>
-        </p:spPr>
-        <p:txBody>
-          <a:bodyPr wrap="square" lIns="0" tIns="0" rIns="0" bIns="0" rtlCol="0" anchor="ctr"/>
-          <a:lstStyle/>
-          <a:p>
-            <a:pPr marL="0" indent="0">
-              <a:lnSpc>
-                <a:spcPct val="120000"/>
-              </a:lnSpc>
-              <a:buNone/>
-            </a:pPr>
-            <a:r>
-              <a:rPr lang="en-US" sz="1050" dirty="0">
+                <a:latin typeface="Helvetica"/>
+              </a:rPr>
+              <a:t>BALAS KOMPLAIN</a:t>
+            </a:r>
+          </a:p>
+        </p:txBody>
+      </p:sp>
+      <p:sp>
+        <p:nvSpPr>
+          <p:cNvPr id="22" name="TextBox 21"/>
+          <p:cNvSpPr txBox="1"/>
+          <p:nvPr/>
+        </p:nvSpPr>
+        <p:spPr>
+          <a:xfrm>
+            <a:off x="9610344" y="2779776"/>
+            <a:ext cx="1810511" cy="685800"/>
+          </a:xfrm>
+          <a:prstGeom prst="rect">
+            <a:avLst/>
+          </a:prstGeom>
+          <a:noFill/>
+        </p:spPr>
+        <p:txBody>
+          <a:bodyPr wrap="square" lIns="0" rIns="0" tIns="0" bIns="0">
+            <a:spAutoFit/>
+          </a:bodyPr>
+          <a:lstStyle/>
+          <a:p>
+            <a:r>
+              <a:rPr sz="950">
                 <a:solidFill>
                   <a:srgbClr val="23283A"/>
                 </a:solidFill>
-                <a:latin typeface="Helvetica" pitchFamily="34" charset="0"/>
-                <a:ea typeface="Helvetica" pitchFamily="34" charset="-122"/>
-                <a:cs typeface="Helvetica" pitchFamily="34" charset="-120"/>
-              </a:rPr>
-              <a:t>Pelanggan 3+ bulan tidak beli — "kami kangen kamu"</a:t>
-            </a:r>
-            <a:endParaRPr lang="en-US" sz="1050" dirty="0"/>
-          </a:p>
-        </p:txBody>
-      </p:sp>
-      <p:sp>
-        <p:nvSpPr>
-          <p:cNvPr id="23" name="Shape 21"/>
-          <p:cNvSpPr/>
-          <p:nvPr/>
-        </p:nvSpPr>
-        <p:spPr>
-          <a:xfrm>
-            <a:off x="7781544" y="3520440"/>
-            <a:ext cx="3529584" cy="1234440"/>
+                <a:latin typeface="Helvetica"/>
+              </a:rPr>
+              <a:t>Minta maaf + solusi (ganti/refund)</a:t>
+            </a:r>
+          </a:p>
+        </p:txBody>
+      </p:sp>
+      <p:sp>
+        <p:nvSpPr>
+          <p:cNvPr id="23" name="Rounded Rectangle 22"/>
+          <p:cNvSpPr/>
+          <p:nvPr/>
+        </p:nvSpPr>
+        <p:spPr>
+          <a:xfrm>
+            <a:off x="502920" y="3703320"/>
+            <a:ext cx="2103120" cy="1417320"/>
           </a:xfrm>
           <a:prstGeom prst="roundRect">
             <a:avLst>
@@ -5715,95 +5020,575 @@
             <a:solidFill>
               <a:srgbClr val="BFDBFE"/>
             </a:solidFill>
-            <a:prstDash val="solid"/>
           </a:ln>
-        </p:spPr>
-        <p:txBody>
-          <a:bodyPr/>
-          <a:lstStyle/>
-          <a:p>
-            <a:endParaRPr lang="en-ID"/>
-          </a:p>
-        </p:txBody>
-      </p:sp>
-      <p:sp>
-        <p:nvSpPr>
-          <p:cNvPr id="24" name="Text 22"/>
-          <p:cNvSpPr/>
-          <p:nvPr/>
-        </p:nvSpPr>
-        <p:spPr>
-          <a:xfrm>
-            <a:off x="7946136" y="3666744"/>
-            <a:ext cx="3200400" cy="365760"/>
-          </a:xfrm>
-          <a:prstGeom prst="rect">
-            <a:avLst/>
-          </a:prstGeom>
-          <a:noFill/>
-          <a:ln/>
-        </p:spPr>
-        <p:txBody>
-          <a:bodyPr wrap="square" lIns="0" tIns="0" rIns="0" bIns="0" rtlCol="0" anchor="ctr"/>
-          <a:lstStyle/>
-          <a:p>
-            <a:pPr marL="0" indent="0">
-              <a:buNone/>
-            </a:pPr>
-            <a:r>
-              <a:rPr lang="en-US" sz="1150" b="1" dirty="0">
+          <a:effectLst/>
+        </p:spPr>
+        <p:style>
+          <a:lnRef idx="1">
+            <a:schemeClr val="accent1"/>
+          </a:lnRef>
+          <a:fillRef idx="3">
+            <a:schemeClr val="accent1"/>
+          </a:fillRef>
+          <a:effectRef idx="2">
+            <a:schemeClr val="accent1"/>
+          </a:effectRef>
+          <a:fontRef idx="minor">
+            <a:schemeClr val="lt1"/>
+          </a:fontRef>
+        </p:style>
+        <p:txBody>
+          <a:bodyPr rtlCol="0" anchor="ctr"/>
+          <a:lstStyle/>
+          <a:p>
+            <a:pPr algn="ctr"/>
+            <a:r>
+              <a:t/>
+            </a:r>
+          </a:p>
+        </p:txBody>
+      </p:sp>
+      <p:sp>
+        <p:nvSpPr>
+          <p:cNvPr id="24" name="TextBox 23"/>
+          <p:cNvSpPr txBox="1"/>
+          <p:nvPr/>
+        </p:nvSpPr>
+        <p:spPr>
+          <a:xfrm>
+            <a:off x="649224" y="3831335"/>
+            <a:ext cx="1810511" cy="502920"/>
+          </a:xfrm>
+          <a:prstGeom prst="rect">
+            <a:avLst/>
+          </a:prstGeom>
+          <a:noFill/>
+        </p:spPr>
+        <p:txBody>
+          <a:bodyPr wrap="square" lIns="0" rIns="0" tIns="0" bIns="0">
+            <a:spAutoFit/>
+          </a:bodyPr>
+          <a:lstStyle/>
+          <a:p>
+            <a:r>
+              <a:rPr sz="1100" b="1">
                 <a:solidFill>
                   <a:srgbClr val="1D4ED8"/>
                 </a:solidFill>
-                <a:latin typeface="Helvetica" pitchFamily="34" charset="0"/>
-                <a:ea typeface="Helvetica" pitchFamily="34" charset="-122"/>
-                <a:cs typeface="Helvetica" pitchFamily="34" charset="-120"/>
-              </a:rPr>
-              <a:t>RESELLER / MITRA</a:t>
-            </a:r>
-            <a:endParaRPr lang="en-US" sz="1150" dirty="0"/>
-          </a:p>
-        </p:txBody>
-      </p:sp>
-      <p:sp>
-        <p:nvSpPr>
-          <p:cNvPr id="25" name="Text 23"/>
-          <p:cNvSpPr/>
-          <p:nvPr/>
-        </p:nvSpPr>
-        <p:spPr>
-          <a:xfrm>
-            <a:off x="7946136" y="4050792"/>
-            <a:ext cx="3200400" cy="594360"/>
-          </a:xfrm>
-          <a:prstGeom prst="rect">
-            <a:avLst/>
-          </a:prstGeom>
-          <a:noFill/>
-          <a:ln/>
-        </p:spPr>
-        <p:txBody>
-          <a:bodyPr wrap="square" lIns="0" tIns="0" rIns="0" bIns="0" rtlCol="0" anchor="ctr"/>
-          <a:lstStyle/>
-          <a:p>
-            <a:pPr marL="0" indent="0">
-              <a:lnSpc>
-                <a:spcPct val="120000"/>
-              </a:lnSpc>
-              <a:buNone/>
-            </a:pPr>
-            <a:r>
-              <a:rPr lang="en-US" sz="1050" dirty="0">
+                <a:latin typeface="Helvetica"/>
+              </a:rPr>
+              <a:t>MINTA TESTIMONI</a:t>
+            </a:r>
+          </a:p>
+        </p:txBody>
+      </p:sp>
+      <p:sp>
+        <p:nvSpPr>
+          <p:cNvPr id="25" name="TextBox 24"/>
+          <p:cNvSpPr txBox="1"/>
+          <p:nvPr/>
+        </p:nvSpPr>
+        <p:spPr>
+          <a:xfrm>
+            <a:off x="649224" y="4361688"/>
+            <a:ext cx="1810511" cy="685800"/>
+          </a:xfrm>
+          <a:prstGeom prst="rect">
+            <a:avLst/>
+          </a:prstGeom>
+          <a:noFill/>
+        </p:spPr>
+        <p:txBody>
+          <a:bodyPr wrap="square" lIns="0" rIns="0" tIns="0" bIns="0">
+            <a:spAutoFit/>
+          </a:bodyPr>
+          <a:lstStyle/>
+          <a:p>
+            <a:r>
+              <a:rPr sz="950">
                 <a:solidFill>
                   <a:srgbClr val="23283A"/>
                 </a:solidFill>
-                <a:latin typeface="Helvetica" pitchFamily="34" charset="0"/>
-                <a:ea typeface="Helvetica" pitchFamily="34" charset="-122"/>
-                <a:cs typeface="Helvetica" pitchFamily="34" charset="-120"/>
-              </a:rPr>
-              <a:t>B2B untuk ajak kolaborasi</a:t>
-            </a:r>
-            <a:endParaRPr lang="en-US" sz="1050" dirty="0"/>
+                <a:latin typeface="Helvetica"/>
+              </a:rPr>
+              <a:t>Tanya pengalaman + minta review</a:t>
+            </a:r>
+          </a:p>
+        </p:txBody>
+      </p:sp>
+      <p:sp>
+        <p:nvSpPr>
+          <p:cNvPr id="26" name="Rounded Rectangle 25"/>
+          <p:cNvSpPr/>
+          <p:nvPr/>
+        </p:nvSpPr>
+        <p:spPr>
+          <a:xfrm>
+            <a:off x="2743200" y="3703320"/>
+            <a:ext cx="2103120" cy="1417320"/>
+          </a:xfrm>
+          <a:prstGeom prst="roundRect">
+            <a:avLst>
+              <a:gd name="adj" fmla="val 7407"/>
+            </a:avLst>
+          </a:prstGeom>
+          <a:solidFill>
+            <a:srgbClr val="EFF6FF"/>
+          </a:solidFill>
+          <a:ln w="12700">
+            <a:solidFill>
+              <a:srgbClr val="BFDBFE"/>
+            </a:solidFill>
+          </a:ln>
+          <a:effectLst/>
+        </p:spPr>
+        <p:style>
+          <a:lnRef idx="1">
+            <a:schemeClr val="accent1"/>
+          </a:lnRef>
+          <a:fillRef idx="3">
+            <a:schemeClr val="accent1"/>
+          </a:fillRef>
+          <a:effectRef idx="2">
+            <a:schemeClr val="accent1"/>
+          </a:effectRef>
+          <a:fontRef idx="minor">
+            <a:schemeClr val="lt1"/>
+          </a:fontRef>
+        </p:style>
+        <p:txBody>
+          <a:bodyPr rtlCol="0" anchor="ctr"/>
+          <a:lstStyle/>
+          <a:p>
+            <a:pPr algn="ctr"/>
+            <a:r>
+              <a:t/>
+            </a:r>
+          </a:p>
+        </p:txBody>
+      </p:sp>
+      <p:sp>
+        <p:nvSpPr>
+          <p:cNvPr id="27" name="TextBox 26"/>
+          <p:cNvSpPr txBox="1"/>
+          <p:nvPr/>
+        </p:nvSpPr>
+        <p:spPr>
+          <a:xfrm>
+            <a:off x="2889504" y="3831335"/>
+            <a:ext cx="1810511" cy="502920"/>
+          </a:xfrm>
+          <a:prstGeom prst="rect">
+            <a:avLst/>
+          </a:prstGeom>
+          <a:noFill/>
+        </p:spPr>
+        <p:txBody>
+          <a:bodyPr wrap="square" lIns="0" rIns="0" tIns="0" bIns="0">
+            <a:spAutoFit/>
+          </a:bodyPr>
+          <a:lstStyle/>
+          <a:p>
+            <a:r>
+              <a:rPr sz="1100" b="1">
+                <a:solidFill>
+                  <a:srgbClr val="1D4ED8"/>
+                </a:solidFill>
+                <a:latin typeface="Helvetica"/>
+              </a:rPr>
+              <a:t>BROADCAST PROMO</a:t>
+            </a:r>
+          </a:p>
+        </p:txBody>
+      </p:sp>
+      <p:sp>
+        <p:nvSpPr>
+          <p:cNvPr id="28" name="TextBox 27"/>
+          <p:cNvSpPr txBox="1"/>
+          <p:nvPr/>
+        </p:nvSpPr>
+        <p:spPr>
+          <a:xfrm>
+            <a:off x="2889504" y="4361688"/>
+            <a:ext cx="1810511" cy="685800"/>
+          </a:xfrm>
+          <a:prstGeom prst="rect">
+            <a:avLst/>
+          </a:prstGeom>
+          <a:noFill/>
+        </p:spPr>
+        <p:txBody>
+          <a:bodyPr wrap="square" lIns="0" rIns="0" tIns="0" bIns="0">
+            <a:spAutoFit/>
+          </a:bodyPr>
+          <a:lstStyle/>
+          <a:p>
+            <a:r>
+              <a:rPr sz="950">
+                <a:solidFill>
+                  <a:srgbClr val="23283A"/>
+                </a:solidFill>
+                <a:latin typeface="Helvetica"/>
+              </a:rPr>
+              <a:t>Hook menarik + deadline + cara order</a:t>
+            </a:r>
+          </a:p>
+        </p:txBody>
+      </p:sp>
+      <p:sp>
+        <p:nvSpPr>
+          <p:cNvPr id="29" name="Rounded Rectangle 28"/>
+          <p:cNvSpPr/>
+          <p:nvPr/>
+        </p:nvSpPr>
+        <p:spPr>
+          <a:xfrm>
+            <a:off x="4983479" y="3703320"/>
+            <a:ext cx="2103120" cy="1417320"/>
+          </a:xfrm>
+          <a:prstGeom prst="roundRect">
+            <a:avLst>
+              <a:gd name="adj" fmla="val 7407"/>
+            </a:avLst>
+          </a:prstGeom>
+          <a:solidFill>
+            <a:srgbClr val="EFF6FF"/>
+          </a:solidFill>
+          <a:ln w="12700">
+            <a:solidFill>
+              <a:srgbClr val="BFDBFE"/>
+            </a:solidFill>
+          </a:ln>
+          <a:effectLst/>
+        </p:spPr>
+        <p:style>
+          <a:lnRef idx="1">
+            <a:schemeClr val="accent1"/>
+          </a:lnRef>
+          <a:fillRef idx="3">
+            <a:schemeClr val="accent1"/>
+          </a:fillRef>
+          <a:effectRef idx="2">
+            <a:schemeClr val="accent1"/>
+          </a:effectRef>
+          <a:fontRef idx="minor">
+            <a:schemeClr val="lt1"/>
+          </a:fontRef>
+        </p:style>
+        <p:txBody>
+          <a:bodyPr rtlCol="0" anchor="ctr"/>
+          <a:lstStyle/>
+          <a:p>
+            <a:pPr algn="ctr"/>
+            <a:r>
+              <a:t/>
+            </a:r>
+          </a:p>
+        </p:txBody>
+      </p:sp>
+      <p:sp>
+        <p:nvSpPr>
+          <p:cNvPr id="30" name="TextBox 29"/>
+          <p:cNvSpPr txBox="1"/>
+          <p:nvPr/>
+        </p:nvSpPr>
+        <p:spPr>
+          <a:xfrm>
+            <a:off x="5129783" y="3831335"/>
+            <a:ext cx="1810511" cy="502920"/>
+          </a:xfrm>
+          <a:prstGeom prst="rect">
+            <a:avLst/>
+          </a:prstGeom>
+          <a:noFill/>
+        </p:spPr>
+        <p:txBody>
+          <a:bodyPr wrap="square" lIns="0" rIns="0" tIns="0" bIns="0">
+            <a:spAutoFit/>
+          </a:bodyPr>
+          <a:lstStyle/>
+          <a:p>
+            <a:r>
+              <a:rPr sz="1100" b="1">
+                <a:solidFill>
+                  <a:srgbClr val="1D4ED8"/>
+                </a:solidFill>
+                <a:latin typeface="Helvetica"/>
+              </a:rPr>
+              <a:t>NEGOSIASI HARGA</a:t>
+            </a:r>
+          </a:p>
+        </p:txBody>
+      </p:sp>
+      <p:sp>
+        <p:nvSpPr>
+          <p:cNvPr id="31" name="TextBox 30"/>
+          <p:cNvSpPr txBox="1"/>
+          <p:nvPr/>
+        </p:nvSpPr>
+        <p:spPr>
+          <a:xfrm>
+            <a:off x="5129783" y="4361688"/>
+            <a:ext cx="1810511" cy="685800"/>
+          </a:xfrm>
+          <a:prstGeom prst="rect">
+            <a:avLst/>
+          </a:prstGeom>
+          <a:noFill/>
+        </p:spPr>
+        <p:txBody>
+          <a:bodyPr wrap="square" lIns="0" rIns="0" tIns="0" bIns="0">
+            <a:spAutoFit/>
+          </a:bodyPr>
+          <a:lstStyle/>
+          <a:p>
+            <a:r>
+              <a:rPr sz="950">
+                <a:solidFill>
+                  <a:srgbClr val="23283A"/>
+                </a:solidFill>
+                <a:latin typeface="Helvetica"/>
+              </a:rPr>
+              <a:t>Pertahankan harga + tawarkan value</a:t>
+            </a:r>
+          </a:p>
+        </p:txBody>
+      </p:sp>
+      <p:sp>
+        <p:nvSpPr>
+          <p:cNvPr id="32" name="Rounded Rectangle 31"/>
+          <p:cNvSpPr/>
+          <p:nvPr/>
+        </p:nvSpPr>
+        <p:spPr>
+          <a:xfrm>
+            <a:off x="7223759" y="3703320"/>
+            <a:ext cx="2103120" cy="1417320"/>
+          </a:xfrm>
+          <a:prstGeom prst="roundRect">
+            <a:avLst>
+              <a:gd name="adj" fmla="val 7407"/>
+            </a:avLst>
+          </a:prstGeom>
+          <a:solidFill>
+            <a:srgbClr val="EFF6FF"/>
+          </a:solidFill>
+          <a:ln w="12700">
+            <a:solidFill>
+              <a:srgbClr val="BFDBFE"/>
+            </a:solidFill>
+          </a:ln>
+          <a:effectLst/>
+        </p:spPr>
+        <p:style>
+          <a:lnRef idx="1">
+            <a:schemeClr val="accent1"/>
+          </a:lnRef>
+          <a:fillRef idx="3">
+            <a:schemeClr val="accent1"/>
+          </a:fillRef>
+          <a:effectRef idx="2">
+            <a:schemeClr val="accent1"/>
+          </a:effectRef>
+          <a:fontRef idx="minor">
+            <a:schemeClr val="lt1"/>
+          </a:fontRef>
+        </p:style>
+        <p:txBody>
+          <a:bodyPr rtlCol="0" anchor="ctr"/>
+          <a:lstStyle/>
+          <a:p>
+            <a:pPr algn="ctr"/>
+            <a:r>
+              <a:t/>
+            </a:r>
+          </a:p>
+        </p:txBody>
+      </p:sp>
+      <p:sp>
+        <p:nvSpPr>
+          <p:cNvPr id="33" name="TextBox 32"/>
+          <p:cNvSpPr txBox="1"/>
+          <p:nvPr/>
+        </p:nvSpPr>
+        <p:spPr>
+          <a:xfrm>
+            <a:off x="7370063" y="3831335"/>
+            <a:ext cx="1810511" cy="502920"/>
+          </a:xfrm>
+          <a:prstGeom prst="rect">
+            <a:avLst/>
+          </a:prstGeom>
+          <a:noFill/>
+        </p:spPr>
+        <p:txBody>
+          <a:bodyPr wrap="square" lIns="0" rIns="0" tIns="0" bIns="0">
+            <a:spAutoFit/>
+          </a:bodyPr>
+          <a:lstStyle/>
+          <a:p>
+            <a:r>
+              <a:rPr sz="1100" b="1">
+                <a:solidFill>
+                  <a:srgbClr val="1D4ED8"/>
+                </a:solidFill>
+                <a:latin typeface="Helvetica"/>
+              </a:rPr>
+              <a:t>STOK HABIS</a:t>
+            </a:r>
+          </a:p>
+        </p:txBody>
+      </p:sp>
+      <p:sp>
+        <p:nvSpPr>
+          <p:cNvPr id="34" name="TextBox 33"/>
+          <p:cNvSpPr txBox="1"/>
+          <p:nvPr/>
+        </p:nvSpPr>
+        <p:spPr>
+          <a:xfrm>
+            <a:off x="7370063" y="4361688"/>
+            <a:ext cx="1810511" cy="685800"/>
+          </a:xfrm>
+          <a:prstGeom prst="rect">
+            <a:avLst/>
+          </a:prstGeom>
+          <a:noFill/>
+        </p:spPr>
+        <p:txBody>
+          <a:bodyPr wrap="square" lIns="0" rIns="0" tIns="0" bIns="0">
+            <a:spAutoFit/>
+          </a:bodyPr>
+          <a:lstStyle/>
+          <a:p>
+            <a:r>
+              <a:rPr sz="950">
+                <a:solidFill>
+                  <a:srgbClr val="23283A"/>
+                </a:solidFill>
+                <a:latin typeface="Helvetica"/>
+              </a:rPr>
+              <a:t>Info stok + estimasi restock</a:t>
+            </a:r>
+          </a:p>
+        </p:txBody>
+      </p:sp>
+      <p:sp>
+        <p:nvSpPr>
+          <p:cNvPr id="35" name="Rounded Rectangle 34"/>
+          <p:cNvSpPr/>
+          <p:nvPr/>
+        </p:nvSpPr>
+        <p:spPr>
+          <a:xfrm>
+            <a:off x="9464040" y="3703320"/>
+            <a:ext cx="2103120" cy="1417320"/>
+          </a:xfrm>
+          <a:prstGeom prst="roundRect">
+            <a:avLst>
+              <a:gd name="adj" fmla="val 7407"/>
+            </a:avLst>
+          </a:prstGeom>
+          <a:solidFill>
+            <a:srgbClr val="EFF6FF"/>
+          </a:solidFill>
+          <a:ln w="12700">
+            <a:solidFill>
+              <a:srgbClr val="BFDBFE"/>
+            </a:solidFill>
+          </a:ln>
+          <a:effectLst/>
+        </p:spPr>
+        <p:style>
+          <a:lnRef idx="1">
+            <a:schemeClr val="accent1"/>
+          </a:lnRef>
+          <a:fillRef idx="3">
+            <a:schemeClr val="accent1"/>
+          </a:fillRef>
+          <a:effectRef idx="2">
+            <a:schemeClr val="accent1"/>
+          </a:effectRef>
+          <a:fontRef idx="minor">
+            <a:schemeClr val="lt1"/>
+          </a:fontRef>
+        </p:style>
+        <p:txBody>
+          <a:bodyPr rtlCol="0" anchor="ctr"/>
+          <a:lstStyle/>
+          <a:p>
+            <a:pPr algn="ctr"/>
+            <a:r>
+              <a:t/>
+            </a:r>
+          </a:p>
+        </p:txBody>
+      </p:sp>
+      <p:sp>
+        <p:nvSpPr>
+          <p:cNvPr id="36" name="TextBox 35"/>
+          <p:cNvSpPr txBox="1"/>
+          <p:nvPr/>
+        </p:nvSpPr>
+        <p:spPr>
+          <a:xfrm>
+            <a:off x="9610344" y="3831335"/>
+            <a:ext cx="1810511" cy="502920"/>
+          </a:xfrm>
+          <a:prstGeom prst="rect">
+            <a:avLst/>
+          </a:prstGeom>
+          <a:noFill/>
+        </p:spPr>
+        <p:txBody>
+          <a:bodyPr wrap="square" lIns="0" rIns="0" tIns="0" bIns="0">
+            <a:spAutoFit/>
+          </a:bodyPr>
+          <a:lstStyle/>
+          <a:p>
+            <a:r>
+              <a:rPr sz="1100" b="1">
+                <a:solidFill>
+                  <a:srgbClr val="1D4ED8"/>
+                </a:solidFill>
+                <a:latin typeface="Helvetica"/>
+              </a:rPr>
+              <a:t>UCAPAN TERIMA KASIH</a:t>
+            </a:r>
+          </a:p>
+        </p:txBody>
+      </p:sp>
+      <p:sp>
+        <p:nvSpPr>
+          <p:cNvPr id="37" name="TextBox 36"/>
+          <p:cNvSpPr txBox="1"/>
+          <p:nvPr/>
+        </p:nvSpPr>
+        <p:spPr>
+          <a:xfrm>
+            <a:off x="9610344" y="4361688"/>
+            <a:ext cx="1810511" cy="685800"/>
+          </a:xfrm>
+          <a:prstGeom prst="rect">
+            <a:avLst/>
+          </a:prstGeom>
+          <a:noFill/>
+        </p:spPr>
+        <p:txBody>
+          <a:bodyPr wrap="square" lIns="0" rIns="0" tIns="0" bIns="0">
+            <a:spAutoFit/>
+          </a:bodyPr>
+          <a:lstStyle/>
+          <a:p>
+            <a:r>
+              <a:rPr sz="950">
+                <a:solidFill>
+                  <a:srgbClr val="23283A"/>
+                </a:solidFill>
+                <a:latin typeface="Helvetica"/>
+              </a:rPr>
+              <a:t>Terima kasih + undang kembali</a:t>
+            </a:r>
           </a:p>
         </p:txBody>
       </p:sp>
@@ -5969,7 +5754,7 @@
                 <a:ea typeface="Helvetica" pitchFamily="34" charset="-122"/>
                 <a:cs typeface="Helvetica" pitchFamily="34" charset="-120"/>
               </a:rPr>
-              <a:t>Modul 05 — Komunikasi Pelanggan (WA + Email)</a:t>
+              <a:t>Modul 05 — Komunikasi Pelanggan (WhatsApp)</a:t>
             </a:r>
             <a:endParaRPr lang="en-US" sz="1250" dirty="0"/>
           </a:p>
@@ -6238,7 +6023,7 @@
                 <a:ea typeface="Helvetica" pitchFamily="34" charset="-122"/>
                 <a:cs typeface="Helvetica" pitchFamily="34" charset="-120"/>
               </a:rPr>
-              <a:t>Brand voice untuk komunikasi pelanggan: tone santai-hangat, sapaan "Kak", batasan emoji 1-2/pesan. Email: nama pengirim [nama], jabatan [Owner/dst].</a:t>
+              <a:t>Brand voice untuk komunikasi pelanggan: tone santai-hangat, sapaan "Kak", batasan emoji 1-2/pesan.</a:t>
             </a:r>
             <a:endParaRPr lang="en-US" sz="950" dirty="0"/>
           </a:p>
@@ -6261,7 +6046,7 @@
           <a:noFill/>
         </p:spPr>
         <p:txBody>
-          <a:bodyPr wrap="square" lIns="0" rIns="0" tIns="0" bIns="0">
+          <a:bodyPr wrap="square" lIns="0" tIns="0" rIns="0" bIns="0">
             <a:spAutoFit/>
           </a:bodyPr>
           <a:lstStyle/>
@@ -6323,9 +6108,7 @@
           <a:lstStyle/>
           <a:p>
             <a:pPr algn="ctr"/>
-            <a:r>
-              <a:t/>
-            </a:r>
+            <a:endParaRPr/>
           </a:p>
         </p:txBody>
       </p:sp>
@@ -6346,7 +6129,7 @@
           <a:noFill/>
         </p:spPr>
         <p:txBody>
-          <a:bodyPr wrap="none" lIns="0" rIns="0" tIns="0" bIns="0">
+          <a:bodyPr wrap="none" lIns="0" tIns="0" rIns="0" bIns="0">
             <a:spAutoFit/>
           </a:bodyPr>
           <a:lstStyle/>
@@ -6380,7 +6163,7 @@
           <a:noFill/>
         </p:spPr>
         <p:txBody>
-          <a:bodyPr wrap="square" lIns="0" rIns="0" tIns="0" bIns="0">
+          <a:bodyPr wrap="square" lIns="0" tIns="0" rIns="0" bIns="0">
             <a:spAutoFit/>
           </a:bodyPr>
           <a:lstStyle/>
@@ -6438,7 +6221,7 @@
           </a:fontRef>
         </p:style>
         <p:txBody>
-          <a:bodyPr rtlCol="0" anchor="ctr" lIns="155448" rIns="155448" tIns="73152" bIns="73152" wrap="square"/>
+          <a:bodyPr wrap="square" lIns="155448" tIns="73152" rIns="155448" bIns="73152" rtlCol="0" anchor="ctr"/>
           <a:lstStyle/>
           <a:p>
             <a:pPr algn="ctr"/>
@@ -6471,7 +6254,7 @@
           <a:noFill/>
         </p:spPr>
         <p:txBody>
-          <a:bodyPr wrap="square" lIns="0" rIns="0" tIns="0" bIns="0">
+          <a:bodyPr wrap="square" lIns="0" tIns="0" rIns="0" bIns="0">
             <a:spAutoFit/>
           </a:bodyPr>
           <a:lstStyle/>
@@ -6497,7 +6280,7 @@
 </file>
 
 <file path=ppt/slides/slide8.xml><?xml version="1.0" encoding="utf-8"?>
-<p:sld xmlns:a="http://schemas.openxmlformats.org/drawingml/2006/main" xmlns:p="http://schemas.openxmlformats.org/presentationml/2006/main" xmlns:r="http://schemas.openxmlformats.org/officeDocument/2006/relationships">
+<p:sld xmlns:a="http://schemas.openxmlformats.org/drawingml/2006/main" xmlns:r="http://schemas.openxmlformats.org/officeDocument/2006/relationships" xmlns:p="http://schemas.openxmlformats.org/presentationml/2006/main">
   <p:cSld>
     <p:spTree>
       <p:nvGrpSpPr>
@@ -6505,7 +6288,14 @@
         <p:cNvGrpSpPr/>
         <p:nvPr/>
       </p:nvGrpSpPr>
-      <p:grpSpPr/>
+      <p:grpSpPr>
+        <a:xfrm>
+          <a:off x="0" y="0"/>
+          <a:ext cx="0" cy="0"/>
+          <a:chOff x="0" y="0"/>
+          <a:chExt cx="0" cy="0"/>
+        </a:xfrm>
+      </p:grpSpPr>
       <p:sp>
         <p:nvSpPr>
           <p:cNvPr id="19" name="Rounded Rectangle 18"/>
@@ -6551,9 +6341,7 @@
           <a:lstStyle/>
           <a:p>
             <a:pPr algn="ctr"/>
-            <a:r>
-              <a:t/>
-            </a:r>
+            <a:endParaRPr/>
           </a:p>
         </p:txBody>
       </p:sp>
@@ -6694,7 +6482,7 @@
                 <a:ea typeface="Helvetica" pitchFamily="34" charset="-122"/>
                 <a:cs typeface="Helvetica" pitchFamily="34" charset="-120"/>
               </a:rPr>
-              <a:t>Modul 05 — Komunikasi Pelanggan (WA + Email)</a:t>
+              <a:t>Modul 05 — Komunikasi Pelanggan (WhatsApp)</a:t>
             </a:r>
             <a:endParaRPr lang="en-US" sz="1250" dirty="0"/>
           </a:p>
@@ -6902,7 +6690,7 @@
                 <a:ea typeface="Helvetica" pitchFamily="34" charset="-122"/>
                 <a:cs typeface="Helvetica" pitchFamily="34" charset="-120"/>
               </a:rPr>
-              <a:t>File pendukung: cm-template-wa.txt. Mau coba Email juga? cm-template-email.txt siap dipakai (opsional).</a:t>
+              <a:t>File pendukung: cm-template-wa.txt.</a:t>
             </a:r>
             <a:endParaRPr lang="en-US" sz="1100" dirty="0"/>
           </a:p>
@@ -6982,7 +6770,7 @@
           <a:noFill/>
         </p:spPr>
         <p:txBody>
-          <a:bodyPr wrap="none" lIns="0" rIns="0" tIns="0" bIns="0">
+          <a:bodyPr wrap="none" lIns="0" tIns="0" rIns="0" bIns="0">
             <a:spAutoFit/>
           </a:bodyPr>
           <a:lstStyle/>
@@ -7016,7 +6804,7 @@
           <a:noFill/>
         </p:spPr>
         <p:txBody>
-          <a:bodyPr wrap="square" lIns="0" rIns="0" tIns="0" bIns="0">
+          <a:bodyPr wrap="square" lIns="0" tIns="0" rIns="0" bIns="0">
             <a:spAutoFit/>
           </a:bodyPr>
           <a:lstStyle/>
@@ -7050,7 +6838,7 @@
           <a:noFill/>
         </p:spPr>
         <p:txBody>
-          <a:bodyPr wrap="square" lIns="0" rIns="0" tIns="0" bIns="0">
+          <a:bodyPr wrap="square" lIns="0" tIns="0" rIns="0" bIns="0">
             <a:spAutoFit/>
           </a:bodyPr>
           <a:lstStyle/>

</xml_diff>

<commit_message>
M05: remove redundant Buruk vs Baik section, wire Latihan 1-3 together
- Cut Contoh Prompt: Buruk vs Baik (redundant with Latihan 1+2, confusing sequencing)
- Latihan 1: brand voice now includes a signature line
- Latihan 2: output explicitly shows tone/signature carried over from Latihan 1
- Latihan 3: real customer-chat sample instead of abstract instruction
- PPTX: deleted redundant slide, fixed a pre-existing stale WA+Email eyebrow found during re-render, renumbered 8->7 slides

Checkpoint 105
</commit_message>
<xml_diff>
--- a/Content-Marketing/M05-Komunikasi-Pelanggan/K3-M05-Komunikasi-Pelanggan.pptx
+++ b/Content-Marketing/M05-Komunikasi-Pelanggan/K3-M05-Komunikasi-Pelanggan.pptx
@@ -11,7 +11,6 @@
     <p:sldId id="256" r:id="rId2"/>
     <p:sldId id="257" r:id="rId3"/>
     <p:sldId id="258" r:id="rId4"/>
-    <p:sldId id="259" r:id="rId5"/>
     <p:sldId id="260" r:id="rId6"/>
     <p:sldId id="261" r:id="rId7"/>
     <p:sldId id="262" r:id="rId8"/>
@@ -478,90 +477,6 @@
             <a:fld id="{F7021451-1387-4CA6-816F-3879F97B5CBC}" type="slidenum">
               <a:rPr lang="en-US"/>
               <a:t>3</a:t>
-            </a:fld>
-            <a:endParaRPr lang="en-US"/>
-          </a:p>
-        </p:txBody>
-      </p:sp>
-    </p:spTree>
-    <p:extLst>
-      <p:ext uri="{BB962C8B-B14F-4D97-AF65-F5344CB8AC3E}">
-        <p14:creationId xmlns:p14="http://schemas.microsoft.com/office/powerpoint/2010/main" val="1024086991"/>
-      </p:ext>
-    </p:extLst>
-  </p:cSld>
-  <p:clrMapOvr>
-    <a:masterClrMapping/>
-  </p:clrMapOvr>
-</p:notes>
-</file>
-
-<file path=ppt/notesSlides/notesSlide4.xml><?xml version="1.0" encoding="utf-8"?>
-<p:notes xmlns:a="http://schemas.openxmlformats.org/drawingml/2006/main" xmlns:r="http://schemas.openxmlformats.org/officeDocument/2006/relationships" xmlns:p="http://schemas.openxmlformats.org/presentationml/2006/main">
-  <p:cSld>
-    <p:spTree>
-      <p:nvGrpSpPr>
-        <p:cNvPr id="1" name=""/>
-        <p:cNvGrpSpPr/>
-        <p:nvPr/>
-      </p:nvGrpSpPr>
-      <p:grpSpPr>
-        <a:xfrm>
-          <a:off x="0" y="0"/>
-          <a:ext cx="0" cy="0"/>
-          <a:chOff x="0" y="0"/>
-          <a:chExt cx="0" cy="0"/>
-        </a:xfrm>
-      </p:grpSpPr>
-      <p:sp>
-        <p:nvSpPr>
-          <p:cNvPr id="2" name="Slide Image Placeholder 1"/>
-          <p:cNvSpPr>
-            <a:spLocks noGrp="1" noRot="1" noChangeAspect="1"/>
-          </p:cNvSpPr>
-          <p:nvPr>
-            <p:ph type="sldImg"/>
-          </p:nvPr>
-        </p:nvSpPr>
-        <p:spPr/>
-      </p:sp>
-      <p:sp>
-        <p:nvSpPr>
-          <p:cNvPr id="3" name="Notes Placeholder 2"/>
-          <p:cNvSpPr>
-            <a:spLocks noGrp="1"/>
-          </p:cNvSpPr>
-          <p:nvPr>
-            <p:ph type="body" idx="1"/>
-          </p:nvPr>
-        </p:nvSpPr>
-        <p:spPr/>
-        <p:txBody>
-          <a:bodyPr/>
-          <a:lstStyle/>
-          <a:p>
-            <a:endParaRPr lang="en-US" dirty="0"/>
-          </a:p>
-        </p:txBody>
-      </p:sp>
-      <p:sp>
-        <p:nvSpPr>
-          <p:cNvPr id="4" name="Slide Number Placeholder 3"/>
-          <p:cNvSpPr>
-            <a:spLocks noGrp="1"/>
-          </p:cNvSpPr>
-          <p:nvPr>
-            <p:ph type="sldNum" sz="quarter" idx="10"/>
-          </p:nvPr>
-        </p:nvSpPr>
-        <p:spPr/>
-        <p:txBody>
-          <a:bodyPr/>
-          <a:lstStyle/>
-          <a:p>
-            <a:fld id="{F7021451-1387-4CA6-816F-3879F97B5CBC}" type="slidenum">
-              <a:rPr lang="en-US"/>
-              <a:t>4</a:t>
             </a:fld>
             <a:endParaRPr lang="en-US"/>
           </a:p>
@@ -3040,409 +2955,6 @@
 
 <file path=ppt/slides/slide4.xml><?xml version="1.0" encoding="utf-8"?>
 <p:sld xmlns:a="http://schemas.openxmlformats.org/drawingml/2006/main" xmlns:r="http://schemas.openxmlformats.org/officeDocument/2006/relationships" xmlns:p="http://schemas.openxmlformats.org/presentationml/2006/main">
-  <p:cSld name="Slide 4">
-    <p:spTree>
-      <p:nvGrpSpPr>
-        <p:cNvPr id="1" name=""/>
-        <p:cNvGrpSpPr/>
-        <p:nvPr/>
-      </p:nvGrpSpPr>
-      <p:grpSpPr>
-        <a:xfrm>
-          <a:off x="0" y="0"/>
-          <a:ext cx="0" cy="0"/>
-          <a:chOff x="0" y="0"/>
-          <a:chExt cx="0" cy="0"/>
-        </a:xfrm>
-      </p:grpSpPr>
-      <p:sp>
-        <p:nvSpPr>
-          <p:cNvPr id="2" name="Shape 0"/>
-          <p:cNvSpPr/>
-          <p:nvPr/>
-        </p:nvSpPr>
-        <p:spPr>
-          <a:xfrm>
-            <a:off x="0" y="0"/>
-            <a:ext cx="12191695" cy="960120"/>
-          </a:xfrm>
-          <a:prstGeom prst="rect">
-            <a:avLst/>
-          </a:prstGeom>
-          <a:solidFill>
-            <a:srgbClr val="0D1321"/>
-          </a:solidFill>
-          <a:ln/>
-        </p:spPr>
-        <p:txBody>
-          <a:bodyPr/>
-          <a:lstStyle/>
-          <a:p>
-            <a:endParaRPr lang="en-ID"/>
-          </a:p>
-        </p:txBody>
-      </p:sp>
-      <p:sp>
-        <p:nvSpPr>
-          <p:cNvPr id="3" name="Shape 1"/>
-          <p:cNvSpPr/>
-          <p:nvPr/>
-        </p:nvSpPr>
-        <p:spPr>
-          <a:xfrm>
-            <a:off x="0" y="960120"/>
-            <a:ext cx="12191695" cy="41148"/>
-          </a:xfrm>
-          <a:prstGeom prst="rect">
-            <a:avLst/>
-          </a:prstGeom>
-          <a:solidFill>
-            <a:srgbClr val="6849F6"/>
-          </a:solidFill>
-          <a:ln/>
-        </p:spPr>
-        <p:txBody>
-          <a:bodyPr/>
-          <a:lstStyle/>
-          <a:p>
-            <a:endParaRPr lang="en-ID"/>
-          </a:p>
-        </p:txBody>
-      </p:sp>
-      <p:sp>
-        <p:nvSpPr>
-          <p:cNvPr id="4" name="Text 2"/>
-          <p:cNvSpPr/>
-          <p:nvPr/>
-        </p:nvSpPr>
-        <p:spPr>
-          <a:xfrm>
-            <a:off x="502920" y="256032"/>
-            <a:ext cx="3657600" cy="457200"/>
-          </a:xfrm>
-          <a:prstGeom prst="rect">
-            <a:avLst/>
-          </a:prstGeom>
-          <a:noFill/>
-          <a:ln/>
-        </p:spPr>
-        <p:txBody>
-          <a:bodyPr wrap="square" lIns="0" tIns="0" rIns="0" bIns="0" rtlCol="0" anchor="ctr"/>
-          <a:lstStyle/>
-          <a:p>
-            <a:pPr marL="0" indent="0">
-              <a:buNone/>
-            </a:pPr>
-            <a:r>
-              <a:rPr lang="en-US" sz="2000" b="1" dirty="0">
-                <a:solidFill>
-                  <a:srgbClr val="FFFFFF"/>
-                </a:solidFill>
-                <a:latin typeface="Helvetica" pitchFamily="34" charset="0"/>
-                <a:ea typeface="Helvetica" pitchFamily="34" charset="-122"/>
-                <a:cs typeface="Helvetica" pitchFamily="34" charset="-120"/>
-              </a:rPr>
-              <a:t>belajar</a:t>
-            </a:r>
-            <a:r>
-              <a:rPr lang="en-US" sz="2000" b="1" dirty="0">
-                <a:solidFill>
-                  <a:srgbClr val="8B7CF6"/>
-                </a:solidFill>
-                <a:latin typeface="Helvetica" pitchFamily="34" charset="0"/>
-                <a:ea typeface="Helvetica" pitchFamily="34" charset="-122"/>
-                <a:cs typeface="Helvetica" pitchFamily="34" charset="-120"/>
-              </a:rPr>
-              <a:t>claude</a:t>
-            </a:r>
-            <a:endParaRPr lang="en-US" sz="2000" dirty="0"/>
-          </a:p>
-        </p:txBody>
-      </p:sp>
-      <p:sp>
-        <p:nvSpPr>
-          <p:cNvPr id="5" name="Text 3"/>
-          <p:cNvSpPr/>
-          <p:nvPr/>
-        </p:nvSpPr>
-        <p:spPr>
-          <a:xfrm>
-            <a:off x="5943600" y="274320"/>
-            <a:ext cx="5760720" cy="411480"/>
-          </a:xfrm>
-          <a:prstGeom prst="rect">
-            <a:avLst/>
-          </a:prstGeom>
-          <a:noFill/>
-          <a:ln/>
-        </p:spPr>
-        <p:txBody>
-          <a:bodyPr wrap="square" lIns="0" tIns="0" rIns="0" bIns="0" rtlCol="0" anchor="ctr"/>
-          <a:lstStyle/>
-          <a:p>
-            <a:pPr marL="0" indent="0" algn="r">
-              <a:buNone/>
-            </a:pPr>
-            <a:r>
-              <a:rPr lang="en-US" sz="1250" dirty="0">
-                <a:solidFill>
-                  <a:srgbClr val="9AA2B4"/>
-                </a:solidFill>
-                <a:latin typeface="Helvetica" pitchFamily="34" charset="0"/>
-                <a:ea typeface="Helvetica" pitchFamily="34" charset="-122"/>
-                <a:cs typeface="Helvetica" pitchFamily="34" charset="-120"/>
-              </a:rPr>
-              <a:t>Modul 05 — Komunikasi Pelanggan (WhatsApp)</a:t>
-            </a:r>
-            <a:endParaRPr lang="en-US" sz="1250" dirty="0"/>
-          </a:p>
-        </p:txBody>
-      </p:sp>
-      <p:sp>
-        <p:nvSpPr>
-          <p:cNvPr id="6" name="Text 4"/>
-          <p:cNvSpPr/>
-          <p:nvPr/>
-        </p:nvSpPr>
-        <p:spPr>
-          <a:xfrm>
-            <a:off x="502920" y="1170432"/>
-            <a:ext cx="11064240" cy="274320"/>
-          </a:xfrm>
-          <a:prstGeom prst="rect">
-            <a:avLst/>
-          </a:prstGeom>
-          <a:noFill/>
-          <a:ln/>
-        </p:spPr>
-        <p:txBody>
-          <a:bodyPr wrap="square" lIns="0" tIns="0" rIns="0" bIns="0" rtlCol="0" anchor="ctr"/>
-          <a:lstStyle/>
-          <a:p>
-            <a:pPr marL="0" indent="0">
-              <a:buNone/>
-            </a:pPr>
-            <a:r>
-              <a:rPr lang="en-US" sz="1250" b="1" kern="0" spc="40" dirty="0">
-                <a:solidFill>
-                  <a:srgbClr val="4B36C7"/>
-                </a:solidFill>
-                <a:latin typeface="Helvetica" pitchFamily="34" charset="0"/>
-                <a:ea typeface="Helvetica" pitchFamily="34" charset="-122"/>
-                <a:cs typeface="Helvetica" pitchFamily="34" charset="-120"/>
-              </a:rPr>
-              <a:t>SATU KALIMAT SUDAH CUKUP, KONTEKS SUDAH TERSIMPAN</a:t>
-            </a:r>
-            <a:endParaRPr lang="en-US" sz="1250" dirty="0"/>
-          </a:p>
-        </p:txBody>
-      </p:sp>
-      <p:sp>
-        <p:nvSpPr>
-          <p:cNvPr id="7" name="Text 5"/>
-          <p:cNvSpPr/>
-          <p:nvPr/>
-        </p:nvSpPr>
-        <p:spPr>
-          <a:xfrm>
-            <a:off x="502920" y="1444752"/>
-            <a:ext cx="11064240" cy="548640"/>
-          </a:xfrm>
-          <a:prstGeom prst="rect">
-            <a:avLst/>
-          </a:prstGeom>
-          <a:noFill/>
-          <a:ln/>
-        </p:spPr>
-        <p:txBody>
-          <a:bodyPr wrap="square" lIns="0" tIns="0" rIns="0" bIns="0" rtlCol="0" anchor="ctr"/>
-          <a:lstStyle/>
-          <a:p>
-            <a:pPr marL="0" indent="0">
-              <a:buNone/>
-            </a:pPr>
-            <a:r>
-              <a:rPr lang="en-US" sz="2200" b="1" dirty="0">
-                <a:solidFill>
-                  <a:srgbClr val="0D1321"/>
-                </a:solidFill>
-                <a:latin typeface="Helvetica" pitchFamily="34" charset="0"/>
-                <a:ea typeface="Helvetica" pitchFamily="34" charset="-122"/>
-                <a:cs typeface="Helvetica" pitchFamily="34" charset="-120"/>
-              </a:rPr>
-              <a:t>Prompt Siap Pakai</a:t>
-            </a:r>
-            <a:endParaRPr lang="en-US" sz="2200" dirty="0"/>
-          </a:p>
-        </p:txBody>
-      </p:sp>
-      <p:sp>
-        <p:nvSpPr>
-          <p:cNvPr id="8" name="Shape 6"/>
-          <p:cNvSpPr/>
-          <p:nvPr/>
-        </p:nvSpPr>
-        <p:spPr>
-          <a:xfrm>
-            <a:off x="502920" y="2121408"/>
-            <a:ext cx="11064240" cy="1783080"/>
-          </a:xfrm>
-          <a:prstGeom prst="roundRect">
-            <a:avLst>
-              <a:gd name="adj" fmla="val 4000"/>
-            </a:avLst>
-          </a:prstGeom>
-          <a:solidFill>
-            <a:srgbClr val="EAFAF0"/>
-          </a:solidFill>
-          <a:ln w="12700">
-            <a:solidFill>
-              <a:srgbClr val="B8E6C9"/>
-            </a:solidFill>
-            <a:prstDash val="solid"/>
-          </a:ln>
-        </p:spPr>
-        <p:txBody>
-          <a:bodyPr/>
-          <a:lstStyle/>
-          <a:p>
-            <a:endParaRPr lang="en-ID"/>
-          </a:p>
-        </p:txBody>
-      </p:sp>
-      <p:sp>
-        <p:nvSpPr>
-          <p:cNvPr id="9" name="Text 7"/>
-          <p:cNvSpPr/>
-          <p:nvPr/>
-        </p:nvSpPr>
-        <p:spPr>
-          <a:xfrm>
-            <a:off x="713232" y="2304288"/>
-            <a:ext cx="10607040" cy="274320"/>
-          </a:xfrm>
-          <a:prstGeom prst="rect">
-            <a:avLst/>
-          </a:prstGeom>
-          <a:noFill/>
-          <a:ln/>
-        </p:spPr>
-        <p:txBody>
-          <a:bodyPr wrap="square" lIns="0" tIns="0" rIns="0" bIns="0" rtlCol="0" anchor="ctr"/>
-          <a:lstStyle/>
-          <a:p>
-            <a:pPr marL="0" indent="0">
-              <a:buNone/>
-            </a:pPr>
-            <a:r>
-              <a:rPr lang="en-US" sz="1150" b="1" kern="0" spc="30" dirty="0">
-                <a:solidFill>
-                  <a:srgbClr val="1A7A44"/>
-                </a:solidFill>
-                <a:latin typeface="Helvetica" pitchFamily="34" charset="0"/>
-                <a:ea typeface="Helvetica" pitchFamily="34" charset="-122"/>
-                <a:cs typeface="Helvetica" pitchFamily="34" charset="-120"/>
-              </a:rPr>
-              <a:t>WHATSAPP — VIA CLAUDE PROJECTS</a:t>
-            </a:r>
-            <a:endParaRPr lang="en-US" sz="1150" dirty="0"/>
-          </a:p>
-        </p:txBody>
-      </p:sp>
-      <p:sp>
-        <p:nvSpPr>
-          <p:cNvPr id="10" name="Text 8"/>
-          <p:cNvSpPr/>
-          <p:nvPr/>
-        </p:nvSpPr>
-        <p:spPr>
-          <a:xfrm>
-            <a:off x="713232" y="2606040"/>
-            <a:ext cx="10607040" cy="685800"/>
-          </a:xfrm>
-          <a:prstGeom prst="rect">
-            <a:avLst/>
-          </a:prstGeom>
-          <a:noFill/>
-          <a:ln/>
-        </p:spPr>
-        <p:txBody>
-          <a:bodyPr wrap="square" lIns="0" tIns="0" rIns="0" bIns="0" rtlCol="0" anchor="ctr"/>
-          <a:lstStyle/>
-          <a:p>
-            <a:pPr marL="0" indent="0">
-              <a:lnSpc>
-                <a:spcPct val="125000"/>
-              </a:lnSpc>
-              <a:buNone/>
-            </a:pPr>
-            <a:r>
-              <a:rPr lang="en-US" sz="1150" i="1" dirty="0">
-                <a:solidFill>
-                  <a:srgbClr val="23283A"/>
-                </a:solidFill>
-                <a:latin typeface="Helvetica" pitchFamily="34" charset="0"/>
-                <a:ea typeface="Helvetica" pitchFamily="34" charset="-122"/>
-                <a:cs typeface="Helvetica" pitchFamily="34" charset="-120"/>
-              </a:rPr>
-              <a:t>"[Claude Project sudah punya profil bisnis, tone santai-hangat, sapaan 'Kak'] Buatkan template WA untuk Skenario 1 dari cm-template-wa.txt: calon pembeli tanya harga pertama kali. Maks 4 baris, emoji 1-2, ada CTA ke katalog."</a:t>
-            </a:r>
-            <a:endParaRPr lang="en-US" sz="1150" dirty="0"/>
-          </a:p>
-        </p:txBody>
-      </p:sp>
-      <p:sp>
-        <p:nvSpPr>
-          <p:cNvPr id="11" name="Text 9"/>
-          <p:cNvSpPr/>
-          <p:nvPr/>
-        </p:nvSpPr>
-        <p:spPr>
-          <a:xfrm>
-            <a:off x="713232" y="3429000"/>
-            <a:ext cx="10607040" cy="502920"/>
-          </a:xfrm>
-          <a:prstGeom prst="rect">
-            <a:avLst/>
-          </a:prstGeom>
-          <a:noFill/>
-          <a:ln/>
-        </p:spPr>
-        <p:txBody>
-          <a:bodyPr wrap="square" lIns="0" tIns="0" rIns="0" bIns="0" rtlCol="0" anchor="ctr"/>
-          <a:lstStyle/>
-          <a:p>
-            <a:pPr marL="0" indent="0">
-              <a:lnSpc>
-                <a:spcPct val="125000"/>
-              </a:lnSpc>
-              <a:buNone/>
-            </a:pPr>
-            <a:r>
-              <a:rPr lang="en-US" sz="1050" dirty="0">
-                <a:solidFill>
-                  <a:srgbClr val="3F6B52"/>
-                </a:solidFill>
-                <a:latin typeface="Helvetica" pitchFamily="34" charset="0"/>
-                <a:ea typeface="Helvetica" pitchFamily="34" charset="-122"/>
-                <a:cs typeface="Helvetica" pitchFamily="34" charset="-120"/>
-              </a:rPr>
-              <a:t>Kenapa berhasil: dengan Projects aktif, 1 kalimat instruksi sudah cukup. Hasilnya kamu copy-paste manual ke WhatsApp (belum ada WA Connector).</a:t>
-            </a:r>
-            <a:endParaRPr lang="en-US" sz="1050" dirty="0"/>
-          </a:p>
-        </p:txBody>
-      </p:sp>
-    </p:spTree>
-  </p:cSld>
-  <p:clrMapOvr>
-    <a:masterClrMapping/>
-  </p:clrMapOvr>
-</p:sld>
-</file>
-
-<file path=ppt/slides/slide5.xml><?xml version="1.0" encoding="utf-8"?>
-<p:sld xmlns:a="http://schemas.openxmlformats.org/drawingml/2006/main" xmlns:r="http://schemas.openxmlformats.org/officeDocument/2006/relationships" xmlns:p="http://schemas.openxmlformats.org/presentationml/2006/main">
   <p:cSld name="Slide 5">
     <p:spTree>
       <p:nvGrpSpPr>
@@ -3634,7 +3146,7 @@
                 <a:ea typeface="Helvetica" pitchFamily="34" charset="-122"/>
                 <a:cs typeface="Helvetica" pitchFamily="34" charset="-120"/>
               </a:rPr>
-              <a:t>DUA KANAL, DUA ALUR — PANJANG BERBEDA KARENA SETUP BERBEDA</a:t>
+              <a:t>SATU ALUR, EMPAT LANGKAH</a:t>
             </a:r>
             <a:endParaRPr lang="en-US" sz="1250" dirty="0"/>
           </a:p>
@@ -3712,7 +3224,7 @@
                 <a:ea typeface="Helvetica" pitchFamily="34" charset="-122"/>
                 <a:cs typeface="Helvetica" pitchFamily="34" charset="-120"/>
               </a:rPr>
-              <a:t>WHATSAPP CS</a:t>
+              <a:t>CARA KERJA STEP-BY-STEP</a:t>
             </a:r>
             <a:endParaRPr lang="en-US" sz="1250" dirty="0"/>
           </a:p>
@@ -4164,7 +3676,7 @@
 </p:sld>
 </file>
 
-<file path=ppt/slides/slide6.xml><?xml version="1.0" encoding="utf-8"?>
+<file path=ppt/slides/slide5.xml><?xml version="1.0" encoding="utf-8"?>
 <p:sld xmlns:a="http://schemas.openxmlformats.org/drawingml/2006/main" xmlns:r="http://schemas.openxmlformats.org/officeDocument/2006/relationships" xmlns:p="http://schemas.openxmlformats.org/presentationml/2006/main">
   <p:cSld name="Slide 6">
     <p:spTree>
@@ -5600,7 +5112,7 @@
 </p:sld>
 </file>
 
-<file path=ppt/slides/slide7.xml><?xml version="1.0" encoding="utf-8"?>
+<file path=ppt/slides/slide6.xml><?xml version="1.0" encoding="utf-8"?>
 <p:sld xmlns:a="http://schemas.openxmlformats.org/drawingml/2006/main" xmlns:r="http://schemas.openxmlformats.org/officeDocument/2006/relationships" xmlns:p="http://schemas.openxmlformats.org/presentationml/2006/main">
   <p:cSld name="Slide 7">
     <p:spTree>
@@ -6023,7 +5535,7 @@
                 <a:ea typeface="Helvetica" pitchFamily="34" charset="-122"/>
                 <a:cs typeface="Helvetica" pitchFamily="34" charset="-120"/>
               </a:rPr>
-              <a:t>Brand voice untuk komunikasi pelanggan: tone santai-hangat, sapaan "Kak", batasan emoji 1-2/pesan.</a:t>
+              <a:t>Brand voice untuk komunikasi pelanggan: tone santai-hangat, sapaan "Kak", batasan emoji 1-2/pesan, tutup pesan dengan "Salam hangat, Dapur Rara".</a:t>
             </a:r>
             <a:endParaRPr lang="en-US" sz="950" dirty="0"/>
           </a:p>
@@ -6266,7 +5778,7 @@
                 </a:solidFill>
                 <a:latin typeface="Helvetica"/>
               </a:rPr>
-              <a:t>✅ Output: 10 template WA dasar tersimpan — jadi acuan Latihan 3</a:t>
+              <a:t>✅ Output: 10 template WA dasar tersimpan — otomatis pakai tone &amp; signature dari Latihan 1</a:t>
             </a:r>
           </a:p>
         </p:txBody>
@@ -6279,7 +5791,7 @@
 </p:sld>
 </file>
 
-<file path=ppt/slides/slide8.xml><?xml version="1.0" encoding="utf-8"?>
+<file path=ppt/slides/slide7.xml><?xml version="1.0" encoding="utf-8"?>
 <p:sld xmlns:a="http://schemas.openxmlformats.org/drawingml/2006/main" xmlns:r="http://schemas.openxmlformats.org/officeDocument/2006/relationships" xmlns:p="http://schemas.openxmlformats.org/presentationml/2006/main">
   <p:cSld>
     <p:spTree>
@@ -6704,8 +6216,8 @@
         </p:nvSpPr>
         <p:spPr>
           <a:xfrm>
-            <a:off x="713232" y="3456432"/>
-            <a:ext cx="10607040" cy="566928"/>
+            <a:off x="713232" y="3320000"/>
+            <a:ext cx="10607040" cy="685800"/>
           </a:xfrm>
           <a:prstGeom prst="roundRect">
             <a:avLst>
@@ -6748,7 +6260,7 @@
                 </a:solidFill>
                 <a:latin typeface="Helvetica"/>
               </a:rPr>
-              <a:t>"Balas WA: pembeli minta diskon tambahan karena mau beli 5 pcs sekaligus."</a:t>
+              <a:t>Balas chat WA ini pakai brand voice dari Project-ku: "Kak, boleh kurang lagi ga harganya kalau aku ambil 5 pcs sekaligus?"</a:t>
             </a:r>
           </a:p>
         </p:txBody>
@@ -6796,7 +6308,7 @@
         <p:spPr>
           <a:xfrm>
             <a:off x="713232" y="2542032"/>
-            <a:ext cx="10607040" cy="777240"/>
+            <a:ext cx="10607040" cy="310000"/>
           </a:xfrm>
           <a:prstGeom prst="rect">
             <a:avLst/>
@@ -6816,7 +6328,7 @@
                 </a:solidFill>
                 <a:latin typeface="Helvetica"/>
               </a:rPr>
-              <a:t>Begitu ada pembeli chat beneran, jangan buka file template — ketik situasinya langsung ke Claude, otomatis cocok ke skenario yang sesuai. Ulangi minimal 5x/minggu, catat respons pelanggan.</a:t>
+              <a:t>Begitu ada pembeli chat beneran, jangan buka file template. Contoh chat masuk:</a:t>
             </a:r>
           </a:p>
         </p:txBody>
@@ -6829,8 +6341,8 @@
         </p:nvSpPr>
         <p:spPr>
           <a:xfrm>
-            <a:off x="713232" y="4114800"/>
-            <a:ext cx="10607040" cy="274320"/>
+            <a:off x="713232" y="4097000"/>
+            <a:ext cx="10607040" cy="320040"/>
           </a:xfrm>
           <a:prstGeom prst="rect">
             <a:avLst/>
@@ -6850,7 +6362,41 @@
                 </a:solidFill>
                 <a:latin typeface="Helvetica"/>
               </a:rPr>
-              <a:t>✅ Output: balasan personal siap pakai, on-the-spot, untuk kasus baru kapanpun</a:t>
+              <a:t>✅ Output: balasan personal siap pakai, on-the-spot. Copy-paste ke WhatsApp, kirim. Ulangi 5x/minggu untuk situasi berbeda.</a:t>
+            </a:r>
+          </a:p>
+        </p:txBody>
+      </p:sp>
+      <p:sp>
+        <p:nvSpPr>
+          <p:cNvPr id="23" name="TextBox 22"/>
+          <p:cNvSpPr txBox="1"/>
+          <p:nvPr/>
+        </p:nvSpPr>
+        <p:spPr>
+          <a:xfrm>
+            <a:off x="713232" y="2888000"/>
+            <a:ext cx="10607040" cy="310000"/>
+          </a:xfrm>
+          <a:prstGeom prst="rect">
+            <a:avLst/>
+          </a:prstGeom>
+          <a:noFill/>
+        </p:spPr>
+        <p:txBody>
+          <a:bodyPr wrap="square">
+            <a:spAutoFit/>
+          </a:bodyPr>
+          <a:lstStyle/>
+          <a:p>
+            <a:r>
+              <a:rPr sz="1200" i="1">
+                <a:solidFill>
+                  <a:srgbClr val="23283A"/>
+                </a:solidFill>
+                <a:latin typeface="Helvetica"/>
+              </a:rPr>
+              <a:t>"Kak, boleh kurang lagi ga harganya kalau aku ambil 5 pcs sekaligus?"</a:t>
             </a:r>
           </a:p>
         </p:txBody>

</xml_diff>

<commit_message>
M05: Latihan 2 now saves generated templates back to Project Knowledge; Latihan 3 matches real messages to those templates instead of generating from scratch
</commit_message>
<xml_diff>
--- a/Content-Marketing/M05-Komunikasi-Pelanggan/K3-M05-Komunikasi-Pelanggan.pptx
+++ b/Content-Marketing/M05-Komunikasi-Pelanggan/K3-M05-Komunikasi-Pelanggan.pptx
@@ -3440,7 +3440,7 @@
                 <a:ea typeface="Helvetica" pitchFamily="34" charset="-122"/>
                 <a:cs typeface="Helvetica" pitchFamily="34" charset="-120"/>
               </a:rPr>
-              <a:t>Generate 10 template dasar sekali di awal — Claude sudah tahu konteks bisnis</a:t>
+              <a:t>Generate 10 template dasar, lalu simpan hasilnya sebagai file baru dan upload lagi ke Project Knowledge</a:t>
             </a:r>
             <a:endParaRPr lang="en-US" sz="1100" dirty="0"/>
           </a:p>
@@ -3548,7 +3548,7 @@
                 <a:ea typeface="Helvetica" pitchFamily="34" charset="-122"/>
                 <a:cs typeface="Helvetica" pitchFamily="34" charset="-120"/>
               </a:rPr>
-              <a:t>Pas ada pembeli chat: ketik situasinya ke Claude — otomatis cocok ke skenario, generate balasan siap pakai</a:t>
+              <a:t>Pas ada pembeli chat: paste pesannya ke Claude, minta cocokkan ke salah satu dari 10 template yang sudah diupload</a:t>
             </a:r>
             <a:endParaRPr lang="en-US" sz="1100" dirty="0"/>
           </a:p>
@@ -5667,7 +5667,7 @@
                 </a:solidFill>
                 <a:latin typeface="Helvetica"/>
               </a:rPr>
-              <a:t>Upload cm-template-wa.txt ke Project Knowledge — sudah siap pakai, tidak perlu diisi apapun.</a:t>
+              <a:t>Langkah 1 — Upload cm-template-wa.txt ke Project Knowledge (siap pakai, tidak perlu diisi apapun).</a:t>
             </a:r>
           </a:p>
         </p:txBody>
@@ -5758,7 +5758,7 @@
                 </a:solidFill>
                 <a:latin typeface="Helvetica"/>
               </a:rPr>
-              <a:t>✅ Output: 10 template WA dasar tersimpan — otomatis pakai tone &amp; signature dari Latihan 1</a:t>
+              <a:t>✅ Output: 10 template WA dasar — pakai tone Latihan 1. Langkah 2: simpan hasilnya, upload lagi ke Project Knowledge.</a:t>
             </a:r>
           </a:p>
         </p:txBody>
@@ -6052,7 +6052,7 @@
                 <a:ea typeface="Helvetica" pitchFamily="34" charset="-122"/>
                 <a:cs typeface="Helvetica" pitchFamily="34" charset="-120"/>
               </a:rPr>
-              <a:t>Latihan 3: Reuse untuk Kasus Nyata</a:t>
+              <a:t>Latihan 3: Cocokkan ke Salah Satu Skenario</a:t>
             </a:r>
             <a:endParaRPr lang="en-US" sz="2200" dirty="0"/>
           </a:p>
@@ -6162,7 +6162,7 @@
                 <a:ea typeface="Helvetica" pitchFamily="34" charset="-122"/>
                 <a:cs typeface="Helvetica" pitchFamily="34" charset="-120"/>
               </a:rPr>
-              <a:t>1 Claude Project dengan brand voice CS aktif (Latihan 1) + 10 template WhatsApp dasar (Latihan 2) + kemampuan generate balasan on-the-spot untuk kasus baru kapanpun (Latihan 3).</a:t>
+              <a:t>1 Claude Project dengan brand voice CS aktif (Latihan 1) + 10 template WhatsApp jadi tersimpan permanen di Project Knowledge (Latihan 2) + kemampuan mencocokkan pesan pembeli asli ke salah satu dari 10 template itu (Latihan 3).</a:t>
             </a:r>
             <a:endParaRPr lang="en-US" sz="1100" dirty="0"/>
           </a:p>
@@ -6240,7 +6240,7 @@
                 </a:solidFill>
                 <a:latin typeface="Helvetica"/>
               </a:rPr>
-              <a:t>Balas chat WA ini pakai brand voice dari Project-ku: "Kak, boleh kurang lagi ga harganya kalau aku ambil 5 pcs sekaligus?"</a:t>
+              <a:t>Cocokkan pesan ini ke salah satu dari 10 template yang sudah aku upload, lalu sesuaikan: "Kak, boleh kurang lagi ga harganya kalau aku ambil 5 pcs sekaligus?"</a:t>
             </a:r>
           </a:p>
         </p:txBody>
@@ -6274,7 +6274,7 @@
                 </a:solidFill>
                 <a:latin typeface="Helvetica"/>
               </a:rPr>
-              <a:t>■  LATIHAN 3 — REUSE UNTUK KASUS NYATA</a:t>
+              <a:t>■  LATIHAN 3 — COCOKKAN KE SALAH SATU SKENARIO</a:t>
             </a:r>
           </a:p>
         </p:txBody>
@@ -6308,7 +6308,7 @@
                 </a:solidFill>
                 <a:latin typeface="Helvetica"/>
               </a:rPr>
-              <a:t>Begitu ada pembeli chat beneran, jangan buka file template. Contoh chat masuk:</a:t>
+              <a:t>Begitu ada pembeli chat beneran — ini cocok Skenario 8 (negosiasi harga) dari 10 template yang sudah diupload:</a:t>
             </a:r>
           </a:p>
         </p:txBody>
@@ -6342,7 +6342,7 @@
                 </a:solidFill>
                 <a:latin typeface="Helvetica"/>
               </a:rPr>
-              <a:t>✅ Output: balasan personal siap pakai, on-the-spot. Copy-paste ke WhatsApp, kirim. Ulangi 5x/minggu untuk situasi berbeda.</a:t>
+              <a:t>✅ Output: balasan hasil adaptasi dari Skenario 8 — bukan generate dari nol. Copy-paste ke WhatsApp, kirim. Ulangi 5x/minggu untuk situasi berbeda.</a:t>
             </a:r>
           </a:p>
         </p:txBody>

</xml_diff>

<commit_message>
M05: simplify to Julia's 3-latihan design — upload once (L2), reuse the file's own built-in Prompt Siap Pakai for every real case (L3), no more generate-then-reupload cycle
</commit_message>
<xml_diff>
--- a/Content-Marketing/M05-Komunikasi-Pelanggan/K3-M05-Komunikasi-Pelanggan.pptx
+++ b/Content-Marketing/M05-Komunikasi-Pelanggan/K3-M05-Komunikasi-Pelanggan.pptx
@@ -2188,7 +2188,7 @@
         <p:spPr>
           <a:xfrm>
             <a:off x="713232" y="4041648"/>
-            <a:ext cx="10607040" cy="1005840"/>
+            <a:ext cx="10607040" cy="1080000"/>
           </a:xfrm>
           <a:prstGeom prst="rect">
             <a:avLst/>
@@ -2215,7 +2215,7 @@
                 <a:ea typeface="Helvetica" pitchFamily="34" charset="-122"/>
                 <a:cs typeface="Helvetica" pitchFamily="34" charset="-120"/>
               </a:rPr>
-              <a:t>Level: Claude Projects (semua plan termasuk Free) · Setup: 5 menit sekali. Tambahkan brand voice khusus komunikasi pelanggan — sapaan, batasan, tone untuk CS — ke Claude Project dari Modul 1, yang sudah punya positioning dan identitas visual bisnismu. Upload cm-template-wa.txt ke Project Knowledge — file ini sengaja tidak berisi info bisnis lagi, cuma 10 skenario. Belum ada WA Connector — jadi generate di chat, lalu copy-paste manual ke WhatsApp-mu, selalu begitu.</a:t>
+              <a:t>Level: Claude Projects (semua plan termasuk Free) · Setup: 5 menit sekali. Tambahkan brand voice khusus komunikasi pelanggan — sapaan, batasan, tone untuk CS — ke Claude Project dari Modul 1, yang sudah punya positioning dan identitas visual bisnismu. Upload cm-template-wa.txt ke Project Knowledge — file ini berisi 10 skenario dan satu Prompt Siap Pakai yang tinggal diisi pesan pembeli, dipakai berulang kapan saja. Belum ada WA Connector — jadi generate di chat, lalu copy-paste manual ke WhatsApp-mu, selalu begitu.</a:t>
             </a:r>
             <a:endParaRPr lang="en-US" sz="1200" dirty="0"/>
           </a:p>
@@ -3146,7 +3146,7 @@
                 <a:ea typeface="Helvetica" pitchFamily="34" charset="-122"/>
                 <a:cs typeface="Helvetica" pitchFamily="34" charset="-120"/>
               </a:rPr>
-              <a:t>SATU ALUR, EMPAT LANGKAH</a:t>
+              <a:t>SATU ALUR, TIGA LANGKAH</a:t>
             </a:r>
             <a:endParaRPr lang="en-US" sz="1250" dirty="0"/>
           </a:p>
@@ -3332,7 +3332,7 @@
                 <a:ea typeface="Helvetica" pitchFamily="34" charset="-122"/>
                 <a:cs typeface="Helvetica" pitchFamily="34" charset="-120"/>
               </a:rPr>
-              <a:t>Tambahkan brand voice CS ke Project Modul 1, lalu upload cm-template-wa.txt ke Project Knowledge</a:t>
+              <a:t>Tambahkan brand voice CS ke Claude Project dari Modul 1 — dilakukan sekali saja</a:t>
             </a:r>
             <a:endParaRPr lang="en-US" sz="1100" dirty="0"/>
           </a:p>
@@ -3440,7 +3440,7 @@
                 <a:ea typeface="Helvetica" pitchFamily="34" charset="-122"/>
                 <a:cs typeface="Helvetica" pitchFamily="34" charset="-120"/>
               </a:rPr>
-              <a:t>Generate 10 template dasar, lalu simpan hasilnya sebagai file baru dan upload lagi ke Project Knowledge</a:t>
+              <a:t>Upload cm-template-wa.txt ke Project Knowledge — dilakukan sekali saja. File ini sudah lengkap: 10 skenario + prompt siap pakai</a:t>
             </a:r>
             <a:endParaRPr lang="en-US" sz="1100" dirty="0"/>
           </a:p>
@@ -3548,123 +3548,9 @@
                 <a:ea typeface="Helvetica" pitchFamily="34" charset="-122"/>
                 <a:cs typeface="Helvetica" pitchFamily="34" charset="-120"/>
               </a:rPr>
-              <a:t>Pas ada pembeli chat: paste pesannya ke Claude, minta cocokkan ke salah satu dari 10 template yang sudah diupload</a:t>
+              <a:t>Pas ada pembeli beneran chat: cocokkan ke salah satu dari 10 skenario, isi prompt siap pakai di file dengan pesan aslinya, kirim ke Claude, lalu copy-paste balasannya ke WhatsApp</a:t>
             </a:r>
             <a:endParaRPr lang="en-US" sz="1100" dirty="0"/>
-          </a:p>
-        </p:txBody>
-      </p:sp>
-      <p:sp>
-        <p:nvSpPr>
-          <p:cNvPr id="33" name="Oval 32"/>
-          <p:cNvSpPr/>
-          <p:nvPr/>
-        </p:nvSpPr>
-        <p:spPr>
-          <a:xfrm>
-            <a:off x="502920" y="4645152"/>
-            <a:ext cx="292608" cy="292608"/>
-          </a:xfrm>
-          <a:prstGeom prst="ellipse">
-            <a:avLst/>
-          </a:prstGeom>
-          <a:solidFill>
-            <a:srgbClr val="1A7A44"/>
-          </a:solidFill>
-          <a:ln>
-            <a:noFill/>
-          </a:ln>
-          <a:effectLst/>
-        </p:spPr>
-        <p:style>
-          <a:lnRef idx="1">
-            <a:schemeClr val="accent1"/>
-          </a:lnRef>
-          <a:fillRef idx="3">
-            <a:schemeClr val="accent1"/>
-          </a:fillRef>
-          <a:effectRef idx="2">
-            <a:schemeClr val="accent1"/>
-          </a:effectRef>
-          <a:fontRef idx="minor">
-            <a:schemeClr val="lt1"/>
-          </a:fontRef>
-        </p:style>
-        <p:txBody>
-          <a:bodyPr rtlCol="0" anchor="ctr"/>
-          <a:lstStyle/>
-          <a:p>
-            <a:pPr algn="ctr"/>
-            <a:endParaRPr/>
-          </a:p>
-        </p:txBody>
-      </p:sp>
-      <p:sp>
-        <p:nvSpPr>
-          <p:cNvPr id="34" name="TextBox 33"/>
-          <p:cNvSpPr txBox="1"/>
-          <p:nvPr/>
-        </p:nvSpPr>
-        <p:spPr>
-          <a:xfrm>
-            <a:off x="502920" y="4645152"/>
-            <a:ext cx="292608" cy="292608"/>
-          </a:xfrm>
-          <a:prstGeom prst="rect">
-            <a:avLst/>
-          </a:prstGeom>
-          <a:noFill/>
-        </p:spPr>
-        <p:txBody>
-          <a:bodyPr wrap="none" lIns="0" tIns="0" rIns="0" bIns="0" anchor="ctr">
-            <a:spAutoFit/>
-          </a:bodyPr>
-          <a:lstStyle/>
-          <a:p>
-            <a:pPr algn="ctr"/>
-            <a:r>
-              <a:rPr sz="1150" b="1">
-                <a:solidFill>
-                  <a:srgbClr val="FFFFFF"/>
-                </a:solidFill>
-                <a:latin typeface="Helvetica"/>
-              </a:rPr>
-              <a:t>4</a:t>
-            </a:r>
-          </a:p>
-        </p:txBody>
-      </p:sp>
-      <p:sp>
-        <p:nvSpPr>
-          <p:cNvPr id="35" name="TextBox 34"/>
-          <p:cNvSpPr txBox="1"/>
-          <p:nvPr/>
-        </p:nvSpPr>
-        <p:spPr>
-          <a:xfrm>
-            <a:off x="905256" y="4654183"/>
-            <a:ext cx="10332720" cy="338554"/>
-          </a:xfrm>
-          <a:prstGeom prst="rect">
-            <a:avLst/>
-          </a:prstGeom>
-          <a:noFill/>
-        </p:spPr>
-        <p:txBody>
-          <a:bodyPr wrap="square" lIns="0" tIns="0" rIns="0" bIns="0" anchor="ctr">
-            <a:spAutoFit/>
-          </a:bodyPr>
-          <a:lstStyle/>
-          <a:p>
-            <a:r>
-              <a:rPr sz="1100">
-                <a:solidFill>
-                  <a:srgbClr val="23283A"/>
-                </a:solidFill>
-                <a:latin typeface="Helvetica"/>
-              </a:rPr>
-              <a:t>Copy-paste balasan ke WhatsApp. Simpan 10 template dasar di catatan WA/Google Keep sebagai referensi cepat</a:t>
-            </a:r>
           </a:p>
         </p:txBody>
       </p:sp>
@@ -5324,7 +5210,7 @@
                 <a:ea typeface="Helvetica" pitchFamily="34" charset="-122"/>
                 <a:cs typeface="Helvetica" pitchFamily="34" charset="-120"/>
               </a:rPr>
-              <a:t>Latihan 1 &amp; 2: Setup Brand Voice + Generate Template</a:t>
+              <a:t>Latihan 1 &amp; 2: Setup Brand Voice + Upload Template</a:t>
             </a:r>
             <a:endParaRPr lang="en-US" sz="2200" dirty="0"/>
           </a:p>
@@ -5564,7 +5450,7 @@
         <p:spPr>
           <a:xfrm>
             <a:off x="502920" y="3913632"/>
-            <a:ext cx="11064240" cy="1737360"/>
+            <a:ext cx="11064240" cy="1575880"/>
           </a:xfrm>
           <a:prstGeom prst="roundRect">
             <a:avLst>
@@ -5633,7 +5519,7 @@
                 </a:solidFill>
                 <a:latin typeface="Helvetica"/>
               </a:rPr>
-              <a:t>■  LATIHAN 2 — GENERATE TEMPLATE DASAR</a:t>
+              <a:t>■  LATIHAN 2 — UPLOAD TEMPLATE SKENARIO</a:t>
             </a:r>
           </a:p>
         </p:txBody>
@@ -5667,64 +5553,7 @@
                 </a:solidFill>
                 <a:latin typeface="Helvetica"/>
               </a:rPr>
-              <a:t>Langkah 1 — Upload cm-template-wa.txt ke Project Knowledge (siap pakai, tidak perlu diisi apapun).</a:t>
-            </a:r>
-          </a:p>
-        </p:txBody>
-      </p:sp>
-      <p:sp>
-        <p:nvSpPr>
-          <p:cNvPr id="23" name="Rounded Rectangle 22"/>
-          <p:cNvSpPr/>
-          <p:nvPr/>
-        </p:nvSpPr>
-        <p:spPr>
-          <a:xfrm>
-            <a:off x="713232" y="4643987"/>
-            <a:ext cx="10607040" cy="594360"/>
-          </a:xfrm>
-          <a:prstGeom prst="roundRect">
-            <a:avLst>
-              <a:gd name="adj" fmla="val 10667"/>
-            </a:avLst>
-          </a:prstGeom>
-          <a:solidFill>
-            <a:srgbClr val="FFFFFF"/>
-          </a:solidFill>
-          <a:ln w="12700">
-            <a:solidFill>
-              <a:srgbClr val="B8E6C9"/>
-            </a:solidFill>
-          </a:ln>
-          <a:effectLst/>
-        </p:spPr>
-        <p:style>
-          <a:lnRef idx="1">
-            <a:schemeClr val="accent1"/>
-          </a:lnRef>
-          <a:fillRef idx="3">
-            <a:schemeClr val="accent1"/>
-          </a:fillRef>
-          <a:effectRef idx="2">
-            <a:schemeClr val="accent1"/>
-          </a:effectRef>
-          <a:fontRef idx="minor">
-            <a:schemeClr val="lt1"/>
-          </a:fontRef>
-        </p:style>
-        <p:txBody>
-          <a:bodyPr wrap="square" lIns="155448" tIns="73152" rIns="155448" bIns="73152" rtlCol="0" anchor="ctr"/>
-          <a:lstStyle/>
-          <a:p>
-            <a:pPr algn="ctr"/>
-            <a:r>
-              <a:rPr sz="950" i="1">
-                <a:solidFill>
-                  <a:srgbClr val="1A7A44"/>
-                </a:solidFill>
-                <a:latin typeface="Helvetica"/>
-              </a:rPr>
-              <a:t>Buatkan 10 template WhatsApp untuk skenario di cm-template-wa.txt.</a:t>
+              <a:t>Upload cm-template-wa.txt ke Project Knowledge — sudah siap pakai, tidak perlu diisi apapun. Dilakukan sekali saja, sama seperti Latihan 1.</a:t>
             </a:r>
           </a:p>
         </p:txBody>
@@ -5737,7 +5566,7 @@
         </p:nvSpPr>
         <p:spPr>
           <a:xfrm>
-            <a:off x="713232" y="5284067"/>
+            <a:off x="713232" y="5065192"/>
             <a:ext cx="10607040" cy="274320"/>
           </a:xfrm>
           <a:prstGeom prst="rect">
@@ -5758,7 +5587,7 @@
                 </a:solidFill>
                 <a:latin typeface="Helvetica"/>
               </a:rPr>
-              <a:t>✅ Output: 10 template WA dasar — pakai tone Latihan 1. Langkah 2: simpan hasilnya, upload lagi ke Project Knowledge.</a:t>
+              <a:t>✅ Output: cm-template-wa.txt tersimpan permanen — 10 skenario + prompt siap pakai bisa dipakai kapan saja, tanpa upload ulang.</a:t>
             </a:r>
           </a:p>
         </p:txBody>
@@ -5797,7 +5626,7 @@
         <p:spPr>
           <a:xfrm>
             <a:off x="502920" y="2084831"/>
-            <a:ext cx="11064240" cy="2377440"/>
+            <a:ext cx="11064240" cy="2546440"/>
           </a:xfrm>
           <a:prstGeom prst="roundRect">
             <a:avLst>
@@ -6052,7 +5881,7 @@
                 <a:ea typeface="Helvetica" pitchFamily="34" charset="-122"/>
                 <a:cs typeface="Helvetica" pitchFamily="34" charset="-120"/>
               </a:rPr>
-              <a:t>Latihan 3: Cocokkan ke Salah Satu Skenario</a:t>
+              <a:t>Latihan 3: Pakai Prompt Siap Pakai dari File</a:t>
             </a:r>
             <a:endParaRPr lang="en-US" sz="2200" dirty="0"/>
           </a:p>
@@ -6066,7 +5895,7 @@
         </p:nvSpPr>
         <p:spPr>
           <a:xfrm>
-            <a:off x="502920" y="4663440"/>
+            <a:off x="502920" y="4832440"/>
             <a:ext cx="11064240" cy="1691640"/>
           </a:xfrm>
           <a:prstGeom prst="roundRect">
@@ -6095,7 +5924,7 @@
         </p:nvSpPr>
         <p:spPr>
           <a:xfrm>
-            <a:off x="713232" y="4828032"/>
+            <a:off x="713232" y="4997032"/>
             <a:ext cx="10607040" cy="274320"/>
           </a:xfrm>
           <a:prstGeom prst="rect">
@@ -6134,7 +5963,7 @@
         </p:nvSpPr>
         <p:spPr>
           <a:xfrm>
-            <a:off x="713232" y="5120640"/>
+            <a:off x="713232" y="5289640"/>
             <a:ext cx="10607040" cy="1097280"/>
           </a:xfrm>
           <a:prstGeom prst="rect">
@@ -6162,7 +5991,7 @@
                 <a:ea typeface="Helvetica" pitchFamily="34" charset="-122"/>
                 <a:cs typeface="Helvetica" pitchFamily="34" charset="-120"/>
               </a:rPr>
-              <a:t>1 Claude Project dengan brand voice CS aktif (Latihan 1) + 10 template WhatsApp jadi tersimpan permanen di Project Knowledge (Latihan 2) + kemampuan mencocokkan pesan pembeli asli ke salah satu dari 10 template itu (Latihan 3).</a:t>
+              <a:t>1 Claude Project dengan brand voice CS aktif (Latihan 1) + cm-template-wa.txt tersimpan permanen di Project Knowledge (Latihan 2) + kemampuan generate balasan on-brand untuk pesan pembeli asli, kapanpun, pakai prompt siap pakai dari file itu (Latihan 3).</a:t>
             </a:r>
             <a:endParaRPr lang="en-US" sz="1100" dirty="0"/>
           </a:p>
@@ -6197,7 +6026,7 @@
         <p:spPr>
           <a:xfrm>
             <a:off x="713232" y="3320000"/>
-            <a:ext cx="10607040" cy="685800"/>
+            <a:ext cx="10607040" cy="750000"/>
           </a:xfrm>
           <a:prstGeom prst="roundRect">
             <a:avLst>
@@ -6240,7 +6069,7 @@
                 </a:solidFill>
                 <a:latin typeface="Helvetica"/>
               </a:rPr>
-              <a:t>Cocokkan pesan ini ke salah satu dari 10 template yang sudah aku upload, lalu sesuaikan: "Kak, boleh kurang lagi ga harganya kalau aku ambil 5 pcs sekaligus?"</a:t>
+              <a:t>Buatkan template WhatsApp untuk skenario berikut, pakai brand voice dan sapaan dari Project-ku: "Kak, boleh kurang lagi ga harganya kalau aku ambil 5 pcs sekaligus?" Maks 5 baris, ada emoji 1-2, ada CTA jelas.</a:t>
             </a:r>
           </a:p>
         </p:txBody>
@@ -6274,7 +6103,7 @@
                 </a:solidFill>
                 <a:latin typeface="Helvetica"/>
               </a:rPr>
-              <a:t>■  LATIHAN 3 — COCOKKAN KE SALAH SATU SKENARIO</a:t>
+              <a:t>■  LATIHAN 3 — PAKAI PROMPT SIAP PAKAI DARI FILE</a:t>
             </a:r>
           </a:p>
         </p:txBody>
@@ -6308,7 +6137,7 @@
                 </a:solidFill>
                 <a:latin typeface="Helvetica"/>
               </a:rPr>
-              <a:t>Begitu ada pembeli chat beneran — ini cocok Skenario 8 (negosiasi harga) dari 10 template yang sudah diupload:</a:t>
+              <a:t>Begitu ada pembeli chat beneran, buka cm-template-wa.txt, cocokkan pesannya ke salah satu dari 10 skenario. Contoh ini cocok Skenario 8 (negosiasi harga):</a:t>
             </a:r>
           </a:p>
         </p:txBody>
@@ -6321,7 +6150,7 @@
         </p:nvSpPr>
         <p:spPr>
           <a:xfrm>
-            <a:off x="713232" y="4097000"/>
+            <a:off x="713232" y="4161200"/>
             <a:ext cx="10607040" cy="320040"/>
           </a:xfrm>
           <a:prstGeom prst="rect">
@@ -6342,7 +6171,7 @@
                 </a:solidFill>
                 <a:latin typeface="Helvetica"/>
               </a:rPr>
-              <a:t>✅ Output: balasan hasil adaptasi dari Skenario 8 — bukan generate dari nol. Copy-paste ke WhatsApp, kirim. Ulangi 5x/minggu untuk situasi berbeda.</a:t>
+              <a:t>✅ Output: balasan sesuai skenario negosiasi harga &amp; brand voice Dapur Rara. Copy-paste ke WhatsApp, kirim. Ulangi tiap ada pembeli chat baru, prompt yang sama.</a:t>
             </a:r>
           </a:p>
         </p:txBody>

</xml_diff>

<commit_message>
Sync K3-M05-Komunikasi-Pelanggan.pptx from local (source of truth)
</commit_message>
<xml_diff>
--- a/Content-Marketing/M05-Komunikasi-Pelanggan/K3-M05-Komunikasi-Pelanggan.pptx
+++ b/Content-Marketing/M05-Komunikasi-Pelanggan/K3-M05-Komunikasi-Pelanggan.pptx
@@ -3304,7 +3304,7 @@
         </p:nvSpPr>
         <p:spPr>
           <a:xfrm>
-            <a:off x="905256" y="2389848"/>
+            <a:off x="905256" y="2366552"/>
             <a:ext cx="10332720" cy="594360"/>
           </a:xfrm>
           <a:prstGeom prst="rect">
@@ -3412,7 +3412,7 @@
         </p:nvSpPr>
         <p:spPr>
           <a:xfrm>
-            <a:off x="905256" y="3103080"/>
+            <a:off x="905256" y="3079784"/>
             <a:ext cx="10332720" cy="594360"/>
           </a:xfrm>
           <a:prstGeom prst="rect">
@@ -6131,13 +6131,310 @@
           <a:lstStyle/>
           <a:p>
             <a:r>
-              <a:rPr sz="1200">
+              <a:rPr sz="1200" dirty="0" err="1">
                 <a:solidFill>
                   <a:srgbClr val="23283A"/>
                 </a:solidFill>
                 <a:latin typeface="Helvetica"/>
               </a:rPr>
-              <a:t>Begitu ada pembeli chat beneran, buka cm-template-wa.txt, cocokkan pesannya ke salah satu dari 10 skenario. Contoh ini cocok Skenario 8 (negosiasi harga):</a:t>
+              <a:t>Begitu</a:t>
+            </a:r>
+            <a:r>
+              <a:rPr sz="1200" dirty="0">
+                <a:solidFill>
+                  <a:srgbClr val="23283A"/>
+                </a:solidFill>
+                <a:latin typeface="Helvetica"/>
+              </a:rPr>
+              <a:t> </a:t>
+            </a:r>
+            <a:r>
+              <a:rPr sz="1200" dirty="0" err="1">
+                <a:solidFill>
+                  <a:srgbClr val="23283A"/>
+                </a:solidFill>
+                <a:latin typeface="Helvetica"/>
+              </a:rPr>
+              <a:t>ada</a:t>
+            </a:r>
+            <a:r>
+              <a:rPr sz="1200" dirty="0">
+                <a:solidFill>
+                  <a:srgbClr val="23283A"/>
+                </a:solidFill>
+                <a:latin typeface="Helvetica"/>
+              </a:rPr>
+              <a:t> </a:t>
+            </a:r>
+            <a:r>
+              <a:rPr sz="1200" dirty="0" err="1">
+                <a:solidFill>
+                  <a:srgbClr val="23283A"/>
+                </a:solidFill>
+                <a:latin typeface="Helvetica"/>
+              </a:rPr>
+              <a:t>pembeli</a:t>
+            </a:r>
+            <a:r>
+              <a:rPr sz="1200" dirty="0">
+                <a:solidFill>
+                  <a:srgbClr val="23283A"/>
+                </a:solidFill>
+                <a:latin typeface="Helvetica"/>
+              </a:rPr>
+              <a:t> chat </a:t>
+            </a:r>
+            <a:r>
+              <a:rPr sz="1200" dirty="0" err="1">
+                <a:solidFill>
+                  <a:srgbClr val="23283A"/>
+                </a:solidFill>
+                <a:latin typeface="Helvetica"/>
+              </a:rPr>
+              <a:t>beneran</a:t>
+            </a:r>
+            <a:r>
+              <a:rPr sz="1200" dirty="0">
+                <a:solidFill>
+                  <a:srgbClr val="23283A"/>
+                </a:solidFill>
+                <a:latin typeface="Helvetica"/>
+              </a:rPr>
+              <a:t>, </a:t>
+            </a:r>
+            <a:r>
+              <a:rPr sz="1200" dirty="0" err="1">
+                <a:solidFill>
+                  <a:srgbClr val="23283A"/>
+                </a:solidFill>
+                <a:latin typeface="Helvetica"/>
+              </a:rPr>
+              <a:t>buka</a:t>
+            </a:r>
+            <a:r>
+              <a:rPr sz="1200" dirty="0">
+                <a:solidFill>
+                  <a:srgbClr val="23283A"/>
+                </a:solidFill>
+                <a:latin typeface="Helvetica"/>
+              </a:rPr>
+              <a:t> cm-template-wa.txt, </a:t>
+            </a:r>
+            <a:r>
+              <a:rPr sz="1200" dirty="0" err="1">
+                <a:solidFill>
+                  <a:srgbClr val="23283A"/>
+                </a:solidFill>
+                <a:latin typeface="Helvetica"/>
+              </a:rPr>
+              <a:t>cocokkan</a:t>
+            </a:r>
+            <a:r>
+              <a:rPr sz="1200" dirty="0">
+                <a:solidFill>
+                  <a:srgbClr val="23283A"/>
+                </a:solidFill>
+                <a:latin typeface="Helvetica"/>
+              </a:rPr>
+              <a:t> </a:t>
+            </a:r>
+            <a:r>
+              <a:rPr sz="1200" dirty="0" err="1">
+                <a:solidFill>
+                  <a:srgbClr val="23283A"/>
+                </a:solidFill>
+                <a:latin typeface="Helvetica"/>
+              </a:rPr>
+              <a:t>pesannya</a:t>
+            </a:r>
+            <a:r>
+              <a:rPr sz="1200" dirty="0">
+                <a:solidFill>
+                  <a:srgbClr val="23283A"/>
+                </a:solidFill>
+                <a:latin typeface="Helvetica"/>
+              </a:rPr>
+              <a:t> </a:t>
+            </a:r>
+            <a:r>
+              <a:rPr sz="1200" dirty="0" err="1">
+                <a:solidFill>
+                  <a:srgbClr val="23283A"/>
+                </a:solidFill>
+                <a:latin typeface="Helvetica"/>
+              </a:rPr>
+              <a:t>ke</a:t>
+            </a:r>
+            <a:r>
+              <a:rPr sz="1200" dirty="0">
+                <a:solidFill>
+                  <a:srgbClr val="23283A"/>
+                </a:solidFill>
+                <a:latin typeface="Helvetica"/>
+              </a:rPr>
+              <a:t> salah </a:t>
+            </a:r>
+            <a:r>
+              <a:rPr sz="1200" dirty="0" err="1">
+                <a:solidFill>
+                  <a:srgbClr val="23283A"/>
+                </a:solidFill>
+                <a:latin typeface="Helvetica"/>
+              </a:rPr>
+              <a:t>satu</a:t>
+            </a:r>
+            <a:r>
+              <a:rPr sz="1200" dirty="0">
+                <a:solidFill>
+                  <a:srgbClr val="23283A"/>
+                </a:solidFill>
+                <a:latin typeface="Helvetica"/>
+              </a:rPr>
+              <a:t> </a:t>
+            </a:r>
+            <a:r>
+              <a:rPr sz="1200" dirty="0" err="1">
+                <a:solidFill>
+                  <a:srgbClr val="23283A"/>
+                </a:solidFill>
+                <a:latin typeface="Helvetica"/>
+              </a:rPr>
+              <a:t>dari</a:t>
+            </a:r>
+            <a:r>
+              <a:rPr sz="1200" dirty="0">
+                <a:solidFill>
+                  <a:srgbClr val="23283A"/>
+                </a:solidFill>
+                <a:latin typeface="Helvetica"/>
+              </a:rPr>
+              <a:t> 10 </a:t>
+            </a:r>
+            <a:r>
+              <a:rPr sz="1200" dirty="0" err="1">
+                <a:solidFill>
+                  <a:srgbClr val="23283A"/>
+                </a:solidFill>
+                <a:latin typeface="Helvetica"/>
+              </a:rPr>
+              <a:t>skenario</a:t>
+            </a:r>
+            <a:r>
+              <a:rPr sz="1200" dirty="0">
+                <a:solidFill>
+                  <a:srgbClr val="23283A"/>
+                </a:solidFill>
+                <a:latin typeface="Helvetica"/>
+              </a:rPr>
+              <a:t>. </a:t>
+            </a:r>
+            <a:r>
+              <a:rPr sz="1200" dirty="0" err="1">
+                <a:solidFill>
+                  <a:srgbClr val="23283A"/>
+                </a:solidFill>
+                <a:latin typeface="Helvetica"/>
+              </a:rPr>
+              <a:t>Contoh</a:t>
+            </a:r>
+            <a:r>
+              <a:rPr sz="1200" dirty="0">
+                <a:solidFill>
+                  <a:srgbClr val="23283A"/>
+                </a:solidFill>
+                <a:latin typeface="Helvetica"/>
+              </a:rPr>
+              <a:t> </a:t>
+            </a:r>
+            <a:r>
+              <a:rPr sz="1200" dirty="0" err="1">
+                <a:solidFill>
+                  <a:srgbClr val="23283A"/>
+                </a:solidFill>
+                <a:latin typeface="Helvetica"/>
+              </a:rPr>
+              <a:t>ini</a:t>
+            </a:r>
+            <a:r>
+              <a:rPr sz="1200" dirty="0">
+                <a:solidFill>
+                  <a:srgbClr val="23283A"/>
+                </a:solidFill>
+                <a:latin typeface="Helvetica"/>
+              </a:rPr>
+              <a:t> </a:t>
+            </a:r>
+            <a:r>
+              <a:rPr sz="1200" dirty="0" err="1">
+                <a:solidFill>
+                  <a:srgbClr val="23283A"/>
+                </a:solidFill>
+                <a:latin typeface="Helvetica"/>
+              </a:rPr>
+              <a:t>cocok</a:t>
+            </a:r>
+            <a:r>
+              <a:rPr sz="1200" dirty="0">
+                <a:solidFill>
+                  <a:srgbClr val="23283A"/>
+                </a:solidFill>
+                <a:latin typeface="Helvetica"/>
+              </a:rPr>
+              <a:t> </a:t>
+            </a:r>
+            <a:r>
+              <a:rPr sz="1200" dirty="0" err="1">
+                <a:solidFill>
+                  <a:srgbClr val="23283A"/>
+                </a:solidFill>
+                <a:latin typeface="Helvetica"/>
+              </a:rPr>
+              <a:t>Skenario</a:t>
+            </a:r>
+            <a:r>
+              <a:rPr sz="1200" dirty="0">
+                <a:solidFill>
+                  <a:srgbClr val="23283A"/>
+                </a:solidFill>
+                <a:latin typeface="Helvetica"/>
+              </a:rPr>
+              <a:t> 8 (</a:t>
+            </a:r>
+            <a:r>
+              <a:rPr sz="1200" dirty="0" err="1">
+                <a:solidFill>
+                  <a:srgbClr val="23283A"/>
+                </a:solidFill>
+                <a:latin typeface="Helvetica"/>
+              </a:rPr>
+              <a:t>negosiasi</a:t>
+            </a:r>
+            <a:r>
+              <a:rPr sz="1200" dirty="0">
+                <a:solidFill>
+                  <a:srgbClr val="23283A"/>
+                </a:solidFill>
+                <a:latin typeface="Helvetica"/>
+              </a:rPr>
+              <a:t> </a:t>
+            </a:r>
+            <a:r>
+              <a:rPr sz="1200" dirty="0" err="1">
+                <a:solidFill>
+                  <a:srgbClr val="23283A"/>
+                </a:solidFill>
+                <a:latin typeface="Helvetica"/>
+              </a:rPr>
+              <a:t>harga</a:t>
+            </a:r>
+            <a:r>
+              <a:rPr sz="1200" dirty="0">
+                <a:solidFill>
+                  <a:srgbClr val="23283A"/>
+                </a:solidFill>
+                <a:latin typeface="Helvetica"/>
+              </a:rPr>
+              <a:t>):</a:t>
             </a:r>
           </a:p>
         </p:txBody>
@@ -6184,7 +6481,7 @@
         </p:nvSpPr>
         <p:spPr>
           <a:xfrm>
-            <a:off x="713232" y="2888000"/>
+            <a:off x="713232" y="2957888"/>
             <a:ext cx="10607040" cy="310000"/>
           </a:xfrm>
           <a:prstGeom prst="rect">
@@ -6199,13 +6496,157 @@
           <a:lstStyle/>
           <a:p>
             <a:r>
-              <a:rPr sz="1200" i="1">
+              <a:rPr sz="1200" i="1" dirty="0">
                 <a:solidFill>
                   <a:srgbClr val="23283A"/>
                 </a:solidFill>
                 <a:latin typeface="Helvetica"/>
               </a:rPr>
-              <a:t>"Kak, boleh kurang lagi ga harganya kalau aku ambil 5 pcs sekaligus?"</a:t>
+              <a:t>"Kak, </a:t>
+            </a:r>
+            <a:r>
+              <a:rPr sz="1200" i="1" dirty="0" err="1">
+                <a:solidFill>
+                  <a:srgbClr val="23283A"/>
+                </a:solidFill>
+                <a:latin typeface="Helvetica"/>
+              </a:rPr>
+              <a:t>boleh</a:t>
+            </a:r>
+            <a:r>
+              <a:rPr sz="1200" i="1" dirty="0">
+                <a:solidFill>
+                  <a:srgbClr val="23283A"/>
+                </a:solidFill>
+                <a:latin typeface="Helvetica"/>
+              </a:rPr>
+              <a:t> </a:t>
+            </a:r>
+            <a:r>
+              <a:rPr sz="1200" i="1" dirty="0" err="1">
+                <a:solidFill>
+                  <a:srgbClr val="23283A"/>
+                </a:solidFill>
+                <a:latin typeface="Helvetica"/>
+              </a:rPr>
+              <a:t>kurang</a:t>
+            </a:r>
+            <a:r>
+              <a:rPr sz="1200" i="1" dirty="0">
+                <a:solidFill>
+                  <a:srgbClr val="23283A"/>
+                </a:solidFill>
+                <a:latin typeface="Helvetica"/>
+              </a:rPr>
+              <a:t> </a:t>
+            </a:r>
+            <a:r>
+              <a:rPr sz="1200" i="1" dirty="0" err="1">
+                <a:solidFill>
+                  <a:srgbClr val="23283A"/>
+                </a:solidFill>
+                <a:latin typeface="Helvetica"/>
+              </a:rPr>
+              <a:t>lagi</a:t>
+            </a:r>
+            <a:r>
+              <a:rPr sz="1200" i="1" dirty="0">
+                <a:solidFill>
+                  <a:srgbClr val="23283A"/>
+                </a:solidFill>
+                <a:latin typeface="Helvetica"/>
+              </a:rPr>
+              <a:t> ga </a:t>
+            </a:r>
+            <a:r>
+              <a:rPr sz="1200" i="1" dirty="0" err="1">
+                <a:solidFill>
+                  <a:srgbClr val="23283A"/>
+                </a:solidFill>
+                <a:latin typeface="Helvetica"/>
+              </a:rPr>
+              <a:t>harganya</a:t>
+            </a:r>
+            <a:r>
+              <a:rPr sz="1200" i="1" dirty="0">
+                <a:solidFill>
+                  <a:srgbClr val="23283A"/>
+                </a:solidFill>
+                <a:latin typeface="Helvetica"/>
+              </a:rPr>
+              <a:t> </a:t>
+            </a:r>
+            <a:r>
+              <a:rPr sz="1200" i="1" dirty="0" err="1">
+                <a:solidFill>
+                  <a:srgbClr val="23283A"/>
+                </a:solidFill>
+                <a:latin typeface="Helvetica"/>
+              </a:rPr>
+              <a:t>kalau</a:t>
+            </a:r>
+            <a:r>
+              <a:rPr sz="1200" i="1" dirty="0">
+                <a:solidFill>
+                  <a:srgbClr val="23283A"/>
+                </a:solidFill>
+                <a:latin typeface="Helvetica"/>
+              </a:rPr>
+              <a:t> </a:t>
+            </a:r>
+            <a:r>
+              <a:rPr sz="1200" i="1" dirty="0" err="1">
+                <a:solidFill>
+                  <a:srgbClr val="23283A"/>
+                </a:solidFill>
+                <a:latin typeface="Helvetica"/>
+              </a:rPr>
+              <a:t>aku</a:t>
+            </a:r>
+            <a:r>
+              <a:rPr sz="1200" i="1" dirty="0">
+                <a:solidFill>
+                  <a:srgbClr val="23283A"/>
+                </a:solidFill>
+                <a:latin typeface="Helvetica"/>
+              </a:rPr>
+              <a:t> </a:t>
+            </a:r>
+            <a:r>
+              <a:rPr sz="1200" i="1" dirty="0" err="1">
+                <a:solidFill>
+                  <a:srgbClr val="23283A"/>
+                </a:solidFill>
+                <a:latin typeface="Helvetica"/>
+              </a:rPr>
+              <a:t>ambil</a:t>
+            </a:r>
+            <a:r>
+              <a:rPr sz="1200" i="1" dirty="0">
+                <a:solidFill>
+                  <a:srgbClr val="23283A"/>
+                </a:solidFill>
+                <a:latin typeface="Helvetica"/>
+              </a:rPr>
+              <a:t> 5 pcs </a:t>
+            </a:r>
+            <a:r>
+              <a:rPr sz="1200" i="1" dirty="0" err="1">
+                <a:solidFill>
+                  <a:srgbClr val="23283A"/>
+                </a:solidFill>
+                <a:latin typeface="Helvetica"/>
+              </a:rPr>
+              <a:t>sekaligus</a:t>
+            </a:r>
+            <a:r>
+              <a:rPr sz="1200" i="1" dirty="0">
+                <a:solidFill>
+                  <a:srgbClr val="23283A"/>
+                </a:solidFill>
+                <a:latin typeface="Helvetica"/>
+              </a:rPr>
+              <a:t>?"</a:t>
             </a:r>
           </a:p>
         </p:txBody>

</xml_diff>